<commit_message>
Chemistry U2 slide decks: audit fix round complete (superscript markup, teacher notes, content fixes)
Co-Authored-By: Claude Sonnet 5.5 <noreply@anthropic.com>
Claude-Session: https://claude.ai/code/session_01CAqidLLu6PiYNMcZx5qMsE
</commit_message>
<xml_diff>
--- a/deliverables/chem-u02/SHULL_CHEM_Slides_U02_S02.3.pptx
+++ b/deliverables/chem-u02/SHULL_CHEM_Slides_U02_S02.3.pptx
@@ -25,9 +25,11 @@
     <p:sldId id="273" r:id="rId19"/>
     <p:sldId id="274" r:id="rId20"/>
     <p:sldId id="275" r:id="rId21"/>
+    <p:sldId id="276" r:id="rId22"/>
+    <p:sldId id="277" r:id="rId23"/>
   </p:sldIdLst>
   <p:notesMasterIdLst>
-    <p:notesMasterId r:id="rId22"/>
+    <p:notesMasterId r:id="rId24"/>
   </p:notesMasterIdLst>
   <p:sldSz cx="12192000" cy="6858000"/>
   <p:notesSz cx="6858000" cy="12192000"/>
@@ -521,7 +523,7 @@
           <a:p>
             <a:r>
               <a:rPr lang="en-US" dirty="0"/>
-              <a:t/>
+              <a:t>PROVISIONAL scope: required through Kr (Z = 36), per the content brief; Matt to confirm. Period 5 and beyond (Mo, Ag, Au) are not taught on these slides and are not checked in the build script. PROVISIONAL notation: configurations are written in filling order, e.g. [Ar] 4s^2 3d^6, not energy order. Image prompt (section slot): a long row of numbered wooden mail slots in a dim hallway, a few holding envelopes.</a:t>
             </a:r>
             <a:endParaRPr lang="en-US" dirty="0"/>
           </a:p>
@@ -609,7 +611,7 @@
           <a:p>
             <a:r>
               <a:rPr lang="en-US" dirty="0"/>
-              <a:t/>
+              <a:t>Oxygen: 1s^2 2s^2 2p^4, 2 + 2 + 4 = 8. The 2p boxes hold one pair and two singles, so 2 unpaired.</a:t>
             </a:r>
             <a:endParaRPr lang="en-US" dirty="0"/>
           </a:p>
@@ -697,7 +699,7 @@
           <a:p>
             <a:r>
               <a:rPr lang="en-US" dirty="0"/>
-              <a:t/>
+              <a:t>N: 1s^2 2s^2 2p^3, 3 unpaired. Cl: 1s^2 2s^2 2p^6 3s^2 3p^5, 1 unpaired. Ca: 1s^2 2s^2 2p^6 3s^2 3p^6 4s^2, 0 unpaired. 3d stays empty until scandium. Image prompt (aside slot): period 3 of a periodic table wall chart, lit from the side.</a:t>
             </a:r>
             <a:endParaRPr lang="en-US" dirty="0"/>
           </a:p>
@@ -785,7 +787,7 @@
           <a:p>
             <a:r>
               <a:rPr lang="en-US" dirty="0"/>
-              <a:t/>
+              <a:t>COMMON ERROR (brief): using the noble gas of the same period, or the element's own. Cl is period 3, so the core is [Ne], not [Ar]; the core is the previous period's noble gas. Shorthand: [Ne] 3s^2 3p^5, which equals the longhand 1s^2 2s^2 2p^6 3s^2 3p^5. Image prompt (concept slot): a neon sign tube glowing orange-red in a dark window.</a:t>
             </a:r>
             <a:endParaRPr lang="en-US" dirty="0"/>
           </a:p>
@@ -873,7 +875,7 @@
           <a:p>
             <a:r>
               <a:rPr lang="en-US" dirty="0"/>
-              <a:t/>
+              <a:t>Students copy the setup, then work it. Answer on the next slide. Fe, Z = 26. Fill 4s before 3d, and we write 4s ahead of 3d (filling-order notation, PROVISIONAL convention). Image prompt (aside slot): a rusted iron nail on a white bench.</a:t>
             </a:r>
             <a:endParaRPr lang="en-US" dirty="0"/>
           </a:p>
@@ -961,7 +963,7 @@
           <a:p>
             <a:r>
               <a:rPr lang="en-US" dirty="0"/>
-              <a:t/>
+              <a:t>Fe: [Ar] 4s^2 3d^6, 18 + 2 + 6 = 26. The 3d boxes hold one pair and four singles, so 4 unpaired. Longhand: 1s^2 2s^2 2p^6 3s^2 3p^6 4s^2 3d^6.</a:t>
             </a:r>
             <a:endParaRPr lang="en-US" dirty="0"/>
           </a:p>
@@ -1049,7 +1051,7 @@
           <a:p>
             <a:r>
               <a:rPr lang="en-US" dirty="0"/>
-              <a:t/>
+              <a:t>Only Cr and Cu are taught as exceptions. Cr: [Ar] 4s^1 3d^5. Cu: [Ar] 4s^1 3d^10. These are measured ground states, not textbook errors. PROVISIONAL label: 'half-full or full d is extra stable' is a simplification, not a predictor; it does not explain every exception. Mo, Ag and Au (one period down) are not taught and unchecked here; outside Cr and Cu, say 'look it up'.</a:t>
             </a:r>
             <a:endParaRPr lang="en-US" dirty="0"/>
           </a:p>
@@ -1137,7 +1139,7 @@
           <a:p>
             <a:r>
               <a:rPr lang="en-US" dirty="0"/>
-              <a:t/>
+              <a:t>Run the four checks in order: count, caps and order, Hund and Pauli, then core / Cr / Cu. Stop at the first failure. Image prompt (band slot): a teacher's red pen resting on a page of student work.</a:t>
             </a:r>
             <a:endParaRPr lang="en-US" dirty="0"/>
           </a:p>
@@ -1225,7 +1227,7 @@
           <a:p>
             <a:r>
               <a:rPr lang="en-US" dirty="0"/>
-              <a:t/>
+              <a:t>Answers on the next slide. Each was written as a ground state. (a) O: 1s^2 2s^2 2p^6 is 10 electrons, O has 8. (b) K: [Ar] 3d^1 puts 3d before 4s. (c) Ca: [Ne] 4s^2 is 12 electrons, wrong core. (d) Cr: [Ar] 4s^2 3d^4 obeys the rules but is not the real ground state. Image prompt (aside slot): a page of student work with a few lines circled in red pen.</a:t>
             </a:r>
             <a:endParaRPr lang="en-US" dirty="0"/>
           </a:p>
@@ -1313,7 +1315,7 @@
           <a:p>
             <a:r>
               <a:rPr lang="en-US" dirty="0"/>
-              <a:t/>
+              <a:t>Corrected: (a) O 1s^2 2s^2 2p^4. (b) K [Ar] 4s^1. (c) Ca [Ar] 4s^2. (d) Cr [Ar] 4s^1 3d^5. Teach 'rules-consistent' versus 'observed': (d) passes every rule on paper and is still not the real atom. Image prompt (data slot): a pencil resting on a page of crossed-out electron counts.</a:t>
             </a:r>
             <a:endParaRPr lang="en-US" dirty="0"/>
           </a:p>
@@ -1401,7 +1403,7 @@
           <a:p>
             <a:r>
               <a:rPr lang="en-US" dirty="0"/>
-              <a:t/>
+              <a:t>Orbital-diagram errors (brief items c, d), labelled (e) and (f) here. (e) N 2p drawn up, down, up: three singles but not parallel. (f) Ne 2s drawn up, up in one box: Pauli. Ask which rule each breaks and what the fix looks like.</a:t>
             </a:r>
             <a:endParaRPr lang="en-US" dirty="0"/>
           </a:p>
@@ -1489,7 +1491,7 @@
           <a:p>
             <a:r>
               <a:rPr lang="en-US" dirty="0"/>
-              <a:t/>
+              <a:t>Hook. Ask: do all 8 electrons have the same energy? Let them guess; the slides answer it (no). Z = 8 comes from the periodic table. Image prompt (concept slot): an apartment building at dusk with a few lit windows on different floors.</a:t>
             </a:r>
             <a:endParaRPr lang="en-US" dirty="0"/>
           </a:p>
@@ -1577,7 +1579,7 @@
           <a:p>
             <a:r>
               <a:rPr lang="en-US" dirty="0"/>
-              <a:t/>
+              <a:t>(e) Hund: unpaired electrons need parallel spins. Correct N 2p: up, up, up. (f) Pauli: two electrons in one orbital must have opposite spins. Correct Ne 2s: up, down. The brief's other Hund error (pair, single, empty) is the WRONG row on the Hund slide earlier in this deck.</a:t>
             </a:r>
             <a:endParaRPr lang="en-US" dirty="0"/>
           </a:p>
@@ -1601,6 +1603,182 @@
             <a:fld id="{F7021451-1387-4CA6-816F-3879F97B5CBC}" type="slidenum">
               <a:rPr lang="en-US"/>
               <a:t>20</a:t>
+            </a:fld>
+            <a:endParaRPr lang="en-US"/>
+          </a:p>
+        </p:txBody>
+      </p:sp>
+    </p:spTree>
+    <p:extLst>
+      <p:ext uri="{BB962C8B-B14F-4D97-AF65-F5344CB8AC3E}">
+        <p14:creationId xmlns:p14="http://schemas.microsoft.com/office/powerpoint/2010/main" val="1024086991"/>
+      </p:ext>
+    </p:extLst>
+  </p:cSld>
+  <p:clrMapOvr>
+    <a:masterClrMapping/>
+  </p:clrMapOvr>
+</p:notes>
+</file>
+
+<file path=ppt/notesSlides/notesSlide21.xml><?xml version="1.0" encoding="utf-8"?>
+<p:notes xmlns:a="http://schemas.openxmlformats.org/drawingml/2006/main" xmlns:r="http://schemas.openxmlformats.org/officeDocument/2006/relationships" xmlns:p="http://schemas.openxmlformats.org/presentationml/2006/main">
+  <p:cSld>
+    <p:spTree>
+      <p:nvGrpSpPr>
+        <p:cNvPr id="1" name=""/>
+        <p:cNvGrpSpPr/>
+        <p:nvPr/>
+      </p:nvGrpSpPr>
+      <p:grpSpPr>
+        <a:xfrm>
+          <a:off x="0" y="0"/>
+          <a:ext cx="0" cy="0"/>
+          <a:chOff x="0" y="0"/>
+          <a:chExt cx="0" cy="0"/>
+        </a:xfrm>
+      </p:grpSpPr>
+      <p:sp>
+        <p:nvSpPr>
+          <p:cNvPr id="2" name="Slide Image Placeholder 1"/>
+          <p:cNvSpPr>
+            <a:spLocks noGrp="1" noRot="1" noChangeAspect="1"/>
+          </p:cNvSpPr>
+          <p:nvPr>
+            <p:ph type="sldImg"/>
+          </p:nvPr>
+        </p:nvSpPr>
+        <p:spPr/>
+      </p:sp>
+      <p:sp>
+        <p:nvSpPr>
+          <p:cNvPr id="3" name="Notes Placeholder 2"/>
+          <p:cNvSpPr>
+            <a:spLocks noGrp="1"/>
+          </p:cNvSpPr>
+          <p:nvPr>
+            <p:ph type="body" idx="1"/>
+          </p:nvPr>
+        </p:nvSpPr>
+        <p:spPr/>
+        <p:txBody>
+          <a:bodyPr/>
+          <a:lstStyle/>
+          <a:p>
+            <a:r>
+              <a:rPr lang="en-US" dirty="0"/>
+              <a:t>Answers (re-derived). P, Z = 15: 1s^2 2s^2 2p^6 3s^2 3p^3, 2+2+6+2+3 = 15, 3 unpaired. S, Z = 16: [Ne] 3s^2 3p^4, 10+2+4 = 16; 3p boxes: one pair and two singles, 2 unpaired. Cu, Z = 29: [Ar] 4s^1 3d^10, 18+1+10 = 29; exception, a filled 3d is extra stable (simplification, PROVISIONAL label). Image prompt (aside slot): a pencil and a blank sheet of lined paper on a lab bench.</a:t>
+            </a:r>
+            <a:endParaRPr lang="en-US" dirty="0"/>
+          </a:p>
+        </p:txBody>
+      </p:sp>
+      <p:sp>
+        <p:nvSpPr>
+          <p:cNvPr id="4" name="Slide Number Placeholder 3"/>
+          <p:cNvSpPr>
+            <a:spLocks noGrp="1"/>
+          </p:cNvSpPr>
+          <p:nvPr>
+            <p:ph type="sldNum" sz="quarter" idx="10"/>
+          </p:nvPr>
+        </p:nvSpPr>
+        <p:spPr/>
+        <p:txBody>
+          <a:bodyPr/>
+          <a:lstStyle/>
+          <a:p>
+            <a:fld id="{F7021451-1387-4CA6-816F-3879F97B5CBC}" type="slidenum">
+              <a:rPr lang="en-US"/>
+              <a:t>21</a:t>
+            </a:fld>
+            <a:endParaRPr lang="en-US"/>
+          </a:p>
+        </p:txBody>
+      </p:sp>
+    </p:spTree>
+    <p:extLst>
+      <p:ext uri="{BB962C8B-B14F-4D97-AF65-F5344CB8AC3E}">
+        <p14:creationId xmlns:p14="http://schemas.microsoft.com/office/powerpoint/2010/main" val="1024086991"/>
+      </p:ext>
+    </p:extLst>
+  </p:cSld>
+  <p:clrMapOvr>
+    <a:masterClrMapping/>
+  </p:clrMapOvr>
+</p:notes>
+</file>
+
+<file path=ppt/notesSlides/notesSlide22.xml><?xml version="1.0" encoding="utf-8"?>
+<p:notes xmlns:a="http://schemas.openxmlformats.org/drawingml/2006/main" xmlns:r="http://schemas.openxmlformats.org/officeDocument/2006/relationships" xmlns:p="http://schemas.openxmlformats.org/presentationml/2006/main">
+  <p:cSld>
+    <p:spTree>
+      <p:nvGrpSpPr>
+        <p:cNvPr id="1" name=""/>
+        <p:cNvGrpSpPr/>
+        <p:nvPr/>
+      </p:nvGrpSpPr>
+      <p:grpSpPr>
+        <a:xfrm>
+          <a:off x="0" y="0"/>
+          <a:ext cx="0" cy="0"/>
+          <a:chOff x="0" y="0"/>
+          <a:chExt cx="0" cy="0"/>
+        </a:xfrm>
+      </p:grpSpPr>
+      <p:sp>
+        <p:nvSpPr>
+          <p:cNvPr id="2" name="Slide Image Placeholder 1"/>
+          <p:cNvSpPr>
+            <a:spLocks noGrp="1" noRot="1" noChangeAspect="1"/>
+          </p:cNvSpPr>
+          <p:nvPr>
+            <p:ph type="sldImg"/>
+          </p:nvPr>
+        </p:nvSpPr>
+        <p:spPr/>
+      </p:sp>
+      <p:sp>
+        <p:nvSpPr>
+          <p:cNvPr id="3" name="Notes Placeholder 2"/>
+          <p:cNvSpPr>
+            <a:spLocks noGrp="1"/>
+          </p:cNvSpPr>
+          <p:nvPr>
+            <p:ph type="body" idx="1"/>
+          </p:nvPr>
+        </p:nvSpPr>
+        <p:spPr/>
+        <p:txBody>
+          <a:bodyPr/>
+          <a:lstStyle/>
+          <a:p>
+            <a:r>
+              <a:rPr lang="en-US" dirty="0"/>
+              <a:t>Looking ahead: next is valence electrons and ion configurations (S2.4). Image prompt (divider slot): an empty lab stool at a long bench, window light across the floor.</a:t>
+            </a:r>
+            <a:endParaRPr lang="en-US" dirty="0"/>
+          </a:p>
+        </p:txBody>
+      </p:sp>
+      <p:sp>
+        <p:nvSpPr>
+          <p:cNvPr id="4" name="Slide Number Placeholder 3"/>
+          <p:cNvSpPr>
+            <a:spLocks noGrp="1"/>
+          </p:cNvSpPr>
+          <p:nvPr>
+            <p:ph type="sldNum" sz="quarter" idx="10"/>
+          </p:nvPr>
+        </p:nvSpPr>
+        <p:spPr/>
+        <p:txBody>
+          <a:bodyPr/>
+          <a:lstStyle/>
+          <a:p>
+            <a:fld id="{F7021451-1387-4CA6-816F-3879F97B5CBC}" type="slidenum">
+              <a:rPr lang="en-US"/>
+              <a:t>22</a:t>
             </a:fld>
             <a:endParaRPr lang="en-US"/>
           </a:p>
@@ -1665,7 +1843,7 @@
           <a:p>
             <a:r>
               <a:rPr lang="en-US" dirty="0"/>
-              <a:t/>
+              <a:t>Say it aloud: two-p-four. Level 2, p sublevel, 4 electrons. Ground state = lowest-energy arrangement; every configuration today is a ground state unless the slide says otherwise. Image prompt (aside slot): a printed periodic table with oxygen's cell circled in pencil.</a:t>
             </a:r>
             <a:endParaRPr lang="en-US" dirty="0"/>
           </a:p>
@@ -1753,7 +1931,7 @@
           <a:p>
             <a:r>
               <a:rPr lang="en-US" dirty="0"/>
-              <a:t/>
+              <a:t>Walk each arrow top right to bottom left. We need the order through 5p: 1s 2s 2p 3s 3p 4s 3d 4p 5s 4d 5p. Say it as: 4s fills before 3d in neutral K and Ca. Do not say 4s is always lower than 3d (once 3d holds electrons it sits lower; that is S2.4, ions).</a:t>
             </a:r>
             <a:endParaRPr lang="en-US" dirty="0"/>
           </a:p>
@@ -1841,7 +2019,7 @@
           <a:p>
             <a:r>
               <a:rPr lang="en-US" dirty="0"/>
-              <a:t/>
+              <a:t>Spin up and down are labels, not literal rotation. Common mix-up: two per orbital, not two per sublevel (a p sublevel has 3 orbitals and holds 6).</a:t>
             </a:r>
             <a:endParaRPr lang="en-US" dirty="0"/>
           </a:p>
@@ -1929,7 +2107,7 @@
           <a:p>
             <a:r>
               <a:rPr lang="en-US" dirty="0"/>
-              <a:t/>
+              <a:t>Figure: N in 2p. Correct = three singles, spins parallel. Wrong = one pair, one single, one empty box. Equal-energy orbitals are called degenerate. Electrons spread out first because sharing an orbital costs repulsion.</a:t>
             </a:r>
             <a:endParaRPr lang="en-US" dirty="0"/>
           </a:p>
@@ -2017,7 +2195,7 @@
           <a:p>
             <a:r>
               <a:rPr lang="en-US" dirty="0"/>
-              <a:t/>
+              <a:t>N has 7 electrons so 7 arrows: 2 + 2 + 3. Convention: draw the up arrow first in every box, and the label's raised number counts the arrows.</a:t>
             </a:r>
             <a:endParaRPr lang="en-US" dirty="0"/>
           </a:p>
@@ -2105,7 +2283,7 @@
           <a:p>
             <a:r>
               <a:rPr lang="en-US" dirty="0"/>
-              <a:t/>
+              <a:t>Four steps, every element. Caps: s 2, p 6, d 10, f 14. Always check that the sum equals Z. Image prompt (band slot): a periodic table wall chart photographed at a shallow angle.</a:t>
             </a:r>
             <a:endParaRPr lang="en-US" dirty="0"/>
           </a:p>
@@ -2193,7 +2371,7 @@
           <a:p>
             <a:r>
               <a:rPr lang="en-US" dirty="0"/>
-              <a:t/>
+              <a:t>Students copy the setup; the work area stays empty on purpose and is filled live on the board. Answer on the next slide: 1s^2 2s^2 2p^4, 2 unpaired. Image prompt (aside slot): a small cylinder of oxygen gas with a regulator, on a lab cart.</a:t>
             </a:r>
             <a:endParaRPr lang="en-US" dirty="0"/>
           </a:p>
@@ -13214,7 +13392,7 @@
       </p:sp>
       <p:sp>
         <p:nvSpPr>
-          <p:cNvPr id="6" name="Text 3"/>
+          <p:cNvPr id="7" name="Text 3"/>
           <p:cNvSpPr txBox="1"/>
           <p:nvPr>
             <p:ph idx="103" hasCustomPrompt="1"/>
@@ -13507,7 +13685,77 @@
                 <a:ea typeface="Trade Gothic Next" pitchFamily="34" charset="-122"/>
                 <a:cs typeface="Trade Gothic Next" pitchFamily="34" charset="-120"/>
               </a:rPr>
-              <a:t>1s² 2s² 2p⁴</a:t>
+              <a:t>1s</a:t>
+            </a:r>
+            <a:pPr indent="0" marL="0">
+              <a:buNone/>
+            </a:pPr>
+            <a:r>
+              <a:rPr lang="en-US" sz="1900" baseline="30000" dirty="0">
+                <a:solidFill>
+                  <a:srgbClr val="14161B"/>
+                </a:solidFill>
+                <a:latin typeface="Trade Gothic Next" pitchFamily="34" charset="0"/>
+                <a:ea typeface="Trade Gothic Next" pitchFamily="34" charset="-122"/>
+                <a:cs typeface="Trade Gothic Next" pitchFamily="34" charset="-120"/>
+              </a:rPr>
+              <a:t>2</a:t>
+            </a:r>
+            <a:pPr indent="0" marL="0">
+              <a:buNone/>
+            </a:pPr>
+            <a:r>
+              <a:rPr lang="en-US" sz="1900" dirty="0">
+                <a:solidFill>
+                  <a:srgbClr val="14161B"/>
+                </a:solidFill>
+                <a:latin typeface="Trade Gothic Next" pitchFamily="34" charset="0"/>
+                <a:ea typeface="Trade Gothic Next" pitchFamily="34" charset="-122"/>
+                <a:cs typeface="Trade Gothic Next" pitchFamily="34" charset="-120"/>
+              </a:rPr>
+              <a:t> 2s</a:t>
+            </a:r>
+            <a:pPr indent="0" marL="0">
+              <a:buNone/>
+            </a:pPr>
+            <a:r>
+              <a:rPr lang="en-US" sz="1900" baseline="30000" dirty="0">
+                <a:solidFill>
+                  <a:srgbClr val="14161B"/>
+                </a:solidFill>
+                <a:latin typeface="Trade Gothic Next" pitchFamily="34" charset="0"/>
+                <a:ea typeface="Trade Gothic Next" pitchFamily="34" charset="-122"/>
+                <a:cs typeface="Trade Gothic Next" pitchFamily="34" charset="-120"/>
+              </a:rPr>
+              <a:t>2</a:t>
+            </a:r>
+            <a:pPr indent="0" marL="0">
+              <a:buNone/>
+            </a:pPr>
+            <a:r>
+              <a:rPr lang="en-US" sz="1900" dirty="0">
+                <a:solidFill>
+                  <a:srgbClr val="14161B"/>
+                </a:solidFill>
+                <a:latin typeface="Trade Gothic Next" pitchFamily="34" charset="0"/>
+                <a:ea typeface="Trade Gothic Next" pitchFamily="34" charset="-122"/>
+                <a:cs typeface="Trade Gothic Next" pitchFamily="34" charset="-120"/>
+              </a:rPr>
+              <a:t> 2p</a:t>
+            </a:r>
+            <a:pPr indent="0" marL="0">
+              <a:buNone/>
+            </a:pPr>
+            <a:r>
+              <a:rPr lang="en-US" sz="1900" baseline="30000" dirty="0">
+                <a:solidFill>
+                  <a:srgbClr val="14161B"/>
+                </a:solidFill>
+                <a:latin typeface="Trade Gothic Next" pitchFamily="34" charset="0"/>
+                <a:ea typeface="Trade Gothic Next" pitchFamily="34" charset="-122"/>
+                <a:cs typeface="Trade Gothic Next" pitchFamily="34" charset="-120"/>
+              </a:rPr>
+              <a:t>4</a:t>
             </a:r>
             <a:endParaRPr lang="en-US" sz="1900" dirty="0"/>
           </a:p>
@@ -13582,7 +13830,91 @@
                 <a:ea typeface="Trade Gothic Next" pitchFamily="34" charset="-122"/>
                 <a:cs typeface="Trade Gothic Next" pitchFamily="34" charset="-120"/>
               </a:rPr>
-              <a:t>Oxygen is 1s² 2s² 2p⁴, with 2 unpaired electrons.</a:t>
+              <a:t>Oxygen is 1s</a:t>
+            </a:r>
+            <a:pPr indent="0" marL="0">
+              <a:buNone/>
+            </a:pPr>
+            <a:r>
+              <a:rPr lang="en-US" sz="1600" b="1" baseline="30000" dirty="0">
+                <a:solidFill>
+                  <a:srgbClr val="EDF0E5"/>
+                </a:solidFill>
+                <a:latin typeface="Trade Gothic Next" pitchFamily="34" charset="0"/>
+                <a:ea typeface="Trade Gothic Next" pitchFamily="34" charset="-122"/>
+                <a:cs typeface="Trade Gothic Next" pitchFamily="34" charset="-120"/>
+              </a:rPr>
+              <a:t>2</a:t>
+            </a:r>
+            <a:pPr indent="0" marL="0">
+              <a:buNone/>
+            </a:pPr>
+            <a:r>
+              <a:rPr lang="en-US" sz="1600" b="1" dirty="0">
+                <a:solidFill>
+                  <a:srgbClr val="EDF0E5"/>
+                </a:solidFill>
+                <a:latin typeface="Trade Gothic Next" pitchFamily="34" charset="0"/>
+                <a:ea typeface="Trade Gothic Next" pitchFamily="34" charset="-122"/>
+                <a:cs typeface="Trade Gothic Next" pitchFamily="34" charset="-120"/>
+              </a:rPr>
+              <a:t> 2s</a:t>
+            </a:r>
+            <a:pPr indent="0" marL="0">
+              <a:buNone/>
+            </a:pPr>
+            <a:r>
+              <a:rPr lang="en-US" sz="1600" b="1" baseline="30000" dirty="0">
+                <a:solidFill>
+                  <a:srgbClr val="EDF0E5"/>
+                </a:solidFill>
+                <a:latin typeface="Trade Gothic Next" pitchFamily="34" charset="0"/>
+                <a:ea typeface="Trade Gothic Next" pitchFamily="34" charset="-122"/>
+                <a:cs typeface="Trade Gothic Next" pitchFamily="34" charset="-120"/>
+              </a:rPr>
+              <a:t>2</a:t>
+            </a:r>
+            <a:pPr indent="0" marL="0">
+              <a:buNone/>
+            </a:pPr>
+            <a:r>
+              <a:rPr lang="en-US" sz="1600" b="1" dirty="0">
+                <a:solidFill>
+                  <a:srgbClr val="EDF0E5"/>
+                </a:solidFill>
+                <a:latin typeface="Trade Gothic Next" pitchFamily="34" charset="0"/>
+                <a:ea typeface="Trade Gothic Next" pitchFamily="34" charset="-122"/>
+                <a:cs typeface="Trade Gothic Next" pitchFamily="34" charset="-120"/>
+              </a:rPr>
+              <a:t> 2p</a:t>
+            </a:r>
+            <a:pPr indent="0" marL="0">
+              <a:buNone/>
+            </a:pPr>
+            <a:r>
+              <a:rPr lang="en-US" sz="1600" b="1" baseline="30000" dirty="0">
+                <a:solidFill>
+                  <a:srgbClr val="EDF0E5"/>
+                </a:solidFill>
+                <a:latin typeface="Trade Gothic Next" pitchFamily="34" charset="0"/>
+                <a:ea typeface="Trade Gothic Next" pitchFamily="34" charset="-122"/>
+                <a:cs typeface="Trade Gothic Next" pitchFamily="34" charset="-120"/>
+              </a:rPr>
+              <a:t>4</a:t>
+            </a:r>
+            <a:pPr indent="0" marL="0">
+              <a:buNone/>
+            </a:pPr>
+            <a:r>
+              <a:rPr lang="en-US" sz="1600" b="1" dirty="0">
+                <a:solidFill>
+                  <a:srgbClr val="EDF0E5"/>
+                </a:solidFill>
+                <a:latin typeface="Trade Gothic Next" pitchFamily="34" charset="0"/>
+                <a:ea typeface="Trade Gothic Next" pitchFamily="34" charset="-122"/>
+                <a:cs typeface="Trade Gothic Next" pitchFamily="34" charset="-120"/>
+              </a:rPr>
+              <a:t>, with 2 unpaired electrons.</a:t>
             </a:r>
             <a:endParaRPr lang="en-US" sz="1600" dirty="0"/>
           </a:p>
@@ -13672,7 +14004,7 @@
       </p:sp>
       <p:sp>
         <p:nvSpPr>
-          <p:cNvPr id="11" name="Text 4"/>
+          <p:cNvPr id="12" name="Text 4"/>
           <p:cNvSpPr txBox="1"/>
           <p:nvPr>
             <p:ph idx="107" hasCustomPrompt="1"/>
@@ -13801,7 +14133,35 @@
                 <a:ea typeface="Trade Gothic Next" pitchFamily="34" charset="-122"/>
                 <a:cs typeface="Trade Gothic Next" pitchFamily="34" charset="-120"/>
               </a:rPr>
-              <a:t>Calcium stops at 4s². The 3d sublevel stays empty until scandium.</a:t>
+              <a:t>Calcium stops at 4s</a:t>
+            </a:r>
+            <a:pPr indent="0" marL="0">
+              <a:buNone/>
+            </a:pPr>
+            <a:r>
+              <a:rPr lang="en-US" sz="1700" baseline="30000" dirty="0">
+                <a:solidFill>
+                  <a:srgbClr val="2E3338"/>
+                </a:solidFill>
+                <a:latin typeface="Trade Gothic Next" pitchFamily="34" charset="0"/>
+                <a:ea typeface="Trade Gothic Next" pitchFamily="34" charset="-122"/>
+                <a:cs typeface="Trade Gothic Next" pitchFamily="34" charset="-120"/>
+              </a:rPr>
+              <a:t>2</a:t>
+            </a:r>
+            <a:pPr indent="0" marL="0">
+              <a:buNone/>
+            </a:pPr>
+            <a:r>
+              <a:rPr lang="en-US" sz="1700" dirty="0">
+                <a:solidFill>
+                  <a:srgbClr val="2E3338"/>
+                </a:solidFill>
+                <a:latin typeface="Trade Gothic Next" pitchFamily="34" charset="0"/>
+                <a:ea typeface="Trade Gothic Next" pitchFamily="34" charset="-122"/>
+                <a:cs typeface="Trade Gothic Next" pitchFamily="34" charset="-120"/>
+              </a:rPr>
+              <a:t>. The 3d sublevel stays empty until scandium.</a:t>
             </a:r>
             <a:endParaRPr lang="en-US" sz="1700" dirty="0"/>
           </a:p>
@@ -13883,14 +14243,78 @@
                 <a:ea typeface="Trade Gothic Next" pitchFamily="34" charset="-122"/>
                 <a:cs typeface="Trade Gothic Next" pitchFamily="34" charset="-120"/>
               </a:rPr>
-              <a:t>1s² 2s² 2p³</a:t>
-            </a:r>
-            <a:endParaRPr lang="en-US" sz="1600" dirty="0"/>
-          </a:p>
-          <a:p>
-            <a:pPr indent="0" marL="0">
-              <a:buNone/>
-            </a:pPr>
+              <a:t>1s</a:t>
+            </a:r>
+            <a:pPr indent="0" marL="0">
+              <a:buNone/>
+            </a:pPr>
+            <a:r>
+              <a:rPr lang="en-US" sz="1600" baseline="30000" dirty="0">
+                <a:solidFill>
+                  <a:srgbClr val="14161B"/>
+                </a:solidFill>
+                <a:latin typeface="Trade Gothic Next" pitchFamily="34" charset="0"/>
+                <a:ea typeface="Trade Gothic Next" pitchFamily="34" charset="-122"/>
+                <a:cs typeface="Trade Gothic Next" pitchFamily="34" charset="-120"/>
+              </a:rPr>
+              <a:t>2</a:t>
+            </a:r>
+            <a:pPr indent="0" marL="0">
+              <a:buNone/>
+            </a:pPr>
+            <a:r>
+              <a:rPr lang="en-US" sz="1600" dirty="0">
+                <a:solidFill>
+                  <a:srgbClr val="14161B"/>
+                </a:solidFill>
+                <a:latin typeface="Trade Gothic Next" pitchFamily="34" charset="0"/>
+                <a:ea typeface="Trade Gothic Next" pitchFamily="34" charset="-122"/>
+                <a:cs typeface="Trade Gothic Next" pitchFamily="34" charset="-120"/>
+              </a:rPr>
+              <a:t> 2s</a:t>
+            </a:r>
+            <a:pPr indent="0" marL="0">
+              <a:buNone/>
+            </a:pPr>
+            <a:r>
+              <a:rPr lang="en-US" sz="1600" baseline="30000" dirty="0">
+                <a:solidFill>
+                  <a:srgbClr val="14161B"/>
+                </a:solidFill>
+                <a:latin typeface="Trade Gothic Next" pitchFamily="34" charset="0"/>
+                <a:ea typeface="Trade Gothic Next" pitchFamily="34" charset="-122"/>
+                <a:cs typeface="Trade Gothic Next" pitchFamily="34" charset="-120"/>
+              </a:rPr>
+              <a:t>2</a:t>
+            </a:r>
+            <a:pPr indent="0" marL="0">
+              <a:buNone/>
+            </a:pPr>
+            <a:r>
+              <a:rPr lang="en-US" sz="1600" dirty="0">
+                <a:solidFill>
+                  <a:srgbClr val="14161B"/>
+                </a:solidFill>
+                <a:latin typeface="Trade Gothic Next" pitchFamily="34" charset="0"/>
+                <a:ea typeface="Trade Gothic Next" pitchFamily="34" charset="-122"/>
+                <a:cs typeface="Trade Gothic Next" pitchFamily="34" charset="-120"/>
+              </a:rPr>
+              <a:t> 2p</a:t>
+            </a:r>
+            <a:pPr indent="0" marL="0">
+              <a:buNone/>
+            </a:pPr>
+            <a:r>
+              <a:rPr lang="en-US" sz="1600" baseline="30000" dirty="0">
+                <a:solidFill>
+                  <a:srgbClr val="14161B"/>
+                </a:solidFill>
+                <a:latin typeface="Trade Gothic Next" pitchFamily="34" charset="0"/>
+                <a:ea typeface="Trade Gothic Next" pitchFamily="34" charset="-122"/>
+                <a:cs typeface="Trade Gothic Next" pitchFamily="34" charset="-120"/>
+              </a:rPr>
+              <a:t>3</a:t>
+            </a:r>
             <a:endParaRPr lang="en-US" sz="1600" dirty="0"/>
           </a:p>
           <a:p>
@@ -14005,14 +14429,134 @@
                 <a:ea typeface="Trade Gothic Next" pitchFamily="34" charset="-122"/>
                 <a:cs typeface="Trade Gothic Next" pitchFamily="34" charset="-120"/>
               </a:rPr>
-              <a:t>1s² 2s² 2p⁶ 3s² 3p⁵</a:t>
-            </a:r>
-            <a:endParaRPr lang="en-US" sz="1600" dirty="0"/>
-          </a:p>
-          <a:p>
-            <a:pPr indent="0" marL="0">
-              <a:buNone/>
-            </a:pPr>
+              <a:t>1s</a:t>
+            </a:r>
+            <a:pPr indent="0" marL="0">
+              <a:buNone/>
+            </a:pPr>
+            <a:r>
+              <a:rPr lang="en-US" sz="1600" baseline="30000" dirty="0">
+                <a:solidFill>
+                  <a:srgbClr val="14161B"/>
+                </a:solidFill>
+                <a:latin typeface="Trade Gothic Next" pitchFamily="34" charset="0"/>
+                <a:ea typeface="Trade Gothic Next" pitchFamily="34" charset="-122"/>
+                <a:cs typeface="Trade Gothic Next" pitchFamily="34" charset="-120"/>
+              </a:rPr>
+              <a:t>2</a:t>
+            </a:r>
+            <a:pPr indent="0" marL="0">
+              <a:buNone/>
+            </a:pPr>
+            <a:r>
+              <a:rPr lang="en-US" sz="1600" dirty="0">
+                <a:solidFill>
+                  <a:srgbClr val="14161B"/>
+                </a:solidFill>
+                <a:latin typeface="Trade Gothic Next" pitchFamily="34" charset="0"/>
+                <a:ea typeface="Trade Gothic Next" pitchFamily="34" charset="-122"/>
+                <a:cs typeface="Trade Gothic Next" pitchFamily="34" charset="-120"/>
+              </a:rPr>
+              <a:t> 2s</a:t>
+            </a:r>
+            <a:pPr indent="0" marL="0">
+              <a:buNone/>
+            </a:pPr>
+            <a:r>
+              <a:rPr lang="en-US" sz="1600" baseline="30000" dirty="0">
+                <a:solidFill>
+                  <a:srgbClr val="14161B"/>
+                </a:solidFill>
+                <a:latin typeface="Trade Gothic Next" pitchFamily="34" charset="0"/>
+                <a:ea typeface="Trade Gothic Next" pitchFamily="34" charset="-122"/>
+                <a:cs typeface="Trade Gothic Next" pitchFamily="34" charset="-120"/>
+              </a:rPr>
+              <a:t>2</a:t>
+            </a:r>
+            <a:pPr indent="0" marL="0">
+              <a:buNone/>
+            </a:pPr>
+            <a:r>
+              <a:rPr lang="en-US" sz="1600" dirty="0">
+                <a:solidFill>
+                  <a:srgbClr val="14161B"/>
+                </a:solidFill>
+                <a:latin typeface="Trade Gothic Next" pitchFamily="34" charset="0"/>
+                <a:ea typeface="Trade Gothic Next" pitchFamily="34" charset="-122"/>
+                <a:cs typeface="Trade Gothic Next" pitchFamily="34" charset="-120"/>
+              </a:rPr>
+              <a:t> 2p</a:t>
+            </a:r>
+            <a:pPr indent="0" marL="0">
+              <a:buNone/>
+            </a:pPr>
+            <a:r>
+              <a:rPr lang="en-US" sz="1600" baseline="30000" dirty="0">
+                <a:solidFill>
+                  <a:srgbClr val="14161B"/>
+                </a:solidFill>
+                <a:latin typeface="Trade Gothic Next" pitchFamily="34" charset="0"/>
+                <a:ea typeface="Trade Gothic Next" pitchFamily="34" charset="-122"/>
+                <a:cs typeface="Trade Gothic Next" pitchFamily="34" charset="-120"/>
+              </a:rPr>
+              <a:t>6</a:t>
+            </a:r>
+            <a:pPr indent="0" marL="0">
+              <a:buNone/>
+            </a:pPr>
+            <a:r>
+              <a:rPr lang="en-US" sz="1600" dirty="0">
+                <a:solidFill>
+                  <a:srgbClr val="14161B"/>
+                </a:solidFill>
+                <a:latin typeface="Trade Gothic Next" pitchFamily="34" charset="0"/>
+                <a:ea typeface="Trade Gothic Next" pitchFamily="34" charset="-122"/>
+                <a:cs typeface="Trade Gothic Next" pitchFamily="34" charset="-120"/>
+              </a:rPr>
+              <a:t> 3s</a:t>
+            </a:r>
+            <a:pPr indent="0" marL="0">
+              <a:buNone/>
+            </a:pPr>
+            <a:r>
+              <a:rPr lang="en-US" sz="1600" baseline="30000" dirty="0">
+                <a:solidFill>
+                  <a:srgbClr val="14161B"/>
+                </a:solidFill>
+                <a:latin typeface="Trade Gothic Next" pitchFamily="34" charset="0"/>
+                <a:ea typeface="Trade Gothic Next" pitchFamily="34" charset="-122"/>
+                <a:cs typeface="Trade Gothic Next" pitchFamily="34" charset="-120"/>
+              </a:rPr>
+              <a:t>2</a:t>
+            </a:r>
+            <a:pPr indent="0" marL="0">
+              <a:buNone/>
+            </a:pPr>
+            <a:r>
+              <a:rPr lang="en-US" sz="1600" dirty="0">
+                <a:solidFill>
+                  <a:srgbClr val="14161B"/>
+                </a:solidFill>
+                <a:latin typeface="Trade Gothic Next" pitchFamily="34" charset="0"/>
+                <a:ea typeface="Trade Gothic Next" pitchFamily="34" charset="-122"/>
+                <a:cs typeface="Trade Gothic Next" pitchFamily="34" charset="-120"/>
+              </a:rPr>
+              <a:t> 3p</a:t>
+            </a:r>
+            <a:pPr indent="0" marL="0">
+              <a:buNone/>
+            </a:pPr>
+            <a:r>
+              <a:rPr lang="en-US" sz="1600" baseline="30000" dirty="0">
+                <a:solidFill>
+                  <a:srgbClr val="14161B"/>
+                </a:solidFill>
+                <a:latin typeface="Trade Gothic Next" pitchFamily="34" charset="0"/>
+                <a:ea typeface="Trade Gothic Next" pitchFamily="34" charset="-122"/>
+                <a:cs typeface="Trade Gothic Next" pitchFamily="34" charset="-120"/>
+              </a:rPr>
+              <a:t>5</a:t>
+            </a:r>
             <a:endParaRPr lang="en-US" sz="1600" dirty="0"/>
           </a:p>
           <a:p>
@@ -14127,14 +14671,162 @@
                 <a:ea typeface="Trade Gothic Next" pitchFamily="34" charset="-122"/>
                 <a:cs typeface="Trade Gothic Next" pitchFamily="34" charset="-120"/>
               </a:rPr>
-              <a:t>1s² 2s² 2p⁶ 3s² 3p⁶ 4s²</a:t>
-            </a:r>
-            <a:endParaRPr lang="en-US" sz="1600" dirty="0"/>
-          </a:p>
-          <a:p>
-            <a:pPr indent="0" marL="0">
-              <a:buNone/>
-            </a:pPr>
+              <a:t>1s</a:t>
+            </a:r>
+            <a:pPr indent="0" marL="0">
+              <a:buNone/>
+            </a:pPr>
+            <a:r>
+              <a:rPr lang="en-US" sz="1600" baseline="30000" dirty="0">
+                <a:solidFill>
+                  <a:srgbClr val="14161B"/>
+                </a:solidFill>
+                <a:latin typeface="Trade Gothic Next" pitchFamily="34" charset="0"/>
+                <a:ea typeface="Trade Gothic Next" pitchFamily="34" charset="-122"/>
+                <a:cs typeface="Trade Gothic Next" pitchFamily="34" charset="-120"/>
+              </a:rPr>
+              <a:t>2</a:t>
+            </a:r>
+            <a:pPr indent="0" marL="0">
+              <a:buNone/>
+            </a:pPr>
+            <a:r>
+              <a:rPr lang="en-US" sz="1600" dirty="0">
+                <a:solidFill>
+                  <a:srgbClr val="14161B"/>
+                </a:solidFill>
+                <a:latin typeface="Trade Gothic Next" pitchFamily="34" charset="0"/>
+                <a:ea typeface="Trade Gothic Next" pitchFamily="34" charset="-122"/>
+                <a:cs typeface="Trade Gothic Next" pitchFamily="34" charset="-120"/>
+              </a:rPr>
+              <a:t> 2s</a:t>
+            </a:r>
+            <a:pPr indent="0" marL="0">
+              <a:buNone/>
+            </a:pPr>
+            <a:r>
+              <a:rPr lang="en-US" sz="1600" baseline="30000" dirty="0">
+                <a:solidFill>
+                  <a:srgbClr val="14161B"/>
+                </a:solidFill>
+                <a:latin typeface="Trade Gothic Next" pitchFamily="34" charset="0"/>
+                <a:ea typeface="Trade Gothic Next" pitchFamily="34" charset="-122"/>
+                <a:cs typeface="Trade Gothic Next" pitchFamily="34" charset="-120"/>
+              </a:rPr>
+              <a:t>2</a:t>
+            </a:r>
+            <a:pPr indent="0" marL="0">
+              <a:buNone/>
+            </a:pPr>
+            <a:r>
+              <a:rPr lang="en-US" sz="1600" dirty="0">
+                <a:solidFill>
+                  <a:srgbClr val="14161B"/>
+                </a:solidFill>
+                <a:latin typeface="Trade Gothic Next" pitchFamily="34" charset="0"/>
+                <a:ea typeface="Trade Gothic Next" pitchFamily="34" charset="-122"/>
+                <a:cs typeface="Trade Gothic Next" pitchFamily="34" charset="-120"/>
+              </a:rPr>
+              <a:t> 2p</a:t>
+            </a:r>
+            <a:pPr indent="0" marL="0">
+              <a:buNone/>
+            </a:pPr>
+            <a:r>
+              <a:rPr lang="en-US" sz="1600" baseline="30000" dirty="0">
+                <a:solidFill>
+                  <a:srgbClr val="14161B"/>
+                </a:solidFill>
+                <a:latin typeface="Trade Gothic Next" pitchFamily="34" charset="0"/>
+                <a:ea typeface="Trade Gothic Next" pitchFamily="34" charset="-122"/>
+                <a:cs typeface="Trade Gothic Next" pitchFamily="34" charset="-120"/>
+              </a:rPr>
+              <a:t>6</a:t>
+            </a:r>
+            <a:pPr indent="0" marL="0">
+              <a:buNone/>
+            </a:pPr>
+            <a:r>
+              <a:rPr lang="en-US" sz="1600" dirty="0">
+                <a:solidFill>
+                  <a:srgbClr val="14161B"/>
+                </a:solidFill>
+                <a:latin typeface="Trade Gothic Next" pitchFamily="34" charset="0"/>
+                <a:ea typeface="Trade Gothic Next" pitchFamily="34" charset="-122"/>
+                <a:cs typeface="Trade Gothic Next" pitchFamily="34" charset="-120"/>
+              </a:rPr>
+              <a:t> 3s</a:t>
+            </a:r>
+            <a:pPr indent="0" marL="0">
+              <a:buNone/>
+            </a:pPr>
+            <a:r>
+              <a:rPr lang="en-US" sz="1600" baseline="30000" dirty="0">
+                <a:solidFill>
+                  <a:srgbClr val="14161B"/>
+                </a:solidFill>
+                <a:latin typeface="Trade Gothic Next" pitchFamily="34" charset="0"/>
+                <a:ea typeface="Trade Gothic Next" pitchFamily="34" charset="-122"/>
+                <a:cs typeface="Trade Gothic Next" pitchFamily="34" charset="-120"/>
+              </a:rPr>
+              <a:t>2</a:t>
+            </a:r>
+            <a:pPr indent="0" marL="0">
+              <a:buNone/>
+            </a:pPr>
+            <a:r>
+              <a:rPr lang="en-US" sz="1600" dirty="0">
+                <a:solidFill>
+                  <a:srgbClr val="14161B"/>
+                </a:solidFill>
+                <a:latin typeface="Trade Gothic Next" pitchFamily="34" charset="0"/>
+                <a:ea typeface="Trade Gothic Next" pitchFamily="34" charset="-122"/>
+                <a:cs typeface="Trade Gothic Next" pitchFamily="34" charset="-120"/>
+              </a:rPr>
+              <a:t> 3p</a:t>
+            </a:r>
+            <a:pPr indent="0" marL="0">
+              <a:buNone/>
+            </a:pPr>
+            <a:r>
+              <a:rPr lang="en-US" sz="1600" baseline="30000" dirty="0">
+                <a:solidFill>
+                  <a:srgbClr val="14161B"/>
+                </a:solidFill>
+                <a:latin typeface="Trade Gothic Next" pitchFamily="34" charset="0"/>
+                <a:ea typeface="Trade Gothic Next" pitchFamily="34" charset="-122"/>
+                <a:cs typeface="Trade Gothic Next" pitchFamily="34" charset="-120"/>
+              </a:rPr>
+              <a:t>6</a:t>
+            </a:r>
+            <a:pPr indent="0" marL="0">
+              <a:buNone/>
+            </a:pPr>
+            <a:r>
+              <a:rPr lang="en-US" sz="1600" dirty="0">
+                <a:solidFill>
+                  <a:srgbClr val="14161B"/>
+                </a:solidFill>
+                <a:latin typeface="Trade Gothic Next" pitchFamily="34" charset="0"/>
+                <a:ea typeface="Trade Gothic Next" pitchFamily="34" charset="-122"/>
+                <a:cs typeface="Trade Gothic Next" pitchFamily="34" charset="-120"/>
+              </a:rPr>
+              <a:t> 4s</a:t>
+            </a:r>
+            <a:pPr indent="0" marL="0">
+              <a:buNone/>
+            </a:pPr>
+            <a:r>
+              <a:rPr lang="en-US" sz="1600" baseline="30000" dirty="0">
+                <a:solidFill>
+                  <a:srgbClr val="14161B"/>
+                </a:solidFill>
+                <a:latin typeface="Trade Gothic Next" pitchFamily="34" charset="0"/>
+                <a:ea typeface="Trade Gothic Next" pitchFamily="34" charset="-122"/>
+                <a:cs typeface="Trade Gothic Next" pitchFamily="34" charset="-120"/>
+              </a:rPr>
+              <a:t>2</a:t>
+            </a:r>
             <a:endParaRPr lang="en-US" sz="1600" dirty="0"/>
           </a:p>
           <a:p>
@@ -14298,7 +14990,7 @@
       </p:sp>
       <p:sp>
         <p:nvSpPr>
-          <p:cNvPr id="13" name="Text 4"/>
+          <p:cNvPr id="14" name="Text 4"/>
           <p:cNvSpPr txBox="1"/>
           <p:nvPr>
             <p:ph idx="107" hasCustomPrompt="1"/>
@@ -14509,14 +15201,134 @@
                 <a:ea typeface="Trade Gothic Next" pitchFamily="34" charset="-122"/>
                 <a:cs typeface="Trade Gothic Next" pitchFamily="34" charset="-120"/>
               </a:rPr>
-              <a:t>1s² 2s² 2p⁶ 3s² 3p⁵</a:t>
-            </a:r>
-            <a:endParaRPr lang="en-US" sz="1600" dirty="0"/>
-          </a:p>
-          <a:p>
-            <a:pPr indent="0" marL="0">
-              <a:buNone/>
-            </a:pPr>
+              <a:t>1s</a:t>
+            </a:r>
+            <a:pPr indent="0" marL="0">
+              <a:buNone/>
+            </a:pPr>
+            <a:r>
+              <a:rPr lang="en-US" sz="1600" baseline="30000" dirty="0">
+                <a:solidFill>
+                  <a:srgbClr val="14161B"/>
+                </a:solidFill>
+                <a:latin typeface="Trade Gothic Next" pitchFamily="34" charset="0"/>
+                <a:ea typeface="Trade Gothic Next" pitchFamily="34" charset="-122"/>
+                <a:cs typeface="Trade Gothic Next" pitchFamily="34" charset="-120"/>
+              </a:rPr>
+              <a:t>2</a:t>
+            </a:r>
+            <a:pPr indent="0" marL="0">
+              <a:buNone/>
+            </a:pPr>
+            <a:r>
+              <a:rPr lang="en-US" sz="1600" dirty="0">
+                <a:solidFill>
+                  <a:srgbClr val="14161B"/>
+                </a:solidFill>
+                <a:latin typeface="Trade Gothic Next" pitchFamily="34" charset="0"/>
+                <a:ea typeface="Trade Gothic Next" pitchFamily="34" charset="-122"/>
+                <a:cs typeface="Trade Gothic Next" pitchFamily="34" charset="-120"/>
+              </a:rPr>
+              <a:t> 2s</a:t>
+            </a:r>
+            <a:pPr indent="0" marL="0">
+              <a:buNone/>
+            </a:pPr>
+            <a:r>
+              <a:rPr lang="en-US" sz="1600" baseline="30000" dirty="0">
+                <a:solidFill>
+                  <a:srgbClr val="14161B"/>
+                </a:solidFill>
+                <a:latin typeface="Trade Gothic Next" pitchFamily="34" charset="0"/>
+                <a:ea typeface="Trade Gothic Next" pitchFamily="34" charset="-122"/>
+                <a:cs typeface="Trade Gothic Next" pitchFamily="34" charset="-120"/>
+              </a:rPr>
+              <a:t>2</a:t>
+            </a:r>
+            <a:pPr indent="0" marL="0">
+              <a:buNone/>
+            </a:pPr>
+            <a:r>
+              <a:rPr lang="en-US" sz="1600" dirty="0">
+                <a:solidFill>
+                  <a:srgbClr val="14161B"/>
+                </a:solidFill>
+                <a:latin typeface="Trade Gothic Next" pitchFamily="34" charset="0"/>
+                <a:ea typeface="Trade Gothic Next" pitchFamily="34" charset="-122"/>
+                <a:cs typeface="Trade Gothic Next" pitchFamily="34" charset="-120"/>
+              </a:rPr>
+              <a:t> 2p</a:t>
+            </a:r>
+            <a:pPr indent="0" marL="0">
+              <a:buNone/>
+            </a:pPr>
+            <a:r>
+              <a:rPr lang="en-US" sz="1600" baseline="30000" dirty="0">
+                <a:solidFill>
+                  <a:srgbClr val="14161B"/>
+                </a:solidFill>
+                <a:latin typeface="Trade Gothic Next" pitchFamily="34" charset="0"/>
+                <a:ea typeface="Trade Gothic Next" pitchFamily="34" charset="-122"/>
+                <a:cs typeface="Trade Gothic Next" pitchFamily="34" charset="-120"/>
+              </a:rPr>
+              <a:t>6</a:t>
+            </a:r>
+            <a:pPr indent="0" marL="0">
+              <a:buNone/>
+            </a:pPr>
+            <a:r>
+              <a:rPr lang="en-US" sz="1600" dirty="0">
+                <a:solidFill>
+                  <a:srgbClr val="14161B"/>
+                </a:solidFill>
+                <a:latin typeface="Trade Gothic Next" pitchFamily="34" charset="0"/>
+                <a:ea typeface="Trade Gothic Next" pitchFamily="34" charset="-122"/>
+                <a:cs typeface="Trade Gothic Next" pitchFamily="34" charset="-120"/>
+              </a:rPr>
+              <a:t> 3s</a:t>
+            </a:r>
+            <a:pPr indent="0" marL="0">
+              <a:buNone/>
+            </a:pPr>
+            <a:r>
+              <a:rPr lang="en-US" sz="1600" baseline="30000" dirty="0">
+                <a:solidFill>
+                  <a:srgbClr val="14161B"/>
+                </a:solidFill>
+                <a:latin typeface="Trade Gothic Next" pitchFamily="34" charset="0"/>
+                <a:ea typeface="Trade Gothic Next" pitchFamily="34" charset="-122"/>
+                <a:cs typeface="Trade Gothic Next" pitchFamily="34" charset="-120"/>
+              </a:rPr>
+              <a:t>2</a:t>
+            </a:r>
+            <a:pPr indent="0" marL="0">
+              <a:buNone/>
+            </a:pPr>
+            <a:r>
+              <a:rPr lang="en-US" sz="1600" dirty="0">
+                <a:solidFill>
+                  <a:srgbClr val="14161B"/>
+                </a:solidFill>
+                <a:latin typeface="Trade Gothic Next" pitchFamily="34" charset="0"/>
+                <a:ea typeface="Trade Gothic Next" pitchFamily="34" charset="-122"/>
+                <a:cs typeface="Trade Gothic Next" pitchFamily="34" charset="-120"/>
+              </a:rPr>
+              <a:t> 3p</a:t>
+            </a:r>
+            <a:pPr indent="0" marL="0">
+              <a:buNone/>
+            </a:pPr>
+            <a:r>
+              <a:rPr lang="en-US" sz="1600" baseline="30000" dirty="0">
+                <a:solidFill>
+                  <a:srgbClr val="14161B"/>
+                </a:solidFill>
+                <a:latin typeface="Trade Gothic Next" pitchFamily="34" charset="0"/>
+                <a:ea typeface="Trade Gothic Next" pitchFamily="34" charset="-122"/>
+                <a:cs typeface="Trade Gothic Next" pitchFamily="34" charset="-120"/>
+              </a:rPr>
+              <a:t>5</a:t>
+            </a:r>
             <a:endParaRPr lang="en-US" sz="1600" dirty="0"/>
           </a:p>
           <a:p>
@@ -14614,7 +15426,49 @@
                 <a:ea typeface="Trade Gothic Next" pitchFamily="34" charset="-122"/>
                 <a:cs typeface="Trade Gothic Next" pitchFamily="34" charset="-120"/>
               </a:rPr>
-              <a:t>[Ne] 3s² 3p⁵</a:t>
+              <a:t>[Ne] 3s</a:t>
+            </a:r>
+            <a:pPr indent="0" marL="0">
+              <a:buNone/>
+            </a:pPr>
+            <a:r>
+              <a:rPr lang="en-US" sz="1600" baseline="30000" dirty="0">
+                <a:solidFill>
+                  <a:srgbClr val="EDF0E5"/>
+                </a:solidFill>
+                <a:latin typeface="Trade Gothic Next" pitchFamily="34" charset="0"/>
+                <a:ea typeface="Trade Gothic Next" pitchFamily="34" charset="-122"/>
+                <a:cs typeface="Trade Gothic Next" pitchFamily="34" charset="-120"/>
+              </a:rPr>
+              <a:t>2</a:t>
+            </a:r>
+            <a:pPr indent="0" marL="0">
+              <a:buNone/>
+            </a:pPr>
+            <a:r>
+              <a:rPr lang="en-US" sz="1600" dirty="0">
+                <a:solidFill>
+                  <a:srgbClr val="EDF0E5"/>
+                </a:solidFill>
+                <a:latin typeface="Trade Gothic Next" pitchFamily="34" charset="0"/>
+                <a:ea typeface="Trade Gothic Next" pitchFamily="34" charset="-122"/>
+                <a:cs typeface="Trade Gothic Next" pitchFamily="34" charset="-120"/>
+              </a:rPr>
+              <a:t> 3p</a:t>
+            </a:r>
+            <a:pPr indent="0" marL="0">
+              <a:buNone/>
+            </a:pPr>
+            <a:r>
+              <a:rPr lang="en-US" sz="1600" baseline="30000" dirty="0">
+                <a:solidFill>
+                  <a:srgbClr val="EDF0E5"/>
+                </a:solidFill>
+                <a:latin typeface="Trade Gothic Next" pitchFamily="34" charset="0"/>
+                <a:ea typeface="Trade Gothic Next" pitchFamily="34" charset="-122"/>
+                <a:cs typeface="Trade Gothic Next" pitchFamily="34" charset="-120"/>
+              </a:rPr>
+              <a:t>5</a:t>
             </a:r>
             <a:endParaRPr lang="en-US" sz="1600" dirty="0"/>
           </a:p>
@@ -14622,12 +15476,6 @@
             <a:pPr indent="0" marL="0">
               <a:buNone/>
             </a:pPr>
-            <a:endParaRPr lang="en-US" sz="1600" dirty="0"/>
-          </a:p>
-          <a:p>
-            <a:pPr indent="0" marL="0">
-              <a:buNone/>
-            </a:pPr>
             <a:r>
               <a:rPr lang="en-US" sz="1600" dirty="0">
                 <a:solidFill>
@@ -14637,7 +15485,91 @@
                 <a:ea typeface="Trade Gothic Next" pitchFamily="34" charset="-122"/>
                 <a:cs typeface="Trade Gothic Next" pitchFamily="34" charset="-120"/>
               </a:rPr>
-              <a:t>[Ne] stands for the first 10: 1s² 2s² 2p⁶.</a:t>
+              <a:t>[Ne] stands for the first 10: 1s</a:t>
+            </a:r>
+            <a:pPr indent="0" marL="0">
+              <a:buNone/>
+            </a:pPr>
+            <a:r>
+              <a:rPr lang="en-US" sz="1600" baseline="30000" dirty="0">
+                <a:solidFill>
+                  <a:srgbClr val="EDF0E5"/>
+                </a:solidFill>
+                <a:latin typeface="Trade Gothic Next" pitchFamily="34" charset="0"/>
+                <a:ea typeface="Trade Gothic Next" pitchFamily="34" charset="-122"/>
+                <a:cs typeface="Trade Gothic Next" pitchFamily="34" charset="-120"/>
+              </a:rPr>
+              <a:t>2</a:t>
+            </a:r>
+            <a:pPr indent="0" marL="0">
+              <a:buNone/>
+            </a:pPr>
+            <a:r>
+              <a:rPr lang="en-US" sz="1600" dirty="0">
+                <a:solidFill>
+                  <a:srgbClr val="EDF0E5"/>
+                </a:solidFill>
+                <a:latin typeface="Trade Gothic Next" pitchFamily="34" charset="0"/>
+                <a:ea typeface="Trade Gothic Next" pitchFamily="34" charset="-122"/>
+                <a:cs typeface="Trade Gothic Next" pitchFamily="34" charset="-120"/>
+              </a:rPr>
+              <a:t> 2s</a:t>
+            </a:r>
+            <a:pPr indent="0" marL="0">
+              <a:buNone/>
+            </a:pPr>
+            <a:r>
+              <a:rPr lang="en-US" sz="1600" baseline="30000" dirty="0">
+                <a:solidFill>
+                  <a:srgbClr val="EDF0E5"/>
+                </a:solidFill>
+                <a:latin typeface="Trade Gothic Next" pitchFamily="34" charset="0"/>
+                <a:ea typeface="Trade Gothic Next" pitchFamily="34" charset="-122"/>
+                <a:cs typeface="Trade Gothic Next" pitchFamily="34" charset="-120"/>
+              </a:rPr>
+              <a:t>2</a:t>
+            </a:r>
+            <a:pPr indent="0" marL="0">
+              <a:buNone/>
+            </a:pPr>
+            <a:r>
+              <a:rPr lang="en-US" sz="1600" dirty="0">
+                <a:solidFill>
+                  <a:srgbClr val="EDF0E5"/>
+                </a:solidFill>
+                <a:latin typeface="Trade Gothic Next" pitchFamily="34" charset="0"/>
+                <a:ea typeface="Trade Gothic Next" pitchFamily="34" charset="-122"/>
+                <a:cs typeface="Trade Gothic Next" pitchFamily="34" charset="-120"/>
+              </a:rPr>
+              <a:t> 2p</a:t>
+            </a:r>
+            <a:pPr indent="0" marL="0">
+              <a:buNone/>
+            </a:pPr>
+            <a:r>
+              <a:rPr lang="en-US" sz="1600" baseline="30000" dirty="0">
+                <a:solidFill>
+                  <a:srgbClr val="EDF0E5"/>
+                </a:solidFill>
+                <a:latin typeface="Trade Gothic Next" pitchFamily="34" charset="0"/>
+                <a:ea typeface="Trade Gothic Next" pitchFamily="34" charset="-122"/>
+                <a:cs typeface="Trade Gothic Next" pitchFamily="34" charset="-120"/>
+              </a:rPr>
+              <a:t>6</a:t>
+            </a:r>
+            <a:pPr indent="0" marL="0">
+              <a:buNone/>
+            </a:pPr>
+            <a:r>
+              <a:rPr lang="en-US" sz="1600" dirty="0">
+                <a:solidFill>
+                  <a:srgbClr val="EDF0E5"/>
+                </a:solidFill>
+                <a:latin typeface="Trade Gothic Next" pitchFamily="34" charset="0"/>
+                <a:ea typeface="Trade Gothic Next" pitchFamily="34" charset="-122"/>
+                <a:cs typeface="Trade Gothic Next" pitchFamily="34" charset="-120"/>
+              </a:rPr>
+              <a:t>.</a:t>
             </a:r>
             <a:endParaRPr lang="en-US" sz="1600" dirty="0"/>
           </a:p>
@@ -14678,7 +15610,7 @@
                 <a:ea typeface="Trade Gothic Next" pitchFamily="34" charset="-122"/>
                 <a:cs typeface="Trade Gothic Next" pitchFamily="34" charset="-120"/>
               </a:rPr>
-              <a:t>Use the noble gas from the previous period. Cl is in period 3, so its core is [Ne].</a:t>
+              <a:t>Use the previous period's noble gas. Cl is in period 3, so its core is [Ne], not [Ar].</a:t>
             </a:r>
             <a:endParaRPr lang="en-US" sz="1600" dirty="0"/>
           </a:p>
@@ -14768,7 +15700,7 @@
       </p:sp>
       <p:sp>
         <p:nvSpPr>
-          <p:cNvPr id="11" name="Text 3"/>
+          <p:cNvPr id="12" name="Text 3"/>
           <p:cNvSpPr txBox="1"/>
           <p:nvPr>
             <p:ph idx="106" hasCustomPrompt="1"/>
@@ -15314,7 +16246,7 @@
       </p:sp>
       <p:sp>
         <p:nvSpPr>
-          <p:cNvPr id="13" name="Text 4"/>
+          <p:cNvPr id="14" name="Text 4"/>
           <p:cNvSpPr txBox="1"/>
           <p:nvPr>
             <p:ph idx="107" hasCustomPrompt="1"/>
@@ -15549,7 +16481,133 @@
                 <a:ea typeface="Trade Gothic Next" pitchFamily="34" charset="-122"/>
                 <a:cs typeface="Trade Gothic Next" pitchFamily="34" charset="-120"/>
               </a:rPr>
-              <a:t>1s² 2s² 2p⁶ 3s² 3p⁶</a:t>
+              <a:t>1s</a:t>
+            </a:r>
+            <a:pPr indent="0" marL="0">
+              <a:buNone/>
+            </a:pPr>
+            <a:r>
+              <a:rPr lang="en-US" sz="1600" baseline="30000" dirty="0">
+                <a:solidFill>
+                  <a:srgbClr val="14161B"/>
+                </a:solidFill>
+                <a:latin typeface="Trade Gothic Next" pitchFamily="34" charset="0"/>
+                <a:ea typeface="Trade Gothic Next" pitchFamily="34" charset="-122"/>
+                <a:cs typeface="Trade Gothic Next" pitchFamily="34" charset="-120"/>
+              </a:rPr>
+              <a:t>2</a:t>
+            </a:r>
+            <a:pPr indent="0" marL="0">
+              <a:buNone/>
+            </a:pPr>
+            <a:r>
+              <a:rPr lang="en-US" sz="1600" dirty="0">
+                <a:solidFill>
+                  <a:srgbClr val="14161B"/>
+                </a:solidFill>
+                <a:latin typeface="Trade Gothic Next" pitchFamily="34" charset="0"/>
+                <a:ea typeface="Trade Gothic Next" pitchFamily="34" charset="-122"/>
+                <a:cs typeface="Trade Gothic Next" pitchFamily="34" charset="-120"/>
+              </a:rPr>
+              <a:t> 2s</a:t>
+            </a:r>
+            <a:pPr indent="0" marL="0">
+              <a:buNone/>
+            </a:pPr>
+            <a:r>
+              <a:rPr lang="en-US" sz="1600" baseline="30000" dirty="0">
+                <a:solidFill>
+                  <a:srgbClr val="14161B"/>
+                </a:solidFill>
+                <a:latin typeface="Trade Gothic Next" pitchFamily="34" charset="0"/>
+                <a:ea typeface="Trade Gothic Next" pitchFamily="34" charset="-122"/>
+                <a:cs typeface="Trade Gothic Next" pitchFamily="34" charset="-120"/>
+              </a:rPr>
+              <a:t>2</a:t>
+            </a:r>
+            <a:pPr indent="0" marL="0">
+              <a:buNone/>
+            </a:pPr>
+            <a:r>
+              <a:rPr lang="en-US" sz="1600" dirty="0">
+                <a:solidFill>
+                  <a:srgbClr val="14161B"/>
+                </a:solidFill>
+                <a:latin typeface="Trade Gothic Next" pitchFamily="34" charset="0"/>
+                <a:ea typeface="Trade Gothic Next" pitchFamily="34" charset="-122"/>
+                <a:cs typeface="Trade Gothic Next" pitchFamily="34" charset="-120"/>
+              </a:rPr>
+              <a:t> 2p</a:t>
+            </a:r>
+            <a:pPr indent="0" marL="0">
+              <a:buNone/>
+            </a:pPr>
+            <a:r>
+              <a:rPr lang="en-US" sz="1600" baseline="30000" dirty="0">
+                <a:solidFill>
+                  <a:srgbClr val="14161B"/>
+                </a:solidFill>
+                <a:latin typeface="Trade Gothic Next" pitchFamily="34" charset="0"/>
+                <a:ea typeface="Trade Gothic Next" pitchFamily="34" charset="-122"/>
+                <a:cs typeface="Trade Gothic Next" pitchFamily="34" charset="-120"/>
+              </a:rPr>
+              <a:t>6</a:t>
+            </a:r>
+            <a:pPr indent="0" marL="0">
+              <a:buNone/>
+            </a:pPr>
+            <a:r>
+              <a:rPr lang="en-US" sz="1600" dirty="0">
+                <a:solidFill>
+                  <a:srgbClr val="14161B"/>
+                </a:solidFill>
+                <a:latin typeface="Trade Gothic Next" pitchFamily="34" charset="0"/>
+                <a:ea typeface="Trade Gothic Next" pitchFamily="34" charset="-122"/>
+                <a:cs typeface="Trade Gothic Next" pitchFamily="34" charset="-120"/>
+              </a:rPr>
+              <a:t> 3s</a:t>
+            </a:r>
+            <a:pPr indent="0" marL="0">
+              <a:buNone/>
+            </a:pPr>
+            <a:r>
+              <a:rPr lang="en-US" sz="1600" baseline="30000" dirty="0">
+                <a:solidFill>
+                  <a:srgbClr val="14161B"/>
+                </a:solidFill>
+                <a:latin typeface="Trade Gothic Next" pitchFamily="34" charset="0"/>
+                <a:ea typeface="Trade Gothic Next" pitchFamily="34" charset="-122"/>
+                <a:cs typeface="Trade Gothic Next" pitchFamily="34" charset="-120"/>
+              </a:rPr>
+              <a:t>2</a:t>
+            </a:r>
+            <a:pPr indent="0" marL="0">
+              <a:buNone/>
+            </a:pPr>
+            <a:r>
+              <a:rPr lang="en-US" sz="1600" dirty="0">
+                <a:solidFill>
+                  <a:srgbClr val="14161B"/>
+                </a:solidFill>
+                <a:latin typeface="Trade Gothic Next" pitchFamily="34" charset="0"/>
+                <a:ea typeface="Trade Gothic Next" pitchFamily="34" charset="-122"/>
+                <a:cs typeface="Trade Gothic Next" pitchFamily="34" charset="-120"/>
+              </a:rPr>
+              <a:t> 3p</a:t>
+            </a:r>
+            <a:pPr indent="0" marL="0">
+              <a:buNone/>
+            </a:pPr>
+            <a:r>
+              <a:rPr lang="en-US" sz="1600" baseline="30000" dirty="0">
+                <a:solidFill>
+                  <a:srgbClr val="14161B"/>
+                </a:solidFill>
+                <a:latin typeface="Trade Gothic Next" pitchFamily="34" charset="0"/>
+                <a:ea typeface="Trade Gothic Next" pitchFamily="34" charset="-122"/>
+                <a:cs typeface="Trade Gothic Next" pitchFamily="34" charset="-120"/>
+              </a:rPr>
+              <a:t>6</a:t>
             </a:r>
             <a:endParaRPr lang="en-US" sz="1600" dirty="0"/>
           </a:p>
@@ -15566,7 +16624,49 @@
                 <a:ea typeface="Trade Gothic Next" pitchFamily="34" charset="-122"/>
                 <a:cs typeface="Trade Gothic Next" pitchFamily="34" charset="-120"/>
               </a:rPr>
-              <a:t>4s² 3d⁶</a:t>
+              <a:t>4s</a:t>
+            </a:r>
+            <a:pPr indent="0" marL="0">
+              <a:buNone/>
+            </a:pPr>
+            <a:r>
+              <a:rPr lang="en-US" sz="1600" baseline="30000" dirty="0">
+                <a:solidFill>
+                  <a:srgbClr val="14161B"/>
+                </a:solidFill>
+                <a:latin typeface="Trade Gothic Next" pitchFamily="34" charset="0"/>
+                <a:ea typeface="Trade Gothic Next" pitchFamily="34" charset="-122"/>
+                <a:cs typeface="Trade Gothic Next" pitchFamily="34" charset="-120"/>
+              </a:rPr>
+              <a:t>2</a:t>
+            </a:r>
+            <a:pPr indent="0" marL="0">
+              <a:buNone/>
+            </a:pPr>
+            <a:r>
+              <a:rPr lang="en-US" sz="1600" dirty="0">
+                <a:solidFill>
+                  <a:srgbClr val="14161B"/>
+                </a:solidFill>
+                <a:latin typeface="Trade Gothic Next" pitchFamily="34" charset="0"/>
+                <a:ea typeface="Trade Gothic Next" pitchFamily="34" charset="-122"/>
+                <a:cs typeface="Trade Gothic Next" pitchFamily="34" charset="-120"/>
+              </a:rPr>
+              <a:t> 3d</a:t>
+            </a:r>
+            <a:pPr indent="0" marL="0">
+              <a:buNone/>
+            </a:pPr>
+            <a:r>
+              <a:rPr lang="en-US" sz="1600" baseline="30000" dirty="0">
+                <a:solidFill>
+                  <a:srgbClr val="14161B"/>
+                </a:solidFill>
+                <a:latin typeface="Trade Gothic Next" pitchFamily="34" charset="0"/>
+                <a:ea typeface="Trade Gothic Next" pitchFamily="34" charset="-122"/>
+                <a:cs typeface="Trade Gothic Next" pitchFamily="34" charset="-120"/>
+              </a:rPr>
+              <a:t>6</a:t>
             </a:r>
             <a:endParaRPr lang="en-US" sz="1600" dirty="0"/>
           </a:p>
@@ -15607,7 +16707,49 @@
                 <a:ea typeface="Trade Gothic Next" pitchFamily="34" charset="-122"/>
                 <a:cs typeface="Trade Gothic Next" pitchFamily="34" charset="-120"/>
               </a:rPr>
-              <a:t>[Ar] 4s² 3d⁶</a:t>
+              <a:t>[Ar] 4s</a:t>
+            </a:r>
+            <a:pPr indent="0" marL="0">
+              <a:buNone/>
+            </a:pPr>
+            <a:r>
+              <a:rPr lang="en-US" sz="1900" baseline="30000" dirty="0">
+                <a:solidFill>
+                  <a:srgbClr val="14161B"/>
+                </a:solidFill>
+                <a:latin typeface="Trade Gothic Next" pitchFamily="34" charset="0"/>
+                <a:ea typeface="Trade Gothic Next" pitchFamily="34" charset="-122"/>
+                <a:cs typeface="Trade Gothic Next" pitchFamily="34" charset="-120"/>
+              </a:rPr>
+              <a:t>2</a:t>
+            </a:r>
+            <a:pPr indent="0" marL="0">
+              <a:buNone/>
+            </a:pPr>
+            <a:r>
+              <a:rPr lang="en-US" sz="1900" dirty="0">
+                <a:solidFill>
+                  <a:srgbClr val="14161B"/>
+                </a:solidFill>
+                <a:latin typeface="Trade Gothic Next" pitchFamily="34" charset="0"/>
+                <a:ea typeface="Trade Gothic Next" pitchFamily="34" charset="-122"/>
+                <a:cs typeface="Trade Gothic Next" pitchFamily="34" charset="-120"/>
+              </a:rPr>
+              <a:t> 3d</a:t>
+            </a:r>
+            <a:pPr indent="0" marL="0">
+              <a:buNone/>
+            </a:pPr>
+            <a:r>
+              <a:rPr lang="en-US" sz="1900" baseline="30000" dirty="0">
+                <a:solidFill>
+                  <a:srgbClr val="14161B"/>
+                </a:solidFill>
+                <a:latin typeface="Trade Gothic Next" pitchFamily="34" charset="0"/>
+                <a:ea typeface="Trade Gothic Next" pitchFamily="34" charset="-122"/>
+                <a:cs typeface="Trade Gothic Next" pitchFamily="34" charset="-120"/>
+              </a:rPr>
+              <a:t>6</a:t>
             </a:r>
             <a:endParaRPr lang="en-US" sz="1900" dirty="0"/>
           </a:p>
@@ -15682,7 +16824,63 @@
                 <a:ea typeface="Trade Gothic Next" pitchFamily="34" charset="-122"/>
                 <a:cs typeface="Trade Gothic Next" pitchFamily="34" charset="-120"/>
               </a:rPr>
-              <a:t>Fe is [Ar] 4s² 3d⁶. One pair and 4 singles in the 3d boxes.</a:t>
+              <a:t>Fe is [Ar] 4s</a:t>
+            </a:r>
+            <a:pPr indent="0" marL="0">
+              <a:buNone/>
+            </a:pPr>
+            <a:r>
+              <a:rPr lang="en-US" sz="1600" b="1" baseline="30000" dirty="0">
+                <a:solidFill>
+                  <a:srgbClr val="EDF0E5"/>
+                </a:solidFill>
+                <a:latin typeface="Trade Gothic Next" pitchFamily="34" charset="0"/>
+                <a:ea typeface="Trade Gothic Next" pitchFamily="34" charset="-122"/>
+                <a:cs typeface="Trade Gothic Next" pitchFamily="34" charset="-120"/>
+              </a:rPr>
+              <a:t>2</a:t>
+            </a:r>
+            <a:pPr indent="0" marL="0">
+              <a:buNone/>
+            </a:pPr>
+            <a:r>
+              <a:rPr lang="en-US" sz="1600" b="1" dirty="0">
+                <a:solidFill>
+                  <a:srgbClr val="EDF0E5"/>
+                </a:solidFill>
+                <a:latin typeface="Trade Gothic Next" pitchFamily="34" charset="0"/>
+                <a:ea typeface="Trade Gothic Next" pitchFamily="34" charset="-122"/>
+                <a:cs typeface="Trade Gothic Next" pitchFamily="34" charset="-120"/>
+              </a:rPr>
+              <a:t> 3d</a:t>
+            </a:r>
+            <a:pPr indent="0" marL="0">
+              <a:buNone/>
+            </a:pPr>
+            <a:r>
+              <a:rPr lang="en-US" sz="1600" b="1" baseline="30000" dirty="0">
+                <a:solidFill>
+                  <a:srgbClr val="EDF0E5"/>
+                </a:solidFill>
+                <a:latin typeface="Trade Gothic Next" pitchFamily="34" charset="0"/>
+                <a:ea typeface="Trade Gothic Next" pitchFamily="34" charset="-122"/>
+                <a:cs typeface="Trade Gothic Next" pitchFamily="34" charset="-120"/>
+              </a:rPr>
+              <a:t>6</a:t>
+            </a:r>
+            <a:pPr indent="0" marL="0">
+              <a:buNone/>
+            </a:pPr>
+            <a:r>
+              <a:rPr lang="en-US" sz="1600" b="1" dirty="0">
+                <a:solidFill>
+                  <a:srgbClr val="EDF0E5"/>
+                </a:solidFill>
+                <a:latin typeface="Trade Gothic Next" pitchFamily="34" charset="0"/>
+                <a:ea typeface="Trade Gothic Next" pitchFamily="34" charset="-122"/>
+                <a:cs typeface="Trade Gothic Next" pitchFamily="34" charset="-120"/>
+              </a:rPr>
+              <a:t>. One pair and 4 singles in the 3d boxes.</a:t>
             </a:r>
             <a:endParaRPr lang="en-US" sz="1600" dirty="0"/>
           </a:p>
@@ -15772,7 +16970,7 @@
       </p:sp>
       <p:sp>
         <p:nvSpPr>
-          <p:cNvPr id="11" name="Text 4"/>
+          <p:cNvPr id="12" name="Text 4"/>
           <p:cNvSpPr txBox="1"/>
           <p:nvPr>
             <p:ph idx="107" hasCustomPrompt="1"/>
@@ -15925,7 +17123,35 @@
                 <a:ea typeface="Trade Gothic Next" pitchFamily="34" charset="-122"/>
                 <a:cs typeface="Trade Gothic Next" pitchFamily="34" charset="-120"/>
               </a:rPr>
-              <a:t>Learn both. The rules predict 4s² for each, and the measurements disagree.</a:t>
+              <a:t>Learn both. The rules predict 4s</a:t>
+            </a:r>
+            <a:pPr indent="0" marL="0">
+              <a:buNone/>
+            </a:pPr>
+            <a:r>
+              <a:rPr lang="en-US" sz="1700" baseline="30000" dirty="0">
+                <a:solidFill>
+                  <a:srgbClr val="2E3338"/>
+                </a:solidFill>
+                <a:latin typeface="Trade Gothic Next" pitchFamily="34" charset="0"/>
+                <a:ea typeface="Trade Gothic Next" pitchFamily="34" charset="-122"/>
+                <a:cs typeface="Trade Gothic Next" pitchFamily="34" charset="-120"/>
+              </a:rPr>
+              <a:t>2</a:t>
+            </a:r>
+            <a:pPr indent="0" marL="0">
+              <a:buNone/>
+            </a:pPr>
+            <a:r>
+              <a:rPr lang="en-US" sz="1700" dirty="0">
+                <a:solidFill>
+                  <a:srgbClr val="2E3338"/>
+                </a:solidFill>
+                <a:latin typeface="Trade Gothic Next" pitchFamily="34" charset="0"/>
+                <a:ea typeface="Trade Gothic Next" pitchFamily="34" charset="-122"/>
+                <a:cs typeface="Trade Gothic Next" pitchFamily="34" charset="-120"/>
+              </a:rPr>
+              <a:t> for each, and the measurements disagree.</a:t>
             </a:r>
             <a:endParaRPr lang="en-US" sz="1700" dirty="0"/>
           </a:p>
@@ -16007,7 +17233,49 @@
                 <a:ea typeface="Trade Gothic Next" pitchFamily="34" charset="-122"/>
                 <a:cs typeface="Trade Gothic Next" pitchFamily="34" charset="-120"/>
               </a:rPr>
-              <a:t>Actual: [Ar] 4s¹ 3d⁵</a:t>
+              <a:t>Actual: [Ar] 4s</a:t>
+            </a:r>
+            <a:pPr indent="0" marL="0">
+              <a:buNone/>
+            </a:pPr>
+            <a:r>
+              <a:rPr lang="en-US" sz="1600" baseline="30000" dirty="0">
+                <a:solidFill>
+                  <a:srgbClr val="14161B"/>
+                </a:solidFill>
+                <a:latin typeface="Trade Gothic Next" pitchFamily="34" charset="0"/>
+                <a:ea typeface="Trade Gothic Next" pitchFamily="34" charset="-122"/>
+                <a:cs typeface="Trade Gothic Next" pitchFamily="34" charset="-120"/>
+              </a:rPr>
+              <a:t>1</a:t>
+            </a:r>
+            <a:pPr indent="0" marL="0">
+              <a:buNone/>
+            </a:pPr>
+            <a:r>
+              <a:rPr lang="en-US" sz="1600" dirty="0">
+                <a:solidFill>
+                  <a:srgbClr val="14161B"/>
+                </a:solidFill>
+                <a:latin typeface="Trade Gothic Next" pitchFamily="34" charset="0"/>
+                <a:ea typeface="Trade Gothic Next" pitchFamily="34" charset="-122"/>
+                <a:cs typeface="Trade Gothic Next" pitchFamily="34" charset="-120"/>
+              </a:rPr>
+              <a:t> 3d</a:t>
+            </a:r>
+            <a:pPr indent="0" marL="0">
+              <a:buNone/>
+            </a:pPr>
+            <a:r>
+              <a:rPr lang="en-US" sz="1600" baseline="30000" dirty="0">
+                <a:solidFill>
+                  <a:srgbClr val="14161B"/>
+                </a:solidFill>
+                <a:latin typeface="Trade Gothic Next" pitchFamily="34" charset="0"/>
+                <a:ea typeface="Trade Gothic Next" pitchFamily="34" charset="-122"/>
+                <a:cs typeface="Trade Gothic Next" pitchFamily="34" charset="-120"/>
+              </a:rPr>
+              <a:t>5</a:t>
             </a:r>
             <a:endParaRPr lang="en-US" sz="1600" dirty="0"/>
           </a:p>
@@ -16089,7 +17357,49 @@
                 <a:ea typeface="Trade Gothic Next" pitchFamily="34" charset="-122"/>
                 <a:cs typeface="Trade Gothic Next" pitchFamily="34" charset="-120"/>
               </a:rPr>
-              <a:t>Actual: [Ar] 4s¹ 3d¹⁰</a:t>
+              <a:t>Actual: [Ar] 4s</a:t>
+            </a:r>
+            <a:pPr indent="0" marL="0">
+              <a:buNone/>
+            </a:pPr>
+            <a:r>
+              <a:rPr lang="en-US" sz="1600" baseline="30000" dirty="0">
+                <a:solidFill>
+                  <a:srgbClr val="14161B"/>
+                </a:solidFill>
+                <a:latin typeface="Trade Gothic Next" pitchFamily="34" charset="0"/>
+                <a:ea typeface="Trade Gothic Next" pitchFamily="34" charset="-122"/>
+                <a:cs typeface="Trade Gothic Next" pitchFamily="34" charset="-120"/>
+              </a:rPr>
+              <a:t>1</a:t>
+            </a:r>
+            <a:pPr indent="0" marL="0">
+              <a:buNone/>
+            </a:pPr>
+            <a:r>
+              <a:rPr lang="en-US" sz="1600" dirty="0">
+                <a:solidFill>
+                  <a:srgbClr val="14161B"/>
+                </a:solidFill>
+                <a:latin typeface="Trade Gothic Next" pitchFamily="34" charset="0"/>
+                <a:ea typeface="Trade Gothic Next" pitchFamily="34" charset="-122"/>
+                <a:cs typeface="Trade Gothic Next" pitchFamily="34" charset="-120"/>
+              </a:rPr>
+              <a:t> 3d</a:t>
+            </a:r>
+            <a:pPr indent="0" marL="0">
+              <a:buNone/>
+            </a:pPr>
+            <a:r>
+              <a:rPr lang="en-US" sz="1600" baseline="30000" dirty="0">
+                <a:solidFill>
+                  <a:srgbClr val="14161B"/>
+                </a:solidFill>
+                <a:latin typeface="Trade Gothic Next" pitchFamily="34" charset="0"/>
+                <a:ea typeface="Trade Gothic Next" pitchFamily="34" charset="-122"/>
+                <a:cs typeface="Trade Gothic Next" pitchFamily="34" charset="-120"/>
+              </a:rPr>
+              <a:t>10</a:t>
             </a:r>
             <a:endParaRPr lang="en-US" sz="1600" dirty="0"/>
           </a:p>
@@ -16261,7 +17571,7 @@
       </p:sp>
       <p:sp>
         <p:nvSpPr>
-          <p:cNvPr id="13" name="Text 3"/>
+          <p:cNvPr id="14" name="Text 3"/>
           <p:cNvSpPr txBox="1"/>
           <p:nvPr>
             <p:ph idx="106" type="body" hasCustomPrompt="1"/>
@@ -16808,7 +18118,7 @@
       </p:sp>
       <p:sp>
         <p:nvSpPr>
-          <p:cNvPr id="14" name="Text 4"/>
+          <p:cNvPr id="15" name="Text 4"/>
           <p:cNvSpPr txBox="1"/>
           <p:nvPr>
             <p:ph idx="107" hasCustomPrompt="1"/>
@@ -17060,7 +18370,77 @@
                 <a:ea typeface="Trade Gothic Next" pitchFamily="34" charset="-122"/>
                 <a:cs typeface="Trade Gothic Next" pitchFamily="34" charset="-120"/>
               </a:rPr>
-              <a:t>(a) O: 1s² 2s² 2p⁶</a:t>
+              <a:t>(a) O: 1s</a:t>
+            </a:r>
+            <a:pPr indent="0" marL="0">
+              <a:buNone/>
+            </a:pPr>
+            <a:r>
+              <a:rPr lang="en-US" sz="1600" baseline="30000" dirty="0">
+                <a:solidFill>
+                  <a:srgbClr val="14161B"/>
+                </a:solidFill>
+                <a:latin typeface="Trade Gothic Next" pitchFamily="34" charset="0"/>
+                <a:ea typeface="Trade Gothic Next" pitchFamily="34" charset="-122"/>
+                <a:cs typeface="Trade Gothic Next" pitchFamily="34" charset="-120"/>
+              </a:rPr>
+              <a:t>2</a:t>
+            </a:r>
+            <a:pPr indent="0" marL="0">
+              <a:buNone/>
+            </a:pPr>
+            <a:r>
+              <a:rPr lang="en-US" sz="1600" dirty="0">
+                <a:solidFill>
+                  <a:srgbClr val="14161B"/>
+                </a:solidFill>
+                <a:latin typeface="Trade Gothic Next" pitchFamily="34" charset="0"/>
+                <a:ea typeface="Trade Gothic Next" pitchFamily="34" charset="-122"/>
+                <a:cs typeface="Trade Gothic Next" pitchFamily="34" charset="-120"/>
+              </a:rPr>
+              <a:t> 2s</a:t>
+            </a:r>
+            <a:pPr indent="0" marL="0">
+              <a:buNone/>
+            </a:pPr>
+            <a:r>
+              <a:rPr lang="en-US" sz="1600" baseline="30000" dirty="0">
+                <a:solidFill>
+                  <a:srgbClr val="14161B"/>
+                </a:solidFill>
+                <a:latin typeface="Trade Gothic Next" pitchFamily="34" charset="0"/>
+                <a:ea typeface="Trade Gothic Next" pitchFamily="34" charset="-122"/>
+                <a:cs typeface="Trade Gothic Next" pitchFamily="34" charset="-120"/>
+              </a:rPr>
+              <a:t>2</a:t>
+            </a:r>
+            <a:pPr indent="0" marL="0">
+              <a:buNone/>
+            </a:pPr>
+            <a:r>
+              <a:rPr lang="en-US" sz="1600" dirty="0">
+                <a:solidFill>
+                  <a:srgbClr val="14161B"/>
+                </a:solidFill>
+                <a:latin typeface="Trade Gothic Next" pitchFamily="34" charset="0"/>
+                <a:ea typeface="Trade Gothic Next" pitchFamily="34" charset="-122"/>
+                <a:cs typeface="Trade Gothic Next" pitchFamily="34" charset="-120"/>
+              </a:rPr>
+              <a:t> 2p</a:t>
+            </a:r>
+            <a:pPr indent="0" marL="0">
+              <a:buNone/>
+            </a:pPr>
+            <a:r>
+              <a:rPr lang="en-US" sz="1600" baseline="30000" dirty="0">
+                <a:solidFill>
+                  <a:srgbClr val="14161B"/>
+                </a:solidFill>
+                <a:latin typeface="Trade Gothic Next" pitchFamily="34" charset="0"/>
+                <a:ea typeface="Trade Gothic Next" pitchFamily="34" charset="-122"/>
+                <a:cs typeface="Trade Gothic Next" pitchFamily="34" charset="-120"/>
+              </a:rPr>
+              <a:t>6</a:t>
             </a:r>
             <a:endParaRPr lang="en-US" sz="1600" dirty="0"/>
           </a:p>
@@ -17077,7 +18457,21 @@
                 <a:ea typeface="Trade Gothic Next" pitchFamily="34" charset="-122"/>
                 <a:cs typeface="Trade Gothic Next" pitchFamily="34" charset="-120"/>
               </a:rPr>
-              <a:t>(b) K: [Ar] 3d¹</a:t>
+              <a:t>(b) K: [Ar] 3d</a:t>
+            </a:r>
+            <a:pPr indent="0" marL="0">
+              <a:buNone/>
+            </a:pPr>
+            <a:r>
+              <a:rPr lang="en-US" sz="1600" baseline="30000" dirty="0">
+                <a:solidFill>
+                  <a:srgbClr val="14161B"/>
+                </a:solidFill>
+                <a:latin typeface="Trade Gothic Next" pitchFamily="34" charset="0"/>
+                <a:ea typeface="Trade Gothic Next" pitchFamily="34" charset="-122"/>
+                <a:cs typeface="Trade Gothic Next" pitchFamily="34" charset="-120"/>
+              </a:rPr>
+              <a:t>1</a:t>
             </a:r>
             <a:endParaRPr lang="en-US" sz="1600" dirty="0"/>
           </a:p>
@@ -17159,7 +18553,21 @@
                 <a:ea typeface="Trade Gothic Next" pitchFamily="34" charset="-122"/>
                 <a:cs typeface="Trade Gothic Next" pitchFamily="34" charset="-120"/>
               </a:rPr>
-              <a:t>(c) Ca: [Ne] 4s²</a:t>
+              <a:t>(c) Ca: [Ne] 4s</a:t>
+            </a:r>
+            <a:pPr indent="0" marL="0">
+              <a:buNone/>
+            </a:pPr>
+            <a:r>
+              <a:rPr lang="en-US" sz="1600" baseline="30000" dirty="0">
+                <a:solidFill>
+                  <a:srgbClr val="14161B"/>
+                </a:solidFill>
+                <a:latin typeface="Trade Gothic Next" pitchFamily="34" charset="0"/>
+                <a:ea typeface="Trade Gothic Next" pitchFamily="34" charset="-122"/>
+                <a:cs typeface="Trade Gothic Next" pitchFamily="34" charset="-120"/>
+              </a:rPr>
+              <a:t>2</a:t>
             </a:r>
             <a:endParaRPr lang="en-US" sz="1600" dirty="0"/>
           </a:p>
@@ -17176,7 +18584,49 @@
                 <a:ea typeface="Trade Gothic Next" pitchFamily="34" charset="-122"/>
                 <a:cs typeface="Trade Gothic Next" pitchFamily="34" charset="-120"/>
               </a:rPr>
-              <a:t>(d) Cr: [Ar] 4s² 3d⁴</a:t>
+              <a:t>(d) Cr: [Ar] 4s</a:t>
+            </a:r>
+            <a:pPr indent="0" marL="0">
+              <a:buNone/>
+            </a:pPr>
+            <a:r>
+              <a:rPr lang="en-US" sz="1600" baseline="30000" dirty="0">
+                <a:solidFill>
+                  <a:srgbClr val="14161B"/>
+                </a:solidFill>
+                <a:latin typeface="Trade Gothic Next" pitchFamily="34" charset="0"/>
+                <a:ea typeface="Trade Gothic Next" pitchFamily="34" charset="-122"/>
+                <a:cs typeface="Trade Gothic Next" pitchFamily="34" charset="-120"/>
+              </a:rPr>
+              <a:t>2</a:t>
+            </a:r>
+            <a:pPr indent="0" marL="0">
+              <a:buNone/>
+            </a:pPr>
+            <a:r>
+              <a:rPr lang="en-US" sz="1600" dirty="0">
+                <a:solidFill>
+                  <a:srgbClr val="14161B"/>
+                </a:solidFill>
+                <a:latin typeface="Trade Gothic Next" pitchFamily="34" charset="0"/>
+                <a:ea typeface="Trade Gothic Next" pitchFamily="34" charset="-122"/>
+                <a:cs typeface="Trade Gothic Next" pitchFamily="34" charset="-120"/>
+              </a:rPr>
+              <a:t> 3d</a:t>
+            </a:r>
+            <a:pPr indent="0" marL="0">
+              <a:buNone/>
+            </a:pPr>
+            <a:r>
+              <a:rPr lang="en-US" sz="1600" baseline="30000" dirty="0">
+                <a:solidFill>
+                  <a:srgbClr val="14161B"/>
+                </a:solidFill>
+                <a:latin typeface="Trade Gothic Next" pitchFamily="34" charset="0"/>
+                <a:ea typeface="Trade Gothic Next" pitchFamily="34" charset="-122"/>
+                <a:cs typeface="Trade Gothic Next" pitchFamily="34" charset="-120"/>
+              </a:rPr>
+              <a:t>4</a:t>
             </a:r>
             <a:endParaRPr lang="en-US" sz="1600" dirty="0"/>
           </a:p>
@@ -17337,7 +18787,7 @@
       </p:sp>
       <p:sp>
         <p:nvSpPr>
-          <p:cNvPr id="13" name="Text 4"/>
+          <p:cNvPr id="14" name="Text 4"/>
           <p:cNvSpPr txBox="1"/>
           <p:nvPr>
             <p:ph idx="107" hasCustomPrompt="1"/>
@@ -17466,7 +18916,7 @@
                 <a:ea typeface="Trade Gothic Next" pitchFamily="34" charset="-122"/>
                 <a:cs typeface="Trade Gothic Next" pitchFamily="34" charset="-120"/>
               </a:rPr>
-              <a:t>Four different problems, four different checks.</a:t>
+              <a:t>Four problems, four different checks. Each fix is on the right.</a:t>
             </a:r>
             <a:endParaRPr lang="en-US" sz="1700" dirty="0"/>
           </a:p>
@@ -17548,7 +18998,7 @@
                 <a:ea typeface="Trade Gothic Next" pitchFamily="34" charset="-122"/>
                 <a:cs typeface="Trade Gothic Next" pitchFamily="34" charset="-120"/>
               </a:rPr>
-              <a:t>(a) 10 electrons. O has 8.</a:t>
+              <a:t>(a) Count: 10, not 8</a:t>
             </a:r>
             <a:endParaRPr lang="en-US" sz="1600" dirty="0"/>
           </a:p>
@@ -17565,7 +19015,7 @@
                 <a:ea typeface="Trade Gothic Next" pitchFamily="34" charset="-122"/>
                 <a:cs typeface="Trade Gothic Next" pitchFamily="34" charset="-120"/>
               </a:rPr>
-              <a:t>(b) 4s fills before 3d.</a:t>
+              <a:t>(b) Aufbau: 4s first</a:t>
             </a:r>
             <a:endParaRPr lang="en-US" sz="1600" dirty="0"/>
           </a:p>
@@ -17582,7 +19032,7 @@
                 <a:ea typeface="Trade Gothic Next" pitchFamily="34" charset="-122"/>
                 <a:cs typeface="Trade Gothic Next" pitchFamily="34" charset="-120"/>
               </a:rPr>
-              <a:t>(c) [Ne] 4s² totals 12.</a:t>
+              <a:t>(c) Core: needs [Ar]</a:t>
             </a:r>
             <a:endParaRPr lang="en-US" sz="1600" dirty="0"/>
           </a:p>
@@ -17599,7 +19049,7 @@
                 <a:ea typeface="Trade Gothic Next" pitchFamily="34" charset="-122"/>
                 <a:cs typeface="Trade Gothic Next" pitchFamily="34" charset="-120"/>
               </a:rPr>
-              <a:t>(d) Rules fit, atom does not.</a:t>
+              <a:t>(d) Real Cr differs</a:t>
             </a:r>
             <a:endParaRPr lang="en-US" sz="1600" dirty="0"/>
           </a:p>
@@ -17640,7 +19090,7 @@
                 <a:ea typeface="Trade Gothic Next" pitchFamily="34" charset="-122"/>
                 <a:cs typeface="Trade Gothic Next" pitchFamily="34" charset="-120"/>
               </a:rPr>
-              <a:t>Breaks:</a:t>
+              <a:t>Corrected:</a:t>
             </a:r>
             <a:endParaRPr lang="en-US" sz="1900" dirty="0"/>
           </a:p>
@@ -17657,7 +19107,77 @@
                 <a:ea typeface="Trade Gothic Next" pitchFamily="34" charset="-122"/>
                 <a:cs typeface="Trade Gothic Next" pitchFamily="34" charset="-120"/>
               </a:rPr>
-              <a:t>(a) the count</a:t>
+              <a:t>(a) 1s</a:t>
+            </a:r>
+            <a:pPr indent="0" marL="0">
+              <a:buNone/>
+            </a:pPr>
+            <a:r>
+              <a:rPr lang="en-US" sz="1900" baseline="30000" dirty="0">
+                <a:solidFill>
+                  <a:srgbClr val="14161B"/>
+                </a:solidFill>
+                <a:latin typeface="Trade Gothic Next" pitchFamily="34" charset="0"/>
+                <a:ea typeface="Trade Gothic Next" pitchFamily="34" charset="-122"/>
+                <a:cs typeface="Trade Gothic Next" pitchFamily="34" charset="-120"/>
+              </a:rPr>
+              <a:t>2</a:t>
+            </a:r>
+            <a:pPr indent="0" marL="0">
+              <a:buNone/>
+            </a:pPr>
+            <a:r>
+              <a:rPr lang="en-US" sz="1900" dirty="0">
+                <a:solidFill>
+                  <a:srgbClr val="14161B"/>
+                </a:solidFill>
+                <a:latin typeface="Trade Gothic Next" pitchFamily="34" charset="0"/>
+                <a:ea typeface="Trade Gothic Next" pitchFamily="34" charset="-122"/>
+                <a:cs typeface="Trade Gothic Next" pitchFamily="34" charset="-120"/>
+              </a:rPr>
+              <a:t> 2s</a:t>
+            </a:r>
+            <a:pPr indent="0" marL="0">
+              <a:buNone/>
+            </a:pPr>
+            <a:r>
+              <a:rPr lang="en-US" sz="1900" baseline="30000" dirty="0">
+                <a:solidFill>
+                  <a:srgbClr val="14161B"/>
+                </a:solidFill>
+                <a:latin typeface="Trade Gothic Next" pitchFamily="34" charset="0"/>
+                <a:ea typeface="Trade Gothic Next" pitchFamily="34" charset="-122"/>
+                <a:cs typeface="Trade Gothic Next" pitchFamily="34" charset="-120"/>
+              </a:rPr>
+              <a:t>2</a:t>
+            </a:r>
+            <a:pPr indent="0" marL="0">
+              <a:buNone/>
+            </a:pPr>
+            <a:r>
+              <a:rPr lang="en-US" sz="1900" dirty="0">
+                <a:solidFill>
+                  <a:srgbClr val="14161B"/>
+                </a:solidFill>
+                <a:latin typeface="Trade Gothic Next" pitchFamily="34" charset="0"/>
+                <a:ea typeface="Trade Gothic Next" pitchFamily="34" charset="-122"/>
+                <a:cs typeface="Trade Gothic Next" pitchFamily="34" charset="-120"/>
+              </a:rPr>
+              <a:t> 2p</a:t>
+            </a:r>
+            <a:pPr indent="0" marL="0">
+              <a:buNone/>
+            </a:pPr>
+            <a:r>
+              <a:rPr lang="en-US" sz="1900" baseline="30000" dirty="0">
+                <a:solidFill>
+                  <a:srgbClr val="14161B"/>
+                </a:solidFill>
+                <a:latin typeface="Trade Gothic Next" pitchFamily="34" charset="0"/>
+                <a:ea typeface="Trade Gothic Next" pitchFamily="34" charset="-122"/>
+                <a:cs typeface="Trade Gothic Next" pitchFamily="34" charset="-120"/>
+              </a:rPr>
+              <a:t>4</a:t>
             </a:r>
             <a:endParaRPr lang="en-US" sz="1900" dirty="0"/>
           </a:p>
@@ -17674,7 +19194,21 @@
                 <a:ea typeface="Trade Gothic Next" pitchFamily="34" charset="-122"/>
                 <a:cs typeface="Trade Gothic Next" pitchFamily="34" charset="-120"/>
               </a:rPr>
-              <a:t>(b) Aufbau</a:t>
+              <a:t>(b) [Ar] 4s</a:t>
+            </a:r>
+            <a:pPr indent="0" marL="0">
+              <a:buNone/>
+            </a:pPr>
+            <a:r>
+              <a:rPr lang="en-US" sz="1900" baseline="30000" dirty="0">
+                <a:solidFill>
+                  <a:srgbClr val="14161B"/>
+                </a:solidFill>
+                <a:latin typeface="Trade Gothic Next" pitchFamily="34" charset="0"/>
+                <a:ea typeface="Trade Gothic Next" pitchFamily="34" charset="-122"/>
+                <a:cs typeface="Trade Gothic Next" pitchFamily="34" charset="-120"/>
+              </a:rPr>
+              <a:t>1</a:t>
             </a:r>
             <a:endParaRPr lang="en-US" sz="1900" dirty="0"/>
           </a:p>
@@ -17691,7 +19225,21 @@
                 <a:ea typeface="Trade Gothic Next" pitchFamily="34" charset="-122"/>
                 <a:cs typeface="Trade Gothic Next" pitchFamily="34" charset="-120"/>
               </a:rPr>
-              <a:t>(c) the core</a:t>
+              <a:t>(c) [Ar] 4s</a:t>
+            </a:r>
+            <a:pPr indent="0" marL="0">
+              <a:buNone/>
+            </a:pPr>
+            <a:r>
+              <a:rPr lang="en-US" sz="1900" baseline="30000" dirty="0">
+                <a:solidFill>
+                  <a:srgbClr val="14161B"/>
+                </a:solidFill>
+                <a:latin typeface="Trade Gothic Next" pitchFamily="34" charset="0"/>
+                <a:ea typeface="Trade Gothic Next" pitchFamily="34" charset="-122"/>
+                <a:cs typeface="Trade Gothic Next" pitchFamily="34" charset="-120"/>
+              </a:rPr>
+              <a:t>2</a:t>
             </a:r>
             <a:endParaRPr lang="en-US" sz="1900" dirty="0"/>
           </a:p>
@@ -17708,7 +19256,49 @@
                 <a:ea typeface="Trade Gothic Next" pitchFamily="34" charset="-122"/>
                 <a:cs typeface="Trade Gothic Next" pitchFamily="34" charset="-120"/>
               </a:rPr>
-              <a:t>(d) the real Cr</a:t>
+              <a:t>(d) [Ar] 4s</a:t>
+            </a:r>
+            <a:pPr indent="0" marL="0">
+              <a:buNone/>
+            </a:pPr>
+            <a:r>
+              <a:rPr lang="en-US" sz="1900" baseline="30000" dirty="0">
+                <a:solidFill>
+                  <a:srgbClr val="14161B"/>
+                </a:solidFill>
+                <a:latin typeface="Trade Gothic Next" pitchFamily="34" charset="0"/>
+                <a:ea typeface="Trade Gothic Next" pitchFamily="34" charset="-122"/>
+                <a:cs typeface="Trade Gothic Next" pitchFamily="34" charset="-120"/>
+              </a:rPr>
+              <a:t>1</a:t>
+            </a:r>
+            <a:pPr indent="0" marL="0">
+              <a:buNone/>
+            </a:pPr>
+            <a:r>
+              <a:rPr lang="en-US" sz="1900" dirty="0">
+                <a:solidFill>
+                  <a:srgbClr val="14161B"/>
+                </a:solidFill>
+                <a:latin typeface="Trade Gothic Next" pitchFamily="34" charset="0"/>
+                <a:ea typeface="Trade Gothic Next" pitchFamily="34" charset="-122"/>
+                <a:cs typeface="Trade Gothic Next" pitchFamily="34" charset="-120"/>
+              </a:rPr>
+              <a:t> 3d</a:t>
+            </a:r>
+            <a:pPr indent="0" marL="0">
+              <a:buNone/>
+            </a:pPr>
+            <a:r>
+              <a:rPr lang="en-US" sz="1900" baseline="30000" dirty="0">
+                <a:solidFill>
+                  <a:srgbClr val="14161B"/>
+                </a:solidFill>
+                <a:latin typeface="Trade Gothic Next" pitchFamily="34" charset="0"/>
+                <a:ea typeface="Trade Gothic Next" pitchFamily="34" charset="-122"/>
+                <a:cs typeface="Trade Gothic Next" pitchFamily="34" charset="-120"/>
+              </a:rPr>
+              <a:t>5</a:t>
             </a:r>
             <a:endParaRPr lang="en-US" sz="1900" dirty="0"/>
           </a:p>
@@ -17749,7 +19339,63 @@
                 <a:ea typeface="Trade Gothic Next" pitchFamily="34" charset="-122"/>
                 <a:cs typeface="Trade Gothic Next" pitchFamily="34" charset="-120"/>
               </a:rPr>
-              <a:t>Cr follows the rules on paper, but the measured ground state is [Ar] 4s¹ 3d⁵.</a:t>
+              <a:t>Cr follows the rules on paper, but the measured ground state is [Ar] 4s</a:t>
+            </a:r>
+            <a:pPr indent="0" marL="0">
+              <a:buNone/>
+            </a:pPr>
+            <a:r>
+              <a:rPr lang="en-US" sz="1600" b="1" baseline="30000" dirty="0">
+                <a:solidFill>
+                  <a:srgbClr val="EDF0E5"/>
+                </a:solidFill>
+                <a:latin typeface="Trade Gothic Next" pitchFamily="34" charset="0"/>
+                <a:ea typeface="Trade Gothic Next" pitchFamily="34" charset="-122"/>
+                <a:cs typeface="Trade Gothic Next" pitchFamily="34" charset="-120"/>
+              </a:rPr>
+              <a:t>1</a:t>
+            </a:r>
+            <a:pPr indent="0" marL="0">
+              <a:buNone/>
+            </a:pPr>
+            <a:r>
+              <a:rPr lang="en-US" sz="1600" b="1" dirty="0">
+                <a:solidFill>
+                  <a:srgbClr val="EDF0E5"/>
+                </a:solidFill>
+                <a:latin typeface="Trade Gothic Next" pitchFamily="34" charset="0"/>
+                <a:ea typeface="Trade Gothic Next" pitchFamily="34" charset="-122"/>
+                <a:cs typeface="Trade Gothic Next" pitchFamily="34" charset="-120"/>
+              </a:rPr>
+              <a:t> 3d</a:t>
+            </a:r>
+            <a:pPr indent="0" marL="0">
+              <a:buNone/>
+            </a:pPr>
+            <a:r>
+              <a:rPr lang="en-US" sz="1600" b="1" baseline="30000" dirty="0">
+                <a:solidFill>
+                  <a:srgbClr val="EDF0E5"/>
+                </a:solidFill>
+                <a:latin typeface="Trade Gothic Next" pitchFamily="34" charset="0"/>
+                <a:ea typeface="Trade Gothic Next" pitchFamily="34" charset="-122"/>
+                <a:cs typeface="Trade Gothic Next" pitchFamily="34" charset="-120"/>
+              </a:rPr>
+              <a:t>5</a:t>
+            </a:r>
+            <a:pPr indent="0" marL="0">
+              <a:buNone/>
+            </a:pPr>
+            <a:r>
+              <a:rPr lang="en-US" sz="1600" b="1" dirty="0">
+                <a:solidFill>
+                  <a:srgbClr val="EDF0E5"/>
+                </a:solidFill>
+                <a:latin typeface="Trade Gothic Next" pitchFamily="34" charset="0"/>
+                <a:ea typeface="Trade Gothic Next" pitchFamily="34" charset="-122"/>
+                <a:cs typeface="Trade Gothic Next" pitchFamily="34" charset="-120"/>
+              </a:rPr>
+              <a:t>.</a:t>
             </a:r>
             <a:endParaRPr lang="en-US" sz="1600" dirty="0"/>
           </a:p>
@@ -17839,7 +19485,7 @@
       </p:sp>
       <p:sp>
         <p:nvSpPr>
-          <p:cNvPr id="10" name="Text 4"/>
+          <p:cNvPr id="11" name="Text 4"/>
           <p:cNvSpPr txBox="1"/>
           <p:nvPr>
             <p:ph idx="107" hasCustomPrompt="1"/>
@@ -17892,9 +19538,33 @@
           <a:chExt cx="0" cy="0"/>
         </a:xfrm>
       </p:grpSpPr>
-      <p:sp>
-        <p:nvSpPr>
-          <p:cNvPr id="2" name="Text 2"/>
+      <p:pic>
+        <p:nvPicPr>
+          <p:cNvPr id="2" name="Image 0" descr="/home/user/WorkWork/templates/slide/assets/chem_u02_s2.3_spot_diagrams.png">    </p:cNvPr>
+          <p:cNvPicPr>
+            <a:picLocks noChangeAspect="1"/>
+          </p:cNvPicPr>
+          <p:nvPr/>
+        </p:nvPicPr>
+        <p:blipFill>
+          <a:blip r:embed="rId1"/>
+          <a:stretch>
+            <a:fillRect/>
+          </a:stretch>
+        </p:blipFill>
+        <p:spPr>
+          <a:xfrm>
+            <a:off x="914400" y="2651760"/>
+            <a:ext cx="4617720" cy="2743200"/>
+          </a:xfrm>
+          <a:prstGeom prst="rect">
+            <a:avLst/>
+          </a:prstGeom>
+        </p:spPr>
+      </p:pic>
+      <p:sp>
+        <p:nvSpPr>
+          <p:cNvPr id="3" name="Text 2"/>
           <p:cNvSpPr txBox="1"/>
           <p:nvPr>
             <p:ph idx="103" type="title" hasCustomPrompt="1"/>
@@ -17903,7 +19573,7 @@
         <p:spPr>
           <a:xfrm>
             <a:off x="685800" y="932688"/>
-            <a:ext cx="7360920" cy="868680"/>
+            <a:ext cx="10820095" cy="868680"/>
           </a:xfrm>
           <a:prstGeom prst="rect">
             <a:avLst/>
@@ -17927,7 +19597,7 @@
                 <a:ea typeface="Trade Gothic Next" pitchFamily="34" charset="-122"/>
                 <a:cs typeface="Trade Gothic Next" pitchFamily="34" charset="-120"/>
               </a:rPr>
-              <a:t>Check Yourself</a:t>
+              <a:t>Example: Spot the Mistake, Diagrams</a:t>
             </a:r>
             <a:endParaRPr lang="en-US" sz="2800" dirty="0"/>
           </a:p>
@@ -17935,7 +19605,7 @@
       </p:sp>
       <p:sp>
         <p:nvSpPr>
-          <p:cNvPr id="3" name="Text 2"/>
+          <p:cNvPr id="4" name="Text 2"/>
           <p:cNvSpPr txBox="1"/>
           <p:nvPr>
             <p:ph idx="104" type="body" hasCustomPrompt="1"/>
@@ -17944,7 +19614,7 @@
         <p:spPr>
           <a:xfrm>
             <a:off x="685800" y="1847088"/>
-            <a:ext cx="7360920" cy="384048"/>
+            <a:ext cx="10820095" cy="384048"/>
           </a:xfrm>
           <a:prstGeom prst="rect">
             <a:avLst/>
@@ -17968,7 +19638,7 @@
                 <a:ea typeface="Trade Gothic Next" pitchFamily="34" charset="-122"/>
                 <a:cs typeface="Trade Gothic Next" pitchFamily="34" charset="-120"/>
               </a:rPr>
-              <a:t>Work all three in your notes before we compare.</a:t>
+              <a:t>Two orbital diagrams. Each breaks a different rule.</a:t>
             </a:r>
             <a:endParaRPr lang="en-US" sz="1700" dirty="0"/>
           </a:p>
@@ -17976,7 +19646,48 @@
       </p:sp>
       <p:sp>
         <p:nvSpPr>
-          <p:cNvPr id="4" name="Text 5"/>
+          <p:cNvPr id="5" name="Text 4"/>
+          <p:cNvSpPr txBox="1"/>
+          <p:nvPr>
+            <p:ph idx="108" type="body" hasCustomPrompt="1"/>
+          </p:nvPr>
+        </p:nvSpPr>
+        <p:spPr>
+          <a:xfrm>
+            <a:off x="6327648" y="2560320"/>
+            <a:ext cx="5129784" cy="219456"/>
+          </a:xfrm>
+          <a:prstGeom prst="rect">
+            <a:avLst/>
+          </a:prstGeom>
+          <a:noFill/>
+          <a:ln/>
+        </p:spPr>
+        <p:txBody>
+          <a:bodyPr wrap="square" lIns="0" tIns="0" rIns="0" bIns="0" rtlCol="0"/>
+          <a:lstStyle/>
+          <a:p>
+            <a:pPr indent="0" marL="0">
+              <a:buNone/>
+            </a:pPr>
+            <a:r>
+              <a:rPr lang="en-US" sz="1200" b="1" spc="120" kern="0" dirty="0">
+                <a:solidFill>
+                  <a:srgbClr val="2E3338"/>
+                </a:solidFill>
+                <a:latin typeface="Trade Gothic Next" pitchFamily="34" charset="0"/>
+                <a:ea typeface="Trade Gothic Next" pitchFamily="34" charset="-122"/>
+                <a:cs typeface="Trade Gothic Next" pitchFamily="34" charset="-120"/>
+              </a:rPr>
+              <a:t>(E) NITROGEN, Z = 7</a:t>
+            </a:r>
+            <a:endParaRPr lang="en-US" sz="1200" dirty="0"/>
+          </a:p>
+        </p:txBody>
+      </p:sp>
+      <p:sp>
+        <p:nvSpPr>
+          <p:cNvPr id="6" name="Text 4"/>
           <p:cNvSpPr txBox="1"/>
           <p:nvPr>
             <p:ph idx="109" type="body" hasCustomPrompt="1"/>
@@ -17984,8 +19695,8 @@
         </p:nvSpPr>
         <p:spPr>
           <a:xfrm>
-            <a:off x="886968" y="2953512"/>
-            <a:ext cx="2999232" cy="219456"/>
+            <a:off x="6327648" y="2852928"/>
+            <a:ext cx="5129784" cy="329184"/>
           </a:xfrm>
           <a:prstGeom prst="rect">
             <a:avLst/>
@@ -18001,6 +19712,47 @@
               <a:buNone/>
             </a:pPr>
             <a:r>
+              <a:rPr lang="en-US" sz="1600" dirty="0">
+                <a:solidFill>
+                  <a:srgbClr val="14161B"/>
+                </a:solidFill>
+                <a:latin typeface="Trade Gothic Next" pitchFamily="34" charset="0"/>
+                <a:ea typeface="Trade Gothic Next" pitchFamily="34" charset="-122"/>
+                <a:cs typeface="Trade Gothic Next" pitchFamily="34" charset="-120"/>
+              </a:rPr>
+              <a:t>Only the three 2p boxes are drawn.</a:t>
+            </a:r>
+            <a:endParaRPr lang="en-US" sz="1600" dirty="0"/>
+          </a:p>
+        </p:txBody>
+      </p:sp>
+      <p:sp>
+        <p:nvSpPr>
+          <p:cNvPr id="7" name="Text 5"/>
+          <p:cNvSpPr txBox="1"/>
+          <p:nvPr>
+            <p:ph idx="111" type="body" hasCustomPrompt="1"/>
+          </p:nvPr>
+        </p:nvSpPr>
+        <p:spPr>
+          <a:xfrm>
+            <a:off x="6327648" y="3694176"/>
+            <a:ext cx="5129784" cy="219456"/>
+          </a:xfrm>
+          <a:prstGeom prst="rect">
+            <a:avLst/>
+          </a:prstGeom>
+          <a:noFill/>
+          <a:ln/>
+        </p:spPr>
+        <p:txBody>
+          <a:bodyPr wrap="square" lIns="0" tIns="0" rIns="0" bIns="0" rtlCol="0"/>
+          <a:lstStyle/>
+          <a:p>
+            <a:pPr indent="0" marL="0">
+              <a:buNone/>
+            </a:pPr>
+            <a:r>
               <a:rPr lang="en-US" sz="1200" b="1" spc="120" kern="0" dirty="0">
                 <a:solidFill>
                   <a:srgbClr val="2E3338"/>
@@ -18009,7 +19761,7 @@
                 <a:ea typeface="Trade Gothic Next" pitchFamily="34" charset="-122"/>
                 <a:cs typeface="Trade Gothic Next" pitchFamily="34" charset="-120"/>
               </a:rPr>
-              <a:t>PHOSPHORUS, Z = 15</a:t>
+              <a:t>(F) NEON, Z = 10</a:t>
             </a:r>
             <a:endParaRPr lang="en-US" sz="1200" dirty="0"/>
           </a:p>
@@ -18017,16 +19769,16 @@
       </p:sp>
       <p:sp>
         <p:nvSpPr>
-          <p:cNvPr id="5" name="Text 5"/>
-          <p:cNvSpPr txBox="1"/>
-          <p:nvPr>
-            <p:ph idx="110" type="body" hasCustomPrompt="1"/>
-          </p:nvPr>
-        </p:nvSpPr>
-        <p:spPr>
-          <a:xfrm>
-            <a:off x="886968" y="3246120"/>
-            <a:ext cx="2999232" cy="1673352"/>
+          <p:cNvPr id="8" name="Text 5"/>
+          <p:cNvSpPr txBox="1"/>
+          <p:nvPr>
+            <p:ph idx="112" type="body" hasCustomPrompt="1"/>
+          </p:nvPr>
+        </p:nvSpPr>
+        <p:spPr>
+          <a:xfrm>
+            <a:off x="6327648" y="3986784"/>
+            <a:ext cx="5129784" cy="329184"/>
           </a:xfrm>
           <a:prstGeom prst="rect">
             <a:avLst/>
@@ -18050,7 +19802,7 @@
                 <a:ea typeface="Trade Gothic Next" pitchFamily="34" charset="-122"/>
                 <a:cs typeface="Trade Gothic Next" pitchFamily="34" charset="-120"/>
               </a:rPr>
-              <a:t>Write the longhand configuration.</a:t>
+              <a:t>Only the 2s box is drawn.</a:t>
             </a:r>
             <a:endParaRPr lang="en-US" sz="1600" dirty="0"/>
           </a:p>
@@ -18058,16 +19810,16 @@
       </p:sp>
       <p:sp>
         <p:nvSpPr>
-          <p:cNvPr id="6" name="Text 6"/>
-          <p:cNvSpPr txBox="1"/>
-          <p:nvPr>
-            <p:ph idx="112" type="body" hasCustomPrompt="1"/>
-          </p:nvPr>
-        </p:nvSpPr>
-        <p:spPr>
-          <a:xfrm>
-            <a:off x="4498848" y="2953512"/>
-            <a:ext cx="2999232" cy="219456"/>
+          <p:cNvPr id="9" name="Text 6"/>
+          <p:cNvSpPr txBox="1"/>
+          <p:nvPr>
+            <p:ph idx="114" type="body" hasCustomPrompt="1"/>
+          </p:nvPr>
+        </p:nvSpPr>
+        <p:spPr>
+          <a:xfrm>
+            <a:off x="6327648" y="4828032"/>
+            <a:ext cx="5129784" cy="219456"/>
           </a:xfrm>
           <a:prstGeom prst="rect">
             <a:avLst/>
@@ -18091,7 +19843,7 @@
                 <a:ea typeface="Trade Gothic Next" pitchFamily="34" charset="-122"/>
                 <a:cs typeface="Trade Gothic Next" pitchFamily="34" charset="-120"/>
               </a:rPr>
-              <a:t>SULFUR, Z = 16</a:t>
+              <a:t>YOUR JOB</a:t>
             </a:r>
             <a:endParaRPr lang="en-US" sz="1200" dirty="0"/>
           </a:p>
@@ -18099,16 +19851,16 @@
       </p:sp>
       <p:sp>
         <p:nvSpPr>
-          <p:cNvPr id="7" name="Text 6"/>
-          <p:cNvSpPr txBox="1"/>
-          <p:nvPr>
-            <p:ph idx="113" type="body" hasCustomPrompt="1"/>
-          </p:nvPr>
-        </p:nvSpPr>
-        <p:spPr>
-          <a:xfrm>
-            <a:off x="4498848" y="3246120"/>
-            <a:ext cx="2999232" cy="1673352"/>
+          <p:cNvPr id="10" name="Text 6"/>
+          <p:cNvSpPr txBox="1"/>
+          <p:nvPr>
+            <p:ph idx="115" type="body" hasCustomPrompt="1"/>
+          </p:nvPr>
+        </p:nvSpPr>
+        <p:spPr>
+          <a:xfrm>
+            <a:off x="6327648" y="5120640"/>
+            <a:ext cx="5129784" cy="320040"/>
           </a:xfrm>
           <a:prstGeom prst="rect">
             <a:avLst/>
@@ -18132,130 +19884,7 @@
                 <a:ea typeface="Trade Gothic Next" pitchFamily="34" charset="-122"/>
                 <a:cs typeface="Trade Gothic Next" pitchFamily="34" charset="-120"/>
               </a:rPr>
-              <a:t>Write the shorthand and sketch the 3p boxes.</a:t>
-            </a:r>
-            <a:endParaRPr lang="en-US" sz="1600" dirty="0"/>
-          </a:p>
-        </p:txBody>
-      </p:sp>
-      <p:sp>
-        <p:nvSpPr>
-          <p:cNvPr id="8" name="Text 7"/>
-          <p:cNvSpPr txBox="1"/>
-          <p:nvPr>
-            <p:ph idx="115" type="body" hasCustomPrompt="1"/>
-          </p:nvPr>
-        </p:nvSpPr>
-        <p:spPr>
-          <a:xfrm>
-            <a:off x="8110728" y="2953512"/>
-            <a:ext cx="2999232" cy="219456"/>
-          </a:xfrm>
-          <a:prstGeom prst="rect">
-            <a:avLst/>
-          </a:prstGeom>
-          <a:noFill/>
-          <a:ln/>
-        </p:spPr>
-        <p:txBody>
-          <a:bodyPr wrap="square" lIns="0" tIns="0" rIns="0" bIns="0" rtlCol="0"/>
-          <a:lstStyle/>
-          <a:p>
-            <a:pPr indent="0" marL="0">
-              <a:buNone/>
-            </a:pPr>
-            <a:r>
-              <a:rPr lang="en-US" sz="1200" b="1" spc="120" kern="0" dirty="0">
-                <a:solidFill>
-                  <a:srgbClr val="2E3338"/>
-                </a:solidFill>
-                <a:latin typeface="Trade Gothic Next" pitchFamily="34" charset="0"/>
-                <a:ea typeface="Trade Gothic Next" pitchFamily="34" charset="-122"/>
-                <a:cs typeface="Trade Gothic Next" pitchFamily="34" charset="-120"/>
-              </a:rPr>
-              <a:t>COPPER, Z = 29</a:t>
-            </a:r>
-            <a:endParaRPr lang="en-US" sz="1200" dirty="0"/>
-          </a:p>
-        </p:txBody>
-      </p:sp>
-      <p:sp>
-        <p:nvSpPr>
-          <p:cNvPr id="9" name="Text 7"/>
-          <p:cNvSpPr txBox="1"/>
-          <p:nvPr>
-            <p:ph idx="116" type="body" hasCustomPrompt="1"/>
-          </p:nvPr>
-        </p:nvSpPr>
-        <p:spPr>
-          <a:xfrm>
-            <a:off x="8110728" y="3246120"/>
-            <a:ext cx="2999232" cy="1673352"/>
-          </a:xfrm>
-          <a:prstGeom prst="rect">
-            <a:avLst/>
-          </a:prstGeom>
-          <a:noFill/>
-          <a:ln/>
-        </p:spPr>
-        <p:txBody>
-          <a:bodyPr wrap="square" lIns="0" tIns="0" rIns="0" bIns="0" rtlCol="0"/>
-          <a:lstStyle/>
-          <a:p>
-            <a:pPr indent="0" marL="0">
-              <a:buNone/>
-            </a:pPr>
-            <a:r>
-              <a:rPr lang="en-US" sz="1600" dirty="0">
-                <a:solidFill>
-                  <a:srgbClr val="14161B"/>
-                </a:solidFill>
-                <a:latin typeface="Trade Gothic Next" pitchFamily="34" charset="0"/>
-                <a:ea typeface="Trade Gothic Next" pitchFamily="34" charset="-122"/>
-                <a:cs typeface="Trade Gothic Next" pitchFamily="34" charset="-120"/>
-              </a:rPr>
-              <a:t>Write the actual shorthand. Say why it is an exception.</a:t>
-            </a:r>
-            <a:endParaRPr lang="en-US" sz="1600" dirty="0"/>
-          </a:p>
-        </p:txBody>
-      </p:sp>
-      <p:sp>
-        <p:nvSpPr>
-          <p:cNvPr id="10" name="Text 9"/>
-          <p:cNvSpPr txBox="1"/>
-          <p:nvPr>
-            <p:ph idx="119" type="body" hasCustomPrompt="1"/>
-          </p:nvPr>
-        </p:nvSpPr>
-        <p:spPr>
-          <a:xfrm>
-            <a:off x="2240280" y="5486400"/>
-            <a:ext cx="8991295" cy="402336"/>
-          </a:xfrm>
-          <a:prstGeom prst="rect">
-            <a:avLst/>
-          </a:prstGeom>
-          <a:noFill/>
-          <a:ln/>
-        </p:spPr>
-        <p:txBody>
-          <a:bodyPr wrap="square" lIns="0" tIns="0" rIns="0" bIns="0" rtlCol="0" anchor="ctr"/>
-          <a:lstStyle/>
-          <a:p>
-            <a:pPr indent="0" marL="0">
-              <a:buNone/>
-            </a:pPr>
-            <a:r>
-              <a:rPr lang="en-US" sz="1600" b="1" dirty="0">
-                <a:solidFill>
-                  <a:srgbClr val="EDF0E5"/>
-                </a:solidFill>
-                <a:latin typeface="Trade Gothic Next" pitchFamily="34" charset="0"/>
-                <a:ea typeface="Trade Gothic Next" pitchFamily="34" charset="-122"/>
-                <a:cs typeface="Trade Gothic Next" pitchFamily="34" charset="-120"/>
-              </a:rPr>
-              <a:t>Show the electron sum for each one. If it is not Z, find the error.</a:t>
+              <a:t>Name the broken rule. Redraw it correctly.</a:t>
             </a:r>
             <a:endParaRPr lang="en-US" sz="1600" dirty="0"/>
           </a:p>
@@ -18304,10 +19933,10 @@
       </p:sp>
       <p:sp>
         <p:nvSpPr>
-          <p:cNvPr id="12" name="Text 10"/>
-          <p:cNvSpPr txBox="1"/>
-          <p:nvPr>
-            <p:ph idx="121" type="body" hasCustomPrompt="1"/>
+          <p:cNvPr id="12" name="Text 7"/>
+          <p:cNvSpPr txBox="1"/>
+          <p:nvPr>
+            <p:ph idx="117" type="body" hasCustomPrompt="1"/>
           </p:nvPr>
         </p:nvSpPr>
         <p:spPr>
@@ -18345,16 +19974,16 @@
       </p:sp>
       <p:sp>
         <p:nvSpPr>
-          <p:cNvPr id="13" name="Text 4"/>
-          <p:cNvSpPr txBox="1"/>
-          <p:nvPr>
-            <p:ph idx="107" hasCustomPrompt="1"/>
-          </p:nvPr>
-        </p:nvSpPr>
-        <p:spPr>
-          <a:xfrm>
-            <a:off x="8641080" y="1088136"/>
-            <a:ext cx="2633472" cy="1481328"/>
+          <p:cNvPr id="14" name="Text 3"/>
+          <p:cNvSpPr txBox="1"/>
+          <p:nvPr>
+            <p:ph idx="106" type="body" hasCustomPrompt="1"/>
+          </p:nvPr>
+        </p:nvSpPr>
+        <p:spPr>
+          <a:xfrm>
+            <a:off x="914400" y="2651760"/>
+            <a:ext cx="4617720" cy="2743200"/>
           </a:xfrm>
           <a:prstGeom prst="rect">
             <a:avLst/>
@@ -18369,7 +19998,7 @@
             <a:pPr algn="ctr" indent="0" marL="0">
               <a:buNone/>
             </a:pPr>
-            <a:endParaRPr lang="en-US" sz="1200" dirty="0"/>
+            <a:endParaRPr lang="en-US" sz="2000" dirty="0"/>
           </a:p>
         </p:txBody>
       </p:sp>
@@ -18605,7 +20234,7 @@
       </p:sp>
       <p:sp>
         <p:nvSpPr>
-          <p:cNvPr id="7" name="Text 4"/>
+          <p:cNvPr id="8" name="Text 4"/>
           <p:cNvSpPr txBox="1"/>
           <p:nvPr>
             <p:ph idx="104" hasCustomPrompt="1"/>
@@ -18658,6 +20287,970 @@
           <a:chExt cx="0" cy="0"/>
         </a:xfrm>
       </p:grpSpPr>
+      <p:pic>
+        <p:nvPicPr>
+          <p:cNvPr id="2" name="Image 0" descr="/home/user/WorkWork/templates/slide/assets/chem_u02_s2.3_spot_diagrams_fixed.png">    </p:cNvPr>
+          <p:cNvPicPr>
+            <a:picLocks noChangeAspect="1"/>
+          </p:cNvPicPr>
+          <p:nvPr/>
+        </p:nvPicPr>
+        <p:blipFill>
+          <a:blip r:embed="rId1"/>
+          <a:stretch>
+            <a:fillRect/>
+          </a:stretch>
+        </p:blipFill>
+        <p:spPr>
+          <a:xfrm>
+            <a:off x="832104" y="2542032"/>
+            <a:ext cx="3867912" cy="2267712"/>
+          </a:xfrm>
+          <a:prstGeom prst="rect">
+            <a:avLst/>
+          </a:prstGeom>
+        </p:spPr>
+      </p:pic>
+      <p:sp>
+        <p:nvSpPr>
+          <p:cNvPr id="3" name="Text 2"/>
+          <p:cNvSpPr txBox="1"/>
+          <p:nvPr>
+            <p:ph idx="103" type="title" hasCustomPrompt="1"/>
+          </p:nvPr>
+        </p:nvSpPr>
+        <p:spPr>
+          <a:xfrm>
+            <a:off x="685800" y="932688"/>
+            <a:ext cx="10820095" cy="868680"/>
+          </a:xfrm>
+          <a:prstGeom prst="rect">
+            <a:avLst/>
+          </a:prstGeom>
+          <a:noFill/>
+          <a:ln/>
+        </p:spPr>
+        <p:txBody>
+          <a:bodyPr wrap="square" lIns="0" tIns="0" rIns="0" bIns="0" rtlCol="0" anchor="t"/>
+          <a:lstStyle/>
+          <a:p>
+            <a:pPr algn="l" indent="0" marL="0">
+              <a:buNone/>
+            </a:pPr>
+            <a:r>
+              <a:rPr lang="en-US" sz="2800" b="1" dirty="0">
+                <a:solidFill>
+                  <a:srgbClr val="14161B"/>
+                </a:solidFill>
+                <a:latin typeface="Trade Gothic Next" pitchFamily="34" charset="0"/>
+                <a:ea typeface="Trade Gothic Next" pitchFamily="34" charset="-122"/>
+                <a:cs typeface="Trade Gothic Next" pitchFamily="34" charset="-120"/>
+              </a:rPr>
+              <a:t>Spot the Mistake, Diagrams, Worked</a:t>
+            </a:r>
+            <a:endParaRPr lang="en-US" sz="2800" dirty="0"/>
+          </a:p>
+        </p:txBody>
+      </p:sp>
+      <p:sp>
+        <p:nvSpPr>
+          <p:cNvPr id="4" name="Text 2"/>
+          <p:cNvSpPr txBox="1"/>
+          <p:nvPr>
+            <p:ph idx="104" type="body" hasCustomPrompt="1"/>
+          </p:nvPr>
+        </p:nvSpPr>
+        <p:spPr>
+          <a:xfrm>
+            <a:off x="685800" y="1847088"/>
+            <a:ext cx="10820095" cy="384048"/>
+          </a:xfrm>
+          <a:prstGeom prst="rect">
+            <a:avLst/>
+          </a:prstGeom>
+          <a:noFill/>
+          <a:ln/>
+        </p:spPr>
+        <p:txBody>
+          <a:bodyPr wrap="square" lIns="0" tIns="0" rIns="0" bIns="0" rtlCol="0"/>
+          <a:lstStyle/>
+          <a:p>
+            <a:pPr indent="0" marL="0">
+              <a:buNone/>
+            </a:pPr>
+            <a:r>
+              <a:rPr lang="en-US" sz="1700" dirty="0">
+                <a:solidFill>
+                  <a:srgbClr val="2E3338"/>
+                </a:solidFill>
+                <a:latin typeface="Trade Gothic Next" pitchFamily="34" charset="0"/>
+                <a:ea typeface="Trade Gothic Next" pitchFamily="34" charset="-122"/>
+                <a:cs typeface="Trade Gothic Next" pitchFamily="34" charset="-120"/>
+              </a:rPr>
+              <a:t>One Hund error and one Pauli error. The fixes are drawn at left.</a:t>
+            </a:r>
+            <a:endParaRPr lang="en-US" sz="1700" dirty="0"/>
+          </a:p>
+        </p:txBody>
+      </p:sp>
+      <p:sp>
+        <p:nvSpPr>
+          <p:cNvPr id="5" name="Text 5"/>
+          <p:cNvSpPr txBox="1"/>
+          <p:nvPr>
+            <p:ph idx="109" type="body" hasCustomPrompt="1"/>
+          </p:nvPr>
+        </p:nvSpPr>
+        <p:spPr>
+          <a:xfrm>
+            <a:off x="5276088" y="2560320"/>
+            <a:ext cx="2752344" cy="219456"/>
+          </a:xfrm>
+          <a:prstGeom prst="rect">
+            <a:avLst/>
+          </a:prstGeom>
+          <a:noFill/>
+          <a:ln/>
+        </p:spPr>
+        <p:txBody>
+          <a:bodyPr wrap="square" lIns="0" tIns="0" rIns="0" bIns="0" rtlCol="0"/>
+          <a:lstStyle/>
+          <a:p>
+            <a:pPr indent="0" marL="0">
+              <a:buNone/>
+            </a:pPr>
+            <a:r>
+              <a:rPr lang="en-US" sz="1200" b="1" spc="120" kern="0" dirty="0">
+                <a:solidFill>
+                  <a:srgbClr val="2E3338"/>
+                </a:solidFill>
+                <a:latin typeface="Trade Gothic Next" pitchFamily="34" charset="0"/>
+                <a:ea typeface="Trade Gothic Next" pitchFamily="34" charset="-122"/>
+                <a:cs typeface="Trade Gothic Next" pitchFamily="34" charset="-120"/>
+              </a:rPr>
+              <a:t>WHAT IS WRONG</a:t>
+            </a:r>
+            <a:endParaRPr lang="en-US" sz="1200" dirty="0"/>
+          </a:p>
+        </p:txBody>
+      </p:sp>
+      <p:sp>
+        <p:nvSpPr>
+          <p:cNvPr id="6" name="Text 5"/>
+          <p:cNvSpPr txBox="1"/>
+          <p:nvPr>
+            <p:ph idx="110" type="body" hasCustomPrompt="1"/>
+          </p:nvPr>
+        </p:nvSpPr>
+        <p:spPr>
+          <a:xfrm>
+            <a:off x="5276088" y="2852928"/>
+            <a:ext cx="2752344" cy="1901952"/>
+          </a:xfrm>
+          <a:prstGeom prst="rect">
+            <a:avLst/>
+          </a:prstGeom>
+          <a:noFill/>
+          <a:ln/>
+        </p:spPr>
+        <p:txBody>
+          <a:bodyPr wrap="square" lIns="0" tIns="0" rIns="0" bIns="0" rtlCol="0"/>
+          <a:lstStyle/>
+          <a:p>
+            <a:pPr indent="0" marL="0">
+              <a:buNone/>
+            </a:pPr>
+            <a:r>
+              <a:rPr lang="en-US" sz="1600" dirty="0">
+                <a:solidFill>
+                  <a:srgbClr val="14161B"/>
+                </a:solidFill>
+                <a:latin typeface="Trade Gothic Next" pitchFamily="34" charset="0"/>
+                <a:ea typeface="Trade Gothic Next" pitchFamily="34" charset="-122"/>
+                <a:cs typeface="Trade Gothic Next" pitchFamily="34" charset="-120"/>
+              </a:rPr>
+              <a:t>(e) Hund: spins differ</a:t>
+            </a:r>
+            <a:endParaRPr lang="en-US" sz="1600" dirty="0"/>
+          </a:p>
+          <a:p>
+            <a:pPr indent="0" marL="0">
+              <a:buNone/>
+            </a:pPr>
+            <a:r>
+              <a:rPr lang="en-US" sz="1600" dirty="0">
+                <a:solidFill>
+                  <a:srgbClr val="14161B"/>
+                </a:solidFill>
+                <a:latin typeface="Trade Gothic Next" pitchFamily="34" charset="0"/>
+                <a:ea typeface="Trade Gothic Next" pitchFamily="34" charset="-122"/>
+                <a:cs typeface="Trade Gothic Next" pitchFamily="34" charset="-120"/>
+              </a:rPr>
+              <a:t>(f) Pauli: same spin</a:t>
+            </a:r>
+            <a:endParaRPr lang="en-US" sz="1600" dirty="0"/>
+          </a:p>
+        </p:txBody>
+      </p:sp>
+      <p:sp>
+        <p:nvSpPr>
+          <p:cNvPr id="7" name="Text 7"/>
+          <p:cNvSpPr txBox="1"/>
+          <p:nvPr>
+            <p:ph idx="113" type="body" hasCustomPrompt="1"/>
+          </p:nvPr>
+        </p:nvSpPr>
+        <p:spPr>
+          <a:xfrm>
+            <a:off x="8613648" y="2871216"/>
+            <a:ext cx="2688336" cy="1920240"/>
+          </a:xfrm>
+          <a:prstGeom prst="rect">
+            <a:avLst/>
+          </a:prstGeom>
+          <a:noFill/>
+          <a:ln/>
+        </p:spPr>
+        <p:txBody>
+          <a:bodyPr wrap="square" lIns="0" tIns="0" rIns="0" bIns="0" rtlCol="0"/>
+          <a:lstStyle/>
+          <a:p>
+            <a:pPr indent="0" marL="0">
+              <a:buNone/>
+            </a:pPr>
+            <a:r>
+              <a:rPr lang="en-US" sz="1900" dirty="0">
+                <a:solidFill>
+                  <a:srgbClr val="14161B"/>
+                </a:solidFill>
+                <a:latin typeface="Trade Gothic Next" pitchFamily="34" charset="0"/>
+                <a:ea typeface="Trade Gothic Next" pitchFamily="34" charset="-122"/>
+                <a:cs typeface="Trade Gothic Next" pitchFamily="34" charset="-120"/>
+              </a:rPr>
+              <a:t>Fixed:</a:t>
+            </a:r>
+            <a:endParaRPr lang="en-US" sz="1900" dirty="0"/>
+          </a:p>
+          <a:p>
+            <a:pPr indent="0" marL="0">
+              <a:buNone/>
+            </a:pPr>
+            <a:r>
+              <a:rPr lang="en-US" sz="1900" dirty="0">
+                <a:solidFill>
+                  <a:srgbClr val="14161B"/>
+                </a:solidFill>
+                <a:latin typeface="Trade Gothic Next" pitchFamily="34" charset="0"/>
+                <a:ea typeface="Trade Gothic Next" pitchFamily="34" charset="-122"/>
+                <a:cs typeface="Trade Gothic Next" pitchFamily="34" charset="-120"/>
+              </a:rPr>
+              <a:t>(e) 2p: up, up, up</a:t>
+            </a:r>
+            <a:endParaRPr lang="en-US" sz="1900" dirty="0"/>
+          </a:p>
+          <a:p>
+            <a:pPr indent="0" marL="0">
+              <a:buNone/>
+            </a:pPr>
+            <a:r>
+              <a:rPr lang="en-US" sz="1900" dirty="0">
+                <a:solidFill>
+                  <a:srgbClr val="14161B"/>
+                </a:solidFill>
+                <a:latin typeface="Trade Gothic Next" pitchFamily="34" charset="0"/>
+                <a:ea typeface="Trade Gothic Next" pitchFamily="34" charset="-122"/>
+                <a:cs typeface="Trade Gothic Next" pitchFamily="34" charset="-120"/>
+              </a:rPr>
+              <a:t>(f) 2s: up, down</a:t>
+            </a:r>
+            <a:endParaRPr lang="en-US" sz="1900" dirty="0"/>
+          </a:p>
+        </p:txBody>
+      </p:sp>
+      <p:sp>
+        <p:nvSpPr>
+          <p:cNvPr id="8" name="Text 9"/>
+          <p:cNvSpPr txBox="1"/>
+          <p:nvPr>
+            <p:ph idx="116" type="body" hasCustomPrompt="1"/>
+          </p:nvPr>
+        </p:nvSpPr>
+        <p:spPr>
+          <a:xfrm>
+            <a:off x="2240280" y="5212080"/>
+            <a:ext cx="8991295" cy="402336"/>
+          </a:xfrm>
+          <a:prstGeom prst="rect">
+            <a:avLst/>
+          </a:prstGeom>
+          <a:noFill/>
+          <a:ln/>
+        </p:spPr>
+        <p:txBody>
+          <a:bodyPr wrap="square" lIns="0" tIns="0" rIns="0" bIns="0" rtlCol="0" anchor="ctr"/>
+          <a:lstStyle/>
+          <a:p>
+            <a:pPr indent="0" marL="0">
+              <a:buNone/>
+            </a:pPr>
+            <a:r>
+              <a:rPr lang="en-US" sz="1600" b="1" dirty="0">
+                <a:solidFill>
+                  <a:srgbClr val="EDF0E5"/>
+                </a:solidFill>
+                <a:latin typeface="Trade Gothic Next" pitchFamily="34" charset="0"/>
+                <a:ea typeface="Trade Gothic Next" pitchFamily="34" charset="-122"/>
+                <a:cs typeface="Trade Gothic Next" pitchFamily="34" charset="-120"/>
+              </a:rPr>
+              <a:t>Hund: singles first, all spins the same. Pauli: two in one orbital must be opposite.</a:t>
+            </a:r>
+            <a:endParaRPr lang="en-US" sz="1600" dirty="0"/>
+          </a:p>
+        </p:txBody>
+      </p:sp>
+      <p:sp>
+        <p:nvSpPr>
+          <p:cNvPr id="9" name="Text 1"/>
+          <p:cNvSpPr txBox="1"/>
+          <p:nvPr>
+            <p:ph idx="101" type="body" hasCustomPrompt="1"/>
+          </p:nvPr>
+        </p:nvSpPr>
+        <p:spPr>
+          <a:xfrm>
+            <a:off x="685800" y="384048"/>
+            <a:ext cx="6400800" cy="237744"/>
+          </a:xfrm>
+          <a:prstGeom prst="rect">
+            <a:avLst/>
+          </a:prstGeom>
+          <a:noFill/>
+          <a:ln/>
+        </p:spPr>
+        <p:txBody>
+          <a:bodyPr wrap="square" lIns="0" tIns="0" rIns="0" bIns="0" rtlCol="0" anchor="ctr"/>
+          <a:lstStyle/>
+          <a:p>
+            <a:pPr indent="0" marL="0">
+              <a:buNone/>
+            </a:pPr>
+            <a:r>
+              <a:rPr lang="en-US" sz="1100" b="1" spc="160" kern="0" dirty="0">
+                <a:solidFill>
+                  <a:srgbClr val="14161B"/>
+                </a:solidFill>
+                <a:latin typeface="Trade Gothic Next" pitchFamily="34" charset="0"/>
+                <a:ea typeface="Trade Gothic Next" pitchFamily="34" charset="-122"/>
+                <a:cs typeface="Trade Gothic Next" pitchFamily="34" charset="-120"/>
+              </a:rPr>
+              <a:t>UNIT 02  •  CHEMISTRY</a:t>
+            </a:r>
+            <a:endParaRPr lang="en-US" sz="1100" dirty="0"/>
+          </a:p>
+        </p:txBody>
+      </p:sp>
+      <p:sp>
+        <p:nvSpPr>
+          <p:cNvPr id="10" name="Text 10"/>
+          <p:cNvSpPr txBox="1"/>
+          <p:nvPr>
+            <p:ph idx="118" type="body" hasCustomPrompt="1"/>
+          </p:nvPr>
+        </p:nvSpPr>
+        <p:spPr>
+          <a:xfrm>
+            <a:off x="8762695" y="6382512"/>
+            <a:ext cx="2743200" cy="237744"/>
+          </a:xfrm>
+          <a:prstGeom prst="rect">
+            <a:avLst/>
+          </a:prstGeom>
+          <a:noFill/>
+          <a:ln/>
+        </p:spPr>
+        <p:txBody>
+          <a:bodyPr wrap="square" lIns="0" tIns="0" rIns="0" bIns="0" rtlCol="0" anchor="ctr"/>
+          <a:lstStyle/>
+          <a:p>
+            <a:pPr algn="r" indent="0" marL="0">
+              <a:buNone/>
+            </a:pPr>
+            <a:r>
+              <a:rPr lang="en-US" sz="1000" b="1" spc="140" kern="0" dirty="0">
+                <a:solidFill>
+                  <a:srgbClr val="2E3338"/>
+                </a:solidFill>
+                <a:latin typeface="Trade Gothic Next" pitchFamily="34" charset="0"/>
+                <a:ea typeface="Trade Gothic Next" pitchFamily="34" charset="-122"/>
+                <a:cs typeface="Trade Gothic Next" pitchFamily="34" charset="-120"/>
+              </a:rPr>
+              <a:t>U02 • S02.3</a:t>
+            </a:r>
+            <a:endParaRPr lang="en-US" sz="1000" dirty="0"/>
+          </a:p>
+        </p:txBody>
+      </p:sp>
+      <p:sp>
+        <p:nvSpPr>
+          <p:cNvPr id="12" name="Text 4"/>
+          <p:cNvSpPr txBox="1"/>
+          <p:nvPr>
+            <p:ph idx="107" hasCustomPrompt="1"/>
+          </p:nvPr>
+        </p:nvSpPr>
+        <p:spPr>
+          <a:xfrm>
+            <a:off x="832104" y="2542032"/>
+            <a:ext cx="3867912" cy="2267712"/>
+          </a:xfrm>
+          <a:prstGeom prst="rect">
+            <a:avLst/>
+          </a:prstGeom>
+          <a:noFill/>
+          <a:ln/>
+        </p:spPr>
+        <p:txBody>
+          <a:bodyPr wrap="square" lIns="0" tIns="0" rIns="0" bIns="0" rtlCol="0" anchor="ctr"/>
+          <a:lstStyle/>
+          <a:p>
+            <a:pPr algn="ctr" indent="0" marL="0">
+              <a:buNone/>
+            </a:pPr>
+            <a:endParaRPr lang="en-US" sz="1200" dirty="0"/>
+          </a:p>
+        </p:txBody>
+      </p:sp>
+    </p:spTree>
+  </p:cSld>
+  <p:clrMapOvr>
+    <a:masterClrMapping/>
+  </p:clrMapOvr>
+</p:sld>
+</file>
+
+<file path=ppt/slides/slide21.xml><?xml version="1.0" encoding="utf-8"?>
+<p:sld xmlns:a="http://schemas.openxmlformats.org/drawingml/2006/main" xmlns:r="http://schemas.openxmlformats.org/officeDocument/2006/relationships" xmlns:p="http://schemas.openxmlformats.org/presentationml/2006/main">
+  <p:cSld name="Slide 21">
+    <p:spTree>
+      <p:nvGrpSpPr>
+        <p:cNvPr id="1" name=""/>
+        <p:cNvGrpSpPr/>
+        <p:nvPr/>
+      </p:nvGrpSpPr>
+      <p:grpSpPr>
+        <a:xfrm>
+          <a:off x="0" y="0"/>
+          <a:ext cx="0" cy="0"/>
+          <a:chOff x="0" y="0"/>
+          <a:chExt cx="0" cy="0"/>
+        </a:xfrm>
+      </p:grpSpPr>
+      <p:sp>
+        <p:nvSpPr>
+          <p:cNvPr id="2" name="Text 2"/>
+          <p:cNvSpPr txBox="1"/>
+          <p:nvPr>
+            <p:ph idx="103" type="title" hasCustomPrompt="1"/>
+          </p:nvPr>
+        </p:nvSpPr>
+        <p:spPr>
+          <a:xfrm>
+            <a:off x="685800" y="932688"/>
+            <a:ext cx="7360920" cy="868680"/>
+          </a:xfrm>
+          <a:prstGeom prst="rect">
+            <a:avLst/>
+          </a:prstGeom>
+          <a:noFill/>
+          <a:ln/>
+        </p:spPr>
+        <p:txBody>
+          <a:bodyPr wrap="square" lIns="0" tIns="0" rIns="0" bIns="0" rtlCol="0" anchor="t"/>
+          <a:lstStyle/>
+          <a:p>
+            <a:pPr algn="l" indent="0" marL="0">
+              <a:buNone/>
+            </a:pPr>
+            <a:r>
+              <a:rPr lang="en-US" sz="2800" b="1" dirty="0">
+                <a:solidFill>
+                  <a:srgbClr val="14161B"/>
+                </a:solidFill>
+                <a:latin typeface="Trade Gothic Next" pitchFamily="34" charset="0"/>
+                <a:ea typeface="Trade Gothic Next" pitchFamily="34" charset="-122"/>
+                <a:cs typeface="Trade Gothic Next" pitchFamily="34" charset="-120"/>
+              </a:rPr>
+              <a:t>Check Yourself</a:t>
+            </a:r>
+            <a:endParaRPr lang="en-US" sz="2800" dirty="0"/>
+          </a:p>
+        </p:txBody>
+      </p:sp>
+      <p:sp>
+        <p:nvSpPr>
+          <p:cNvPr id="3" name="Text 2"/>
+          <p:cNvSpPr txBox="1"/>
+          <p:nvPr>
+            <p:ph idx="104" type="body" hasCustomPrompt="1"/>
+          </p:nvPr>
+        </p:nvSpPr>
+        <p:spPr>
+          <a:xfrm>
+            <a:off x="685800" y="1847088"/>
+            <a:ext cx="7360920" cy="384048"/>
+          </a:xfrm>
+          <a:prstGeom prst="rect">
+            <a:avLst/>
+          </a:prstGeom>
+          <a:noFill/>
+          <a:ln/>
+        </p:spPr>
+        <p:txBody>
+          <a:bodyPr wrap="square" lIns="0" tIns="0" rIns="0" bIns="0" rtlCol="0"/>
+          <a:lstStyle/>
+          <a:p>
+            <a:pPr indent="0" marL="0">
+              <a:buNone/>
+            </a:pPr>
+            <a:r>
+              <a:rPr lang="en-US" sz="1700" dirty="0">
+                <a:solidFill>
+                  <a:srgbClr val="2E3338"/>
+                </a:solidFill>
+                <a:latin typeface="Trade Gothic Next" pitchFamily="34" charset="0"/>
+                <a:ea typeface="Trade Gothic Next" pitchFamily="34" charset="-122"/>
+                <a:cs typeface="Trade Gothic Next" pitchFamily="34" charset="-120"/>
+              </a:rPr>
+              <a:t>Work all three in your notes before we compare.</a:t>
+            </a:r>
+            <a:endParaRPr lang="en-US" sz="1700" dirty="0"/>
+          </a:p>
+        </p:txBody>
+      </p:sp>
+      <p:sp>
+        <p:nvSpPr>
+          <p:cNvPr id="4" name="Text 5"/>
+          <p:cNvSpPr txBox="1"/>
+          <p:nvPr>
+            <p:ph idx="109" type="body" hasCustomPrompt="1"/>
+          </p:nvPr>
+        </p:nvSpPr>
+        <p:spPr>
+          <a:xfrm>
+            <a:off x="886968" y="2953512"/>
+            <a:ext cx="2999232" cy="219456"/>
+          </a:xfrm>
+          <a:prstGeom prst="rect">
+            <a:avLst/>
+          </a:prstGeom>
+          <a:noFill/>
+          <a:ln/>
+        </p:spPr>
+        <p:txBody>
+          <a:bodyPr wrap="square" lIns="0" tIns="0" rIns="0" bIns="0" rtlCol="0"/>
+          <a:lstStyle/>
+          <a:p>
+            <a:pPr indent="0" marL="0">
+              <a:buNone/>
+            </a:pPr>
+            <a:r>
+              <a:rPr lang="en-US" sz="1200" b="1" spc="120" kern="0" dirty="0">
+                <a:solidFill>
+                  <a:srgbClr val="2E3338"/>
+                </a:solidFill>
+                <a:latin typeface="Trade Gothic Next" pitchFamily="34" charset="0"/>
+                <a:ea typeface="Trade Gothic Next" pitchFamily="34" charset="-122"/>
+                <a:cs typeface="Trade Gothic Next" pitchFamily="34" charset="-120"/>
+              </a:rPr>
+              <a:t>PHOSPHORUS, Z = 15</a:t>
+            </a:r>
+            <a:endParaRPr lang="en-US" sz="1200" dirty="0"/>
+          </a:p>
+        </p:txBody>
+      </p:sp>
+      <p:sp>
+        <p:nvSpPr>
+          <p:cNvPr id="5" name="Text 5"/>
+          <p:cNvSpPr txBox="1"/>
+          <p:nvPr>
+            <p:ph idx="110" type="body" hasCustomPrompt="1"/>
+          </p:nvPr>
+        </p:nvSpPr>
+        <p:spPr>
+          <a:xfrm>
+            <a:off x="886968" y="3246120"/>
+            <a:ext cx="2999232" cy="1673352"/>
+          </a:xfrm>
+          <a:prstGeom prst="rect">
+            <a:avLst/>
+          </a:prstGeom>
+          <a:noFill/>
+          <a:ln/>
+        </p:spPr>
+        <p:txBody>
+          <a:bodyPr wrap="square" lIns="0" tIns="0" rIns="0" bIns="0" rtlCol="0"/>
+          <a:lstStyle/>
+          <a:p>
+            <a:pPr indent="0" marL="0">
+              <a:buNone/>
+            </a:pPr>
+            <a:r>
+              <a:rPr lang="en-US" sz="1600" dirty="0">
+                <a:solidFill>
+                  <a:srgbClr val="14161B"/>
+                </a:solidFill>
+                <a:latin typeface="Trade Gothic Next" pitchFamily="34" charset="0"/>
+                <a:ea typeface="Trade Gothic Next" pitchFamily="34" charset="-122"/>
+                <a:cs typeface="Trade Gothic Next" pitchFamily="34" charset="-120"/>
+              </a:rPr>
+              <a:t>Write the longhand configuration.</a:t>
+            </a:r>
+            <a:endParaRPr lang="en-US" sz="1600" dirty="0"/>
+          </a:p>
+        </p:txBody>
+      </p:sp>
+      <p:sp>
+        <p:nvSpPr>
+          <p:cNvPr id="6" name="Text 6"/>
+          <p:cNvSpPr txBox="1"/>
+          <p:nvPr>
+            <p:ph idx="112" type="body" hasCustomPrompt="1"/>
+          </p:nvPr>
+        </p:nvSpPr>
+        <p:spPr>
+          <a:xfrm>
+            <a:off x="4498848" y="2953512"/>
+            <a:ext cx="2999232" cy="219456"/>
+          </a:xfrm>
+          <a:prstGeom prst="rect">
+            <a:avLst/>
+          </a:prstGeom>
+          <a:noFill/>
+          <a:ln/>
+        </p:spPr>
+        <p:txBody>
+          <a:bodyPr wrap="square" lIns="0" tIns="0" rIns="0" bIns="0" rtlCol="0"/>
+          <a:lstStyle/>
+          <a:p>
+            <a:pPr indent="0" marL="0">
+              <a:buNone/>
+            </a:pPr>
+            <a:r>
+              <a:rPr lang="en-US" sz="1200" b="1" spc="120" kern="0" dirty="0">
+                <a:solidFill>
+                  <a:srgbClr val="2E3338"/>
+                </a:solidFill>
+                <a:latin typeface="Trade Gothic Next" pitchFamily="34" charset="0"/>
+                <a:ea typeface="Trade Gothic Next" pitchFamily="34" charset="-122"/>
+                <a:cs typeface="Trade Gothic Next" pitchFamily="34" charset="-120"/>
+              </a:rPr>
+              <a:t>SULFUR, Z = 16</a:t>
+            </a:r>
+            <a:endParaRPr lang="en-US" sz="1200" dirty="0"/>
+          </a:p>
+        </p:txBody>
+      </p:sp>
+      <p:sp>
+        <p:nvSpPr>
+          <p:cNvPr id="7" name="Text 6"/>
+          <p:cNvSpPr txBox="1"/>
+          <p:nvPr>
+            <p:ph idx="113" type="body" hasCustomPrompt="1"/>
+          </p:nvPr>
+        </p:nvSpPr>
+        <p:spPr>
+          <a:xfrm>
+            <a:off x="4498848" y="3246120"/>
+            <a:ext cx="2999232" cy="1673352"/>
+          </a:xfrm>
+          <a:prstGeom prst="rect">
+            <a:avLst/>
+          </a:prstGeom>
+          <a:noFill/>
+          <a:ln/>
+        </p:spPr>
+        <p:txBody>
+          <a:bodyPr wrap="square" lIns="0" tIns="0" rIns="0" bIns="0" rtlCol="0"/>
+          <a:lstStyle/>
+          <a:p>
+            <a:pPr indent="0" marL="0">
+              <a:buNone/>
+            </a:pPr>
+            <a:r>
+              <a:rPr lang="en-US" sz="1600" dirty="0">
+                <a:solidFill>
+                  <a:srgbClr val="14161B"/>
+                </a:solidFill>
+                <a:latin typeface="Trade Gothic Next" pitchFamily="34" charset="0"/>
+                <a:ea typeface="Trade Gothic Next" pitchFamily="34" charset="-122"/>
+                <a:cs typeface="Trade Gothic Next" pitchFamily="34" charset="-120"/>
+              </a:rPr>
+              <a:t>Write the shorthand and sketch the 3p boxes.</a:t>
+            </a:r>
+            <a:endParaRPr lang="en-US" sz="1600" dirty="0"/>
+          </a:p>
+        </p:txBody>
+      </p:sp>
+      <p:sp>
+        <p:nvSpPr>
+          <p:cNvPr id="8" name="Text 7"/>
+          <p:cNvSpPr txBox="1"/>
+          <p:nvPr>
+            <p:ph idx="115" type="body" hasCustomPrompt="1"/>
+          </p:nvPr>
+        </p:nvSpPr>
+        <p:spPr>
+          <a:xfrm>
+            <a:off x="8110728" y="2953512"/>
+            <a:ext cx="2999232" cy="219456"/>
+          </a:xfrm>
+          <a:prstGeom prst="rect">
+            <a:avLst/>
+          </a:prstGeom>
+          <a:noFill/>
+          <a:ln/>
+        </p:spPr>
+        <p:txBody>
+          <a:bodyPr wrap="square" lIns="0" tIns="0" rIns="0" bIns="0" rtlCol="0"/>
+          <a:lstStyle/>
+          <a:p>
+            <a:pPr indent="0" marL="0">
+              <a:buNone/>
+            </a:pPr>
+            <a:r>
+              <a:rPr lang="en-US" sz="1200" b="1" spc="120" kern="0" dirty="0">
+                <a:solidFill>
+                  <a:srgbClr val="2E3338"/>
+                </a:solidFill>
+                <a:latin typeface="Trade Gothic Next" pitchFamily="34" charset="0"/>
+                <a:ea typeface="Trade Gothic Next" pitchFamily="34" charset="-122"/>
+                <a:cs typeface="Trade Gothic Next" pitchFamily="34" charset="-120"/>
+              </a:rPr>
+              <a:t>COPPER, Z = 29</a:t>
+            </a:r>
+            <a:endParaRPr lang="en-US" sz="1200" dirty="0"/>
+          </a:p>
+        </p:txBody>
+      </p:sp>
+      <p:sp>
+        <p:nvSpPr>
+          <p:cNvPr id="9" name="Text 7"/>
+          <p:cNvSpPr txBox="1"/>
+          <p:nvPr>
+            <p:ph idx="116" type="body" hasCustomPrompt="1"/>
+          </p:nvPr>
+        </p:nvSpPr>
+        <p:spPr>
+          <a:xfrm>
+            <a:off x="8110728" y="3246120"/>
+            <a:ext cx="2999232" cy="1673352"/>
+          </a:xfrm>
+          <a:prstGeom prst="rect">
+            <a:avLst/>
+          </a:prstGeom>
+          <a:noFill/>
+          <a:ln/>
+        </p:spPr>
+        <p:txBody>
+          <a:bodyPr wrap="square" lIns="0" tIns="0" rIns="0" bIns="0" rtlCol="0"/>
+          <a:lstStyle/>
+          <a:p>
+            <a:pPr indent="0" marL="0">
+              <a:buNone/>
+            </a:pPr>
+            <a:r>
+              <a:rPr lang="en-US" sz="1600" dirty="0">
+                <a:solidFill>
+                  <a:srgbClr val="14161B"/>
+                </a:solidFill>
+                <a:latin typeface="Trade Gothic Next" pitchFamily="34" charset="0"/>
+                <a:ea typeface="Trade Gothic Next" pitchFamily="34" charset="-122"/>
+                <a:cs typeface="Trade Gothic Next" pitchFamily="34" charset="-120"/>
+              </a:rPr>
+              <a:t>Write the actual shorthand. Say why it is an exception.</a:t>
+            </a:r>
+            <a:endParaRPr lang="en-US" sz="1600" dirty="0"/>
+          </a:p>
+        </p:txBody>
+      </p:sp>
+      <p:sp>
+        <p:nvSpPr>
+          <p:cNvPr id="10" name="Text 9"/>
+          <p:cNvSpPr txBox="1"/>
+          <p:nvPr>
+            <p:ph idx="119" type="body" hasCustomPrompt="1"/>
+          </p:nvPr>
+        </p:nvSpPr>
+        <p:spPr>
+          <a:xfrm>
+            <a:off x="2240280" y="5486400"/>
+            <a:ext cx="8991295" cy="402336"/>
+          </a:xfrm>
+          <a:prstGeom prst="rect">
+            <a:avLst/>
+          </a:prstGeom>
+          <a:noFill/>
+          <a:ln/>
+        </p:spPr>
+        <p:txBody>
+          <a:bodyPr wrap="square" lIns="0" tIns="0" rIns="0" bIns="0" rtlCol="0" anchor="ctr"/>
+          <a:lstStyle/>
+          <a:p>
+            <a:pPr indent="0" marL="0">
+              <a:buNone/>
+            </a:pPr>
+            <a:r>
+              <a:rPr lang="en-US" sz="1600" b="1" dirty="0">
+                <a:solidFill>
+                  <a:srgbClr val="EDF0E5"/>
+                </a:solidFill>
+                <a:latin typeface="Trade Gothic Next" pitchFamily="34" charset="0"/>
+                <a:ea typeface="Trade Gothic Next" pitchFamily="34" charset="-122"/>
+                <a:cs typeface="Trade Gothic Next" pitchFamily="34" charset="-120"/>
+              </a:rPr>
+              <a:t>Show the electron sum for each one. If it is not Z, find the error.</a:t>
+            </a:r>
+            <a:endParaRPr lang="en-US" sz="1600" dirty="0"/>
+          </a:p>
+        </p:txBody>
+      </p:sp>
+      <p:sp>
+        <p:nvSpPr>
+          <p:cNvPr id="11" name="Text 1"/>
+          <p:cNvSpPr txBox="1"/>
+          <p:nvPr>
+            <p:ph idx="101" type="body" hasCustomPrompt="1"/>
+          </p:nvPr>
+        </p:nvSpPr>
+        <p:spPr>
+          <a:xfrm>
+            <a:off x="685800" y="384048"/>
+            <a:ext cx="6400800" cy="237744"/>
+          </a:xfrm>
+          <a:prstGeom prst="rect">
+            <a:avLst/>
+          </a:prstGeom>
+          <a:noFill/>
+          <a:ln/>
+        </p:spPr>
+        <p:txBody>
+          <a:bodyPr wrap="square" lIns="0" tIns="0" rIns="0" bIns="0" rtlCol="0" anchor="ctr"/>
+          <a:lstStyle/>
+          <a:p>
+            <a:pPr indent="0" marL="0">
+              <a:buNone/>
+            </a:pPr>
+            <a:r>
+              <a:rPr lang="en-US" sz="1100" b="1" spc="160" kern="0" dirty="0">
+                <a:solidFill>
+                  <a:srgbClr val="14161B"/>
+                </a:solidFill>
+                <a:latin typeface="Trade Gothic Next" pitchFamily="34" charset="0"/>
+                <a:ea typeface="Trade Gothic Next" pitchFamily="34" charset="-122"/>
+                <a:cs typeface="Trade Gothic Next" pitchFamily="34" charset="-120"/>
+              </a:rPr>
+              <a:t>UNIT 02  •  CHEMISTRY</a:t>
+            </a:r>
+            <a:endParaRPr lang="en-US" sz="1100" dirty="0"/>
+          </a:p>
+        </p:txBody>
+      </p:sp>
+      <p:sp>
+        <p:nvSpPr>
+          <p:cNvPr id="12" name="Text 10"/>
+          <p:cNvSpPr txBox="1"/>
+          <p:nvPr>
+            <p:ph idx="121" type="body" hasCustomPrompt="1"/>
+          </p:nvPr>
+        </p:nvSpPr>
+        <p:spPr>
+          <a:xfrm>
+            <a:off x="8762695" y="6382512"/>
+            <a:ext cx="2743200" cy="237744"/>
+          </a:xfrm>
+          <a:prstGeom prst="rect">
+            <a:avLst/>
+          </a:prstGeom>
+          <a:noFill/>
+          <a:ln/>
+        </p:spPr>
+        <p:txBody>
+          <a:bodyPr wrap="square" lIns="0" tIns="0" rIns="0" bIns="0" rtlCol="0" anchor="ctr"/>
+          <a:lstStyle/>
+          <a:p>
+            <a:pPr algn="r" indent="0" marL="0">
+              <a:buNone/>
+            </a:pPr>
+            <a:r>
+              <a:rPr lang="en-US" sz="1000" b="1" spc="140" kern="0" dirty="0">
+                <a:solidFill>
+                  <a:srgbClr val="2E3338"/>
+                </a:solidFill>
+                <a:latin typeface="Trade Gothic Next" pitchFamily="34" charset="0"/>
+                <a:ea typeface="Trade Gothic Next" pitchFamily="34" charset="-122"/>
+                <a:cs typeface="Trade Gothic Next" pitchFamily="34" charset="-120"/>
+              </a:rPr>
+              <a:t>U02 • S02.3</a:t>
+            </a:r>
+            <a:endParaRPr lang="en-US" sz="1000" dirty="0"/>
+          </a:p>
+        </p:txBody>
+      </p:sp>
+      <p:sp>
+        <p:nvSpPr>
+          <p:cNvPr id="14" name="Text 4"/>
+          <p:cNvSpPr txBox="1"/>
+          <p:nvPr>
+            <p:ph idx="107" hasCustomPrompt="1"/>
+          </p:nvPr>
+        </p:nvSpPr>
+        <p:spPr>
+          <a:xfrm>
+            <a:off x="8641080" y="1088136"/>
+            <a:ext cx="2633472" cy="1481328"/>
+          </a:xfrm>
+          <a:prstGeom prst="rect">
+            <a:avLst/>
+          </a:prstGeom>
+          <a:noFill/>
+          <a:ln/>
+        </p:spPr>
+        <p:txBody>
+          <a:bodyPr wrap="square" lIns="0" tIns="0" rIns="0" bIns="0" rtlCol="0" anchor="ctr"/>
+          <a:lstStyle/>
+          <a:p>
+            <a:pPr algn="ctr" indent="0" marL="0">
+              <a:buNone/>
+            </a:pPr>
+            <a:endParaRPr lang="en-US" sz="1200" dirty="0"/>
+          </a:p>
+        </p:txBody>
+      </p:sp>
+    </p:spTree>
+  </p:cSld>
+  <p:clrMapOvr>
+    <a:masterClrMapping/>
+  </p:clrMapOvr>
+</p:sld>
+</file>
+
+<file path=ppt/slides/slide22.xml><?xml version="1.0" encoding="utf-8"?>
+<p:sld xmlns:a="http://schemas.openxmlformats.org/drawingml/2006/main" xmlns:r="http://schemas.openxmlformats.org/officeDocument/2006/relationships" xmlns:p="http://schemas.openxmlformats.org/presentationml/2006/main">
+  <p:cSld name="Slide 22">
+    <p:spTree>
+      <p:nvGrpSpPr>
+        <p:cNvPr id="1" name=""/>
+        <p:cNvGrpSpPr/>
+        <p:nvPr/>
+      </p:nvGrpSpPr>
+      <p:grpSpPr>
+        <a:xfrm>
+          <a:off x="0" y="0"/>
+          <a:ext cx="0" cy="0"/>
+          <a:chOff x="0" y="0"/>
+          <a:chExt cx="0" cy="0"/>
+        </a:xfrm>
+      </p:grpSpPr>
       <p:sp>
         <p:nvSpPr>
           <p:cNvPr id="2" name="Text 5"/>
@@ -18847,7 +21440,7 @@
       </p:sp>
       <p:sp>
         <p:nvSpPr>
-          <p:cNvPr id="6" name="Text 2"/>
+          <p:cNvPr id="7" name="Text 2"/>
           <p:cNvSpPr txBox="1"/>
           <p:nvPr>
             <p:ph idx="102" hasCustomPrompt="1"/>
@@ -18976,7 +21569,35 @@
                 <a:ea typeface="Trade Gothic Next" pitchFamily="34" charset="-122"/>
                 <a:cs typeface="Trade Gothic Next" pitchFamily="34" charset="-120"/>
               </a:rPr>
-              <a:t>Take 2p⁴ apart one piece at a time.</a:t>
+              <a:t>Take 2p</a:t>
+            </a:r>
+            <a:pPr indent="0" marL="0">
+              <a:buNone/>
+            </a:pPr>
+            <a:r>
+              <a:rPr lang="en-US" sz="1700" baseline="30000" dirty="0">
+                <a:solidFill>
+                  <a:srgbClr val="2E3338"/>
+                </a:solidFill>
+                <a:latin typeface="Trade Gothic Next" pitchFamily="34" charset="0"/>
+                <a:ea typeface="Trade Gothic Next" pitchFamily="34" charset="-122"/>
+                <a:cs typeface="Trade Gothic Next" pitchFamily="34" charset="-120"/>
+              </a:rPr>
+              <a:t>4</a:t>
+            </a:r>
+            <a:pPr indent="0" marL="0">
+              <a:buNone/>
+            </a:pPr>
+            <a:r>
+              <a:rPr lang="en-US" sz="1700" dirty="0">
+                <a:solidFill>
+                  <a:srgbClr val="2E3338"/>
+                </a:solidFill>
+                <a:latin typeface="Trade Gothic Next" pitchFamily="34" charset="0"/>
+                <a:ea typeface="Trade Gothic Next" pitchFamily="34" charset="-122"/>
+                <a:cs typeface="Trade Gothic Next" pitchFamily="34" charset="-120"/>
+              </a:rPr>
+              <a:t> apart one piece at a time.</a:t>
             </a:r>
             <a:endParaRPr lang="en-US" sz="1700" dirty="0"/>
           </a:p>
@@ -19058,7 +21679,21 @@
                 <a:ea typeface="Trade Gothic Next" pitchFamily="34" charset="-122"/>
                 <a:cs typeface="Trade Gothic Next" pitchFamily="34" charset="-120"/>
               </a:rPr>
-              <a:t>The big number in front.</a:t>
+              <a:t>2p</a:t>
+            </a:r>
+            <a:pPr indent="0" marL="0">
+              <a:buNone/>
+            </a:pPr>
+            <a:r>
+              <a:rPr lang="en-US" sz="1600" baseline="30000" dirty="0">
+                <a:solidFill>
+                  <a:srgbClr val="14161B"/>
+                </a:solidFill>
+                <a:latin typeface="Trade Gothic Next" pitchFamily="34" charset="0"/>
+                <a:ea typeface="Trade Gothic Next" pitchFamily="34" charset="-122"/>
+                <a:cs typeface="Trade Gothic Next" pitchFamily="34" charset="-120"/>
+              </a:rPr>
+              <a:t>4</a:t>
             </a:r>
             <a:endParaRPr lang="en-US" sz="1600" dirty="0"/>
           </a:p>
@@ -19066,12 +21701,6 @@
             <a:pPr indent="0" marL="0">
               <a:buNone/>
             </a:pPr>
-            <a:endParaRPr lang="en-US" sz="1600" dirty="0"/>
-          </a:p>
-          <a:p>
-            <a:pPr indent="0" marL="0">
-              <a:buNone/>
-            </a:pPr>
             <a:r>
               <a:rPr lang="en-US" sz="1600" dirty="0">
                 <a:solidFill>
@@ -19081,7 +21710,7 @@
                 <a:ea typeface="Trade Gothic Next" pitchFamily="34" charset="-122"/>
                 <a:cs typeface="Trade Gothic Next" pitchFamily="34" charset="-120"/>
               </a:rPr>
-              <a:t>2p⁴ is in level 2.</a:t>
+              <a:t>The big number in front is the level: 2.</a:t>
             </a:r>
             <a:endParaRPr lang="en-US" sz="1600" dirty="0"/>
           </a:p>
@@ -19163,7 +21792,21 @@
                 <a:ea typeface="Trade Gothic Next" pitchFamily="34" charset="-122"/>
                 <a:cs typeface="Trade Gothic Next" pitchFamily="34" charset="-120"/>
               </a:rPr>
-              <a:t>The letter: s, p, d, or f.</a:t>
+              <a:t>2p</a:t>
+            </a:r>
+            <a:pPr indent="0" marL="0">
+              <a:buNone/>
+            </a:pPr>
+            <a:r>
+              <a:rPr lang="en-US" sz="1600" baseline="30000" dirty="0">
+                <a:solidFill>
+                  <a:srgbClr val="14161B"/>
+                </a:solidFill>
+                <a:latin typeface="Trade Gothic Next" pitchFamily="34" charset="0"/>
+                <a:ea typeface="Trade Gothic Next" pitchFamily="34" charset="-122"/>
+                <a:cs typeface="Trade Gothic Next" pitchFamily="34" charset="-120"/>
+              </a:rPr>
+              <a:t>4</a:t>
             </a:r>
             <a:endParaRPr lang="en-US" sz="1600" dirty="0"/>
           </a:p>
@@ -19171,12 +21814,6 @@
             <a:pPr indent="0" marL="0">
               <a:buNone/>
             </a:pPr>
-            <a:endParaRPr lang="en-US" sz="1600" dirty="0"/>
-          </a:p>
-          <a:p>
-            <a:pPr indent="0" marL="0">
-              <a:buNone/>
-            </a:pPr>
             <a:r>
               <a:rPr lang="en-US" sz="1600" dirty="0">
                 <a:solidFill>
@@ -19186,7 +21823,7 @@
                 <a:ea typeface="Trade Gothic Next" pitchFamily="34" charset="-122"/>
                 <a:cs typeface="Trade Gothic Next" pitchFamily="34" charset="-120"/>
               </a:rPr>
-              <a:t>2p⁴ is in the p sublevel.</a:t>
+              <a:t>The letter is the sublevel: p.</a:t>
             </a:r>
             <a:endParaRPr lang="en-US" sz="1600" dirty="0"/>
           </a:p>
@@ -19268,7 +21905,21 @@
                 <a:ea typeface="Trade Gothic Next" pitchFamily="34" charset="-122"/>
                 <a:cs typeface="Trade Gothic Next" pitchFamily="34" charset="-120"/>
               </a:rPr>
-              <a:t>The raised number.</a:t>
+              <a:t>2p</a:t>
+            </a:r>
+            <a:pPr indent="0" marL="0">
+              <a:buNone/>
+            </a:pPr>
+            <a:r>
+              <a:rPr lang="en-US" sz="1600" baseline="30000" dirty="0">
+                <a:solidFill>
+                  <a:srgbClr val="14161B"/>
+                </a:solidFill>
+                <a:latin typeface="Trade Gothic Next" pitchFamily="34" charset="0"/>
+                <a:ea typeface="Trade Gothic Next" pitchFamily="34" charset="-122"/>
+                <a:cs typeface="Trade Gothic Next" pitchFamily="34" charset="-120"/>
+              </a:rPr>
+              <a:t>4</a:t>
             </a:r>
             <a:endParaRPr lang="en-US" sz="1600" dirty="0"/>
           </a:p>
@@ -19276,12 +21927,6 @@
             <a:pPr indent="0" marL="0">
               <a:buNone/>
             </a:pPr>
-            <a:endParaRPr lang="en-US" sz="1600" dirty="0"/>
-          </a:p>
-          <a:p>
-            <a:pPr indent="0" marL="0">
-              <a:buNone/>
-            </a:pPr>
             <a:r>
               <a:rPr lang="en-US" sz="1600" dirty="0">
                 <a:solidFill>
@@ -19291,7 +21936,7 @@
                 <a:ea typeface="Trade Gothic Next" pitchFamily="34" charset="-122"/>
                 <a:cs typeface="Trade Gothic Next" pitchFamily="34" charset="-120"/>
               </a:rPr>
-              <a:t>2p⁴ holds 4 electrons.</a:t>
+              <a:t>The raised number is the electron count: 4.</a:t>
             </a:r>
             <a:endParaRPr lang="en-US" sz="1600" dirty="0"/>
           </a:p>
@@ -19422,7 +22067,7 @@
       </p:sp>
       <p:sp>
         <p:nvSpPr>
-          <p:cNvPr id="13" name="Text 4"/>
+          <p:cNvPr id="14" name="Text 4"/>
           <p:cNvSpPr txBox="1"/>
           <p:nvPr>
             <p:ph idx="107" hasCustomPrompt="1"/>
@@ -19911,7 +22556,7 @@
       </p:sp>
       <p:sp>
         <p:nvSpPr>
-          <p:cNvPr id="13" name="Text 3"/>
+          <p:cNvPr id="14" name="Text 3"/>
           <p:cNvSpPr txBox="1"/>
           <p:nvPr>
             <p:ph idx="106" type="body" hasCustomPrompt="1"/>
@@ -20400,7 +23045,7 @@
       </p:sp>
       <p:sp>
         <p:nvSpPr>
-          <p:cNvPr id="13" name="Text 3"/>
+          <p:cNvPr id="14" name="Text 3"/>
           <p:cNvSpPr txBox="1"/>
           <p:nvPr>
             <p:ph idx="106" type="body" hasCustomPrompt="1"/>
@@ -20717,7 +23362,35 @@
                 <a:ea typeface="Trade Gothic Next" pitchFamily="34" charset="-122"/>
                 <a:cs typeface="Trade Gothic Next" pitchFamily="34" charset="-120"/>
               </a:rPr>
-              <a:t>Its 2p³ is three single electrons: 3 unpaired.</a:t>
+              <a:t>Its 2p</a:t>
+            </a:r>
+            <a:pPr indent="0" marL="0">
+              <a:buNone/>
+            </a:pPr>
+            <a:r>
+              <a:rPr lang="en-US" sz="1600" baseline="30000" dirty="0">
+                <a:solidFill>
+                  <a:srgbClr val="14161B"/>
+                </a:solidFill>
+                <a:latin typeface="Trade Gothic Next" pitchFamily="34" charset="0"/>
+                <a:ea typeface="Trade Gothic Next" pitchFamily="34" charset="-122"/>
+                <a:cs typeface="Trade Gothic Next" pitchFamily="34" charset="-120"/>
+              </a:rPr>
+              <a:t>3</a:t>
+            </a:r>
+            <a:pPr indent="0" marL="0">
+              <a:buNone/>
+            </a:pPr>
+            <a:r>
+              <a:rPr lang="en-US" sz="1600" dirty="0">
+                <a:solidFill>
+                  <a:srgbClr val="14161B"/>
+                </a:solidFill>
+                <a:latin typeface="Trade Gothic Next" pitchFamily="34" charset="0"/>
+                <a:ea typeface="Trade Gothic Next" pitchFamily="34" charset="-122"/>
+                <a:cs typeface="Trade Gothic Next" pitchFamily="34" charset="-120"/>
+              </a:rPr>
+              <a:t> is three single electrons: 3 unpaired.</a:t>
             </a:r>
             <a:endParaRPr lang="en-US" sz="1600" dirty="0"/>
           </a:p>
@@ -20889,7 +23562,7 @@
       </p:sp>
       <p:sp>
         <p:nvSpPr>
-          <p:cNvPr id="13" name="Text 3"/>
+          <p:cNvPr id="14" name="Text 3"/>
           <p:cNvSpPr txBox="1"/>
           <p:nvPr>
             <p:ph idx="106" type="body" hasCustomPrompt="1"/>
@@ -21378,7 +24051,7 @@
       </p:sp>
       <p:sp>
         <p:nvSpPr>
-          <p:cNvPr id="13" name="Text 3"/>
+          <p:cNvPr id="14" name="Text 3"/>
           <p:cNvSpPr txBox="1"/>
           <p:nvPr>
             <p:ph idx="106" type="body" hasCustomPrompt="1"/>
@@ -21925,7 +24598,7 @@
       </p:sp>
       <p:sp>
         <p:nvSpPr>
-          <p:cNvPr id="14" name="Text 4"/>
+          <p:cNvPr id="15" name="Text 4"/>
           <p:cNvSpPr txBox="1"/>
           <p:nvPr>
             <p:ph idx="107" hasCustomPrompt="1"/>
@@ -22471,7 +25144,7 @@
       </p:sp>
       <p:sp>
         <p:nvSpPr>
-          <p:cNvPr id="13" name="Text 4"/>
+          <p:cNvPr id="14" name="Text 4"/>
           <p:cNvSpPr txBox="1"/>
           <p:nvPr>
             <p:ph idx="107" hasCustomPrompt="1"/>

</xml_diff>

<commit_message>
S2.3: germanium shorthand sum, decorative arrow alt text, counterexample label; rebuild animated and static decks
Co-Authored-By: Claude Sonnet 5.5 <noreply@anthropic.com>
Claude-Session: https://claude.ai/code/session_01CAqidLLu6PiYNMcZx5qMsE
</commit_message>
<xml_diff>
--- a/deliverables/chem-u02/SHULL_CHEM_Slides_U02_S02.3.pptx
+++ b/deliverables/chem-u02/SHULL_CHEM_Slides_U02_S02.3.pptx
@@ -975,7 +975,7 @@
           </a:p>
           <a:p>
             <a:r>
-              <a:t>CLICK BUILD: 4 clicks: 1 Ge: the longhand line, one text box per segment, and its sum (2+2+6+2+6+2+10+2 = 32) appear; 2 Ge: the first 5 segments (the Ar part, 18 electrons) are highlighted: These 18 electrons are exactly argon's configuration; 3 Ge: the highlighted segments leave and [Ar] appears in their place: The noble gas BEFORE germanium stands in for them, like a substitution in math; 4 Ge: the finished line appears: [Ar] 4s2 3d10 4p2.</a:t>
+              <a:t>CLICK BUILD: 4 clicks: 1 Ge: the longhand line, one text box per segment, and its sum (2+2+6+2+6+2+10+2 = 32) appear; 2 Ge: the first 5 segments (the Ar part, 18 electrons) are highlighted: These 18 electrons are exactly argon's configuration; 3 Ge: the highlighted segments and the longhand sum leave and [Ar] appears in their place: The noble gas BEFORE germanium stands in for them, like a substitution in math; 4 Ge: the finished line appears: [Ar] 4s2 3d10 4p2, with its own sum (18 + 2 + 10 + 2 = 32).</a:t>
             </a:r>
           </a:p>
         </p:txBody>
@@ -1599,7 +1599,7 @@
           <a:p>
             <a:r>
               <a:rPr lang="en-US" dirty="0"/>
-              <a:t>STUDENT LEVEL (simplified; say so out loud): 4s and 3d are very close in energy here. Moving one 4s electron gives a completely filled 3d (Cu) or a half-filled 3d with all five spins parallel (Cr). That lowers the atom's total energy slightly, so the real atom does that. This explains Cr and Cu; it does not predict every exception, and in this course students learn Cr and Cu and look the rest up. Do NOT say that half-full and full are always more stable. TEACHER LEVEL: the near-degeneracy of 4s and 3d is what lets a small energy change decide the arrangement. Textbook accounts cite exchange stabilization (same-spin electrons in different orbitals lower the energy; Cr has six parallel spins) and reduced electron-electron repulsion. PROVISIONAL: the textbook story is simpler than the real energy accounting, which needs electron-correlation calculations; that is why the heuristic fails. COUNTEREXAMPLES (PROVISIONAL: the script checks only that the electron totals are 41 and 74; confirm the configurations against a source before quoting or testing): Nb is [Kr] 5s^1 4d^4, an exception that is not half-full or full; W is the regular [Xe] 6s^2 4f^14 5d^4 although Cr and Mo, in the same group, are exceptions. So the heuristic is not a predictor. Mo, Ag and Au (one period down) are not taught and not checked here. Forward pointer to S2.4: the 4s^1 electron leaves first, so Cu^+ = [Ar] 3d^10 and Cu^2+ = [Ar] 3d^9. Image prompt (aside slot): a coil of copper wire beside a chromium-plated tap on a lab bench.</a:t>
+              <a:t>STUDENT LEVEL (simplified; say so out loud): 4s and 3d are very close in energy here. Moving one 4s electron gives a completely filled 3d (Cu) or a half-filled 3d with all five spins parallel (Cr). That lowers the atom's total energy slightly, so the real atom does that. This explains Cr and Cu; it does not predict every exception, and in this course students learn Cr and Cu and look the rest up. Do NOT say that half-full and full are always more stable. TEACHER LEVEL: the near-degeneracy of 4s and 3d is what lets a small energy change decide the arrangement. Textbook accounts cite exchange stabilization (same-spin electrons in different orbitals lower the energy; Cr has six parallel spins) and reduced electron-electron repulsion. PROVISIONAL: the textbook story is simpler than the real energy accounting, which needs electron-correlation calculations; that is why the heuristic fails. COUNTEREXAMPLES (checked against a secondary dataset, the mendeleev PyPI package, for Cr, Cu, Nb, Mo, W, Ag and Au; NIST was not reachable from here; still PROVISIONAL until Matt or a source confirms. The script itself checks only that the electron totals are 41 and 74): Nb is [Kr] 5s^1 4d^4, an exception that is not half-full or full; W is the regular [Xe] 6s^2 4f^14 5d^4 although Cr and Mo, in the same group, are exceptions. So the heuristic is not a predictor. Mo, Ag and Au (one period down) are not taught and not checked here. Forward pointer to S2.4: the 4s^1 electron leaves first, so Cu^+ = [Ar] 3d^10 and Cu^2+ = [Ar] 3d^9. Image prompt (aside slot): a coil of copper wire beside a chromium-plated tap on a lab bench.</a:t>
             </a:r>
             <a:endParaRPr lang="en-US" dirty="0"/>
           </a:p>
@@ -15451,7 +15451,13 @@
       </p:grpSp>
       <p:sp>
         <p:nvSpPr>
-          <p:cNvPr id="22" name="BUILD arrow 1s box1 up" descr="Up arrow in 1s box 1"/>
+          <p:cNvPr id="22" name="BUILD arrow 1s box1 up" descr="">
+            <a:extLst>
+              <a:ext uri="{C183D7F6-B498-43B3-948B-1728B52AA6E4}">
+                <adec:decorative xmlns:adec="http://schemas.microsoft.com/office/drawing/2017/decorative" val="1"/>
+              </a:ext>
+            </a:extLst>
+          </p:cNvPr>
           <p:cNvSpPr/>
           <p:nvPr/>
         </p:nvSpPr>
@@ -15498,7 +15504,13 @@
       </p:sp>
       <p:sp>
         <p:nvSpPr>
-          <p:cNvPr id="23" name="BUILD arrow 1s box1 down" descr="Down arrow in 1s box 1"/>
+          <p:cNvPr id="23" name="BUILD arrow 1s box1 down" descr="">
+            <a:extLst>
+              <a:ext uri="{C183D7F6-B498-43B3-948B-1728B52AA6E4}">
+                <adec:decorative xmlns:adec="http://schemas.microsoft.com/office/drawing/2017/decorative" val="1"/>
+              </a:ext>
+            </a:extLst>
+          </p:cNvPr>
           <p:cNvSpPr/>
           <p:nvPr/>
         </p:nvSpPr>
@@ -15545,7 +15557,13 @@
       </p:sp>
       <p:sp>
         <p:nvSpPr>
-          <p:cNvPr id="24" name="BUILD arrow 2s box1 up" descr="Up arrow in 2s box 1"/>
+          <p:cNvPr id="24" name="BUILD arrow 2s box1 up" descr="">
+            <a:extLst>
+              <a:ext uri="{C183D7F6-B498-43B3-948B-1728B52AA6E4}">
+                <adec:decorative xmlns:adec="http://schemas.microsoft.com/office/drawing/2017/decorative" val="1"/>
+              </a:ext>
+            </a:extLst>
+          </p:cNvPr>
           <p:cNvSpPr/>
           <p:nvPr/>
         </p:nvSpPr>
@@ -15592,7 +15610,13 @@
       </p:sp>
       <p:sp>
         <p:nvSpPr>
-          <p:cNvPr id="25" name="BUILD arrow 2s box1 down" descr="Down arrow in 2s box 1"/>
+          <p:cNvPr id="25" name="BUILD arrow 2s box1 down" descr="">
+            <a:extLst>
+              <a:ext uri="{C183D7F6-B498-43B3-948B-1728B52AA6E4}">
+                <adec:decorative xmlns:adec="http://schemas.microsoft.com/office/drawing/2017/decorative" val="1"/>
+              </a:ext>
+            </a:extLst>
+          </p:cNvPr>
           <p:cNvSpPr/>
           <p:nvPr/>
         </p:nvSpPr>
@@ -15639,7 +15663,13 @@
       </p:sp>
       <p:sp>
         <p:nvSpPr>
-          <p:cNvPr id="26" name="BUILD arrow 2p box1 up" descr="Up arrow in 2p box 1"/>
+          <p:cNvPr id="26" name="BUILD arrow 2p box1 up" descr="">
+            <a:extLst>
+              <a:ext uri="{C183D7F6-B498-43B3-948B-1728B52AA6E4}">
+                <adec:decorative xmlns:adec="http://schemas.microsoft.com/office/drawing/2017/decorative" val="1"/>
+              </a:ext>
+            </a:extLst>
+          </p:cNvPr>
           <p:cNvSpPr/>
           <p:nvPr/>
         </p:nvSpPr>
@@ -15686,7 +15716,13 @@
       </p:sp>
       <p:sp>
         <p:nvSpPr>
-          <p:cNvPr id="27" name="BUILD arrow 2p box2 up" descr="Up arrow in 2p box 2"/>
+          <p:cNvPr id="27" name="BUILD arrow 2p box2 up" descr="">
+            <a:extLst>
+              <a:ext uri="{C183D7F6-B498-43B3-948B-1728B52AA6E4}">
+                <adec:decorative xmlns:adec="http://schemas.microsoft.com/office/drawing/2017/decorative" val="1"/>
+              </a:ext>
+            </a:extLst>
+          </p:cNvPr>
           <p:cNvSpPr/>
           <p:nvPr/>
         </p:nvSpPr>
@@ -15733,7 +15769,13 @@
       </p:sp>
       <p:sp>
         <p:nvSpPr>
-          <p:cNvPr id="28" name="BUILD arrow 2p box3 up" descr="Up arrow in 2p box 3"/>
+          <p:cNvPr id="28" name="BUILD arrow 2p box3 up" descr="">
+            <a:extLst>
+              <a:ext uri="{C183D7F6-B498-43B3-948B-1728B52AA6E4}">
+                <adec:decorative xmlns:adec="http://schemas.microsoft.com/office/drawing/2017/decorative" val="1"/>
+              </a:ext>
+            </a:extLst>
+          </p:cNvPr>
           <p:cNvSpPr/>
           <p:nvPr/>
         </p:nvSpPr>
@@ -15780,7 +15822,13 @@
       </p:sp>
       <p:sp>
         <p:nvSpPr>
-          <p:cNvPr id="29" name="BUILD arrow 2p box1 down" descr="Down arrow in 2p box 1"/>
+          <p:cNvPr id="29" name="BUILD arrow 2p box1 down" descr="">
+            <a:extLst>
+              <a:ext uri="{C183D7F6-B498-43B3-948B-1728B52AA6E4}">
+                <adec:decorative xmlns:adec="http://schemas.microsoft.com/office/drawing/2017/decorative" val="1"/>
+              </a:ext>
+            </a:extLst>
+          </p:cNvPr>
           <p:cNvSpPr/>
           <p:nvPr/>
         </p:nvSpPr>
@@ -19481,14 +19529,14 @@
       </p:sp>
       <p:sp>
         <p:nvSpPr>
-          <p:cNvPr id="26" name="BUILD caption"/>
+          <p:cNvPr id="26" name="BUILD sum shorthand"/>
           <p:cNvSpPr txBox="1"/>
           <p:nvPr/>
         </p:nvSpPr>
         <p:spPr>
           <a:xfrm>
-            <a:off x="1024128" y="3858768"/>
-            <a:ext cx="4398264" cy="493776"/>
+            <a:off x="1024128" y="3547871"/>
+            <a:ext cx="4398264" cy="274320"/>
           </a:xfrm>
           <a:prstGeom prst="rect">
             <a:avLst/>
@@ -19503,13 +19551,13 @@
           <a:p>
             <a:pPr algn="ctr"/>
             <a:r>
-              <a:rPr sz="1600" b="1">
-                <a:solidFill>
-                  <a:srgbClr val="4D730E"/>
+              <a:rPr sz="1800" b="1">
+                <a:solidFill>
+                  <a:srgbClr val="14161B"/>
                 </a:solidFill>
                 <a:latin typeface="Trade Gothic Next"/>
               </a:rPr>
-              <a:t>These 18 electrons are exactly argon's configuration</a:t>
+              <a:t>18 + 2 + 10 + 2 = 32</a:t>
             </a:r>
           </a:p>
         </p:txBody>
@@ -19522,7 +19570,7 @@
         </p:nvSpPr>
         <p:spPr>
           <a:xfrm>
-            <a:off x="1024128" y="4370831"/>
+            <a:off x="1024128" y="3858768"/>
             <a:ext cx="4398264" cy="493776"/>
           </a:xfrm>
           <a:prstGeom prst="rect">
@@ -19544,21 +19592,21 @@
                 </a:solidFill>
                 <a:latin typeface="Trade Gothic Next"/>
               </a:rPr>
-              <a:t>The noble gas BEFORE germanium stands in for them, like a substitution in math</a:t>
-            </a:r>
-          </a:p>
-        </p:txBody>
-      </p:sp>
-      <p:sp>
-        <p:nvSpPr>
-          <p:cNvPr id="28" name="BUILD result"/>
+              <a:t>These 18 electrons are exactly argon's configuration</a:t>
+            </a:r>
+          </a:p>
+        </p:txBody>
+      </p:sp>
+      <p:sp>
+        <p:nvSpPr>
+          <p:cNvPr id="28" name="BUILD caption"/>
           <p:cNvSpPr txBox="1"/>
           <p:nvPr/>
         </p:nvSpPr>
         <p:spPr>
           <a:xfrm>
-            <a:off x="1024128" y="4919472"/>
-            <a:ext cx="4398264" cy="292608"/>
+            <a:off x="1024128" y="4370831"/>
+            <a:ext cx="4398264" cy="493776"/>
           </a:xfrm>
           <a:prstGeom prst="rect">
             <a:avLst/>
@@ -19573,6 +19621,41 @@
           <a:p>
             <a:pPr algn="ctr"/>
             <a:r>
+              <a:rPr sz="1600" b="1">
+                <a:solidFill>
+                  <a:srgbClr val="4D730E"/>
+                </a:solidFill>
+                <a:latin typeface="Trade Gothic Next"/>
+              </a:rPr>
+              <a:t>The noble gas BEFORE germanium stands in for them, like a substitution in math</a:t>
+            </a:r>
+          </a:p>
+        </p:txBody>
+      </p:sp>
+      <p:sp>
+        <p:nvSpPr>
+          <p:cNvPr id="29" name="BUILD result"/>
+          <p:cNvSpPr txBox="1"/>
+          <p:nvPr/>
+        </p:nvSpPr>
+        <p:spPr>
+          <a:xfrm>
+            <a:off x="1024128" y="4919472"/>
+            <a:ext cx="4398264" cy="292608"/>
+          </a:xfrm>
+          <a:prstGeom prst="rect">
+            <a:avLst/>
+          </a:prstGeom>
+          <a:noFill/>
+        </p:spPr>
+        <p:txBody>
+          <a:bodyPr wrap="square" lIns="0" rIns="0" tIns="0" bIns="0" anchor="ctr">
+            <a:spAutoFit/>
+          </a:bodyPr>
+          <a:lstStyle/>
+          <a:p>
+            <a:pPr algn="ctr"/>
+            <a:r>
               <a:rPr sz="1800" b="1">
                 <a:solidFill>
                   <a:srgbClr val="14161B"/>
@@ -19631,7 +19714,7 @@
       </p:sp>
       <p:sp>
         <p:nvSpPr>
-          <p:cNvPr id="29" name="BUILD Ar bracket"/>
+          <p:cNvPr id="30" name="BUILD Ar bracket"/>
           <p:cNvSpPr txBox="1"/>
           <p:nvPr/>
         </p:nvSpPr>
@@ -20113,7 +20196,7 @@
                                           </p:stCondLst>
                                         </p:cTn>
                                         <p:tgtEl>
-                                          <p:spTgt spid="26"/>
+                                          <p:spTgt spid="27"/>
                                         </p:tgtEl>
                                         <p:attrNameLst>
                                           <p:attrName>style.visibility</p:attrName>
@@ -20127,7 +20210,7 @@
                                       <p:cBhvr>
                                         <p:cTn id="42" dur="400"/>
                                         <p:tgtEl>
-                                          <p:spTgt spid="26"/>
+                                          <p:spTgt spid="27"/>
                                         </p:tgtEl>
                                       </p:cBhvr>
                                     </p:animEffect>
@@ -20363,14 +20446,137 @@
                                 </p:cTn>
                               </p:par>
                               <p:par>
-                                <p:cTn id="63" presetID="10" presetClass="entr" presetSubtype="0" fill="hold" grpId="0" nodeType="withEffect">
+                                <p:cTn id="63" presetID="10" presetClass="exit" presetSubtype="0" fill="hold" grpId="0" nodeType="withEffect">
+                                  <p:stCondLst>
+                                    <p:cond delay="0"/>
+                                  </p:stCondLst>
+                                  <p:childTnLst>
+                                    <p:animEffect transition="out" filter="fade">
+                                      <p:cBhvr>
+                                        <p:cTn id="64" dur="400"/>
+                                        <p:tgtEl>
+                                          <p:spTgt spid="25"/>
+                                        </p:tgtEl>
+                                      </p:cBhvr>
+                                    </p:animEffect>
+                                    <p:set>
+                                      <p:cBhvr>
+                                        <p:cTn id="65" dur="1" fill="hold">
+                                          <p:stCondLst>
+                                            <p:cond delay="399"/>
+                                          </p:stCondLst>
+                                        </p:cTn>
+                                        <p:tgtEl>
+                                          <p:spTgt spid="25"/>
+                                        </p:tgtEl>
+                                        <p:attrNameLst>
+                                          <p:attrName>style.visibility</p:attrName>
+                                        </p:attrNameLst>
+                                      </p:cBhvr>
+                                      <p:to>
+                                        <p:strVal val="hidden"/>
+                                      </p:to>
+                                    </p:set>
+                                  </p:childTnLst>
+                                </p:cTn>
+                              </p:par>
+                              <p:par>
+                                <p:cTn id="66" presetID="10" presetClass="entr" presetSubtype="0" fill="hold" grpId="0" nodeType="withEffect">
                                   <p:stCondLst>
                                     <p:cond delay="0"/>
                                   </p:stCondLst>
                                   <p:childTnLst>
                                     <p:set>
                                       <p:cBhvr>
-                                        <p:cTn id="64" dur="1" fill="hold">
+                                        <p:cTn id="67" dur="1" fill="hold">
+                                          <p:stCondLst>
+                                            <p:cond delay="0"/>
+                                          </p:stCondLst>
+                                        </p:cTn>
+                                        <p:tgtEl>
+                                          <p:spTgt spid="30"/>
+                                        </p:tgtEl>
+                                        <p:attrNameLst>
+                                          <p:attrName>style.visibility</p:attrName>
+                                        </p:attrNameLst>
+                                      </p:cBhvr>
+                                      <p:to>
+                                        <p:strVal val="visible"/>
+                                      </p:to>
+                                    </p:set>
+                                    <p:animEffect transition="in" filter="fade">
+                                      <p:cBhvr>
+                                        <p:cTn id="68" dur="400"/>
+                                        <p:tgtEl>
+                                          <p:spTgt spid="30"/>
+                                        </p:tgtEl>
+                                      </p:cBhvr>
+                                    </p:animEffect>
+                                  </p:childTnLst>
+                                </p:cTn>
+                              </p:par>
+                              <p:par>
+                                <p:cTn id="69" presetID="10" presetClass="entr" presetSubtype="0" fill="hold" grpId="0" nodeType="withEffect">
+                                  <p:stCondLst>
+                                    <p:cond delay="0"/>
+                                  </p:stCondLst>
+                                  <p:childTnLst>
+                                    <p:set>
+                                      <p:cBhvr>
+                                        <p:cTn id="70" dur="1" fill="hold">
+                                          <p:stCondLst>
+                                            <p:cond delay="0"/>
+                                          </p:stCondLst>
+                                        </p:cTn>
+                                        <p:tgtEl>
+                                          <p:spTgt spid="28"/>
+                                        </p:tgtEl>
+                                        <p:attrNameLst>
+                                          <p:attrName>style.visibility</p:attrName>
+                                        </p:attrNameLst>
+                                      </p:cBhvr>
+                                      <p:to>
+                                        <p:strVal val="visible"/>
+                                      </p:to>
+                                    </p:set>
+                                    <p:animEffect transition="in" filter="fade">
+                                      <p:cBhvr>
+                                        <p:cTn id="71" dur="400"/>
+                                        <p:tgtEl>
+                                          <p:spTgt spid="28"/>
+                                        </p:tgtEl>
+                                      </p:cBhvr>
+                                    </p:animEffect>
+                                  </p:childTnLst>
+                                </p:cTn>
+                              </p:par>
+                            </p:childTnLst>
+                          </p:cTn>
+                        </p:par>
+                      </p:childTnLst>
+                    </p:cTn>
+                  </p:par>
+                  <p:par>
+                    <p:cTn id="72" fill="hold">
+                      <p:stCondLst>
+                        <p:cond delay="indefinite"/>
+                      </p:stCondLst>
+                      <p:childTnLst>
+                        <p:par>
+                          <p:cTn id="73" fill="hold">
+                            <p:stCondLst>
+                              <p:cond delay="0"/>
+                            </p:stCondLst>
+                            <p:childTnLst>
+                              <p:par>
+                                <p:cTn id="74" presetID="10" presetClass="entr" presetSubtype="0" fill="hold" grpId="0" nodeType="clickEffect">
+                                  <p:stCondLst>
+                                    <p:cond delay="0"/>
+                                  </p:stCondLst>
+                                  <p:childTnLst>
+                                    <p:set>
+                                      <p:cBhvr>
+                                        <p:cTn id="75" dur="1" fill="hold">
                                           <p:stCondLst>
                                             <p:cond delay="0"/>
                                           </p:stCondLst>
@@ -20388,7 +20594,7 @@
                                     </p:set>
                                     <p:animEffect transition="in" filter="fade">
                                       <p:cBhvr>
-                                        <p:cTn id="65" dur="400"/>
+                                        <p:cTn id="76" dur="400"/>
                                         <p:tgtEl>
                                           <p:spTgt spid="29"/>
                                         </p:tgtEl>
@@ -20398,20 +20604,20 @@
                                 </p:cTn>
                               </p:par>
                               <p:par>
-                                <p:cTn id="66" presetID="10" presetClass="entr" presetSubtype="0" fill="hold" grpId="0" nodeType="withEffect">
+                                <p:cTn id="77" presetID="10" presetClass="entr" presetSubtype="0" fill="hold" grpId="0" nodeType="withEffect">
                                   <p:stCondLst>
                                     <p:cond delay="0"/>
                                   </p:stCondLst>
                                   <p:childTnLst>
                                     <p:set>
                                       <p:cBhvr>
-                                        <p:cTn id="67" dur="1" fill="hold">
+                                        <p:cTn id="78" dur="1" fill="hold">
                                           <p:stCondLst>
                                             <p:cond delay="0"/>
                                           </p:stCondLst>
                                         </p:cTn>
                                         <p:tgtEl>
-                                          <p:spTgt spid="27"/>
+                                          <p:spTgt spid="26"/>
                                         </p:tgtEl>
                                         <p:attrNameLst>
                                           <p:attrName>style.visibility</p:attrName>
@@ -20423,62 +20629,9 @@
                                     </p:set>
                                     <p:animEffect transition="in" filter="fade">
                                       <p:cBhvr>
-                                        <p:cTn id="68" dur="400"/>
+                                        <p:cTn id="79" dur="400"/>
                                         <p:tgtEl>
-                                          <p:spTgt spid="27"/>
-                                        </p:tgtEl>
-                                      </p:cBhvr>
-                                    </p:animEffect>
-                                  </p:childTnLst>
-                                </p:cTn>
-                              </p:par>
-                            </p:childTnLst>
-                          </p:cTn>
-                        </p:par>
-                      </p:childTnLst>
-                    </p:cTn>
-                  </p:par>
-                  <p:par>
-                    <p:cTn id="69" fill="hold">
-                      <p:stCondLst>
-                        <p:cond delay="indefinite"/>
-                      </p:stCondLst>
-                      <p:childTnLst>
-                        <p:par>
-                          <p:cTn id="70" fill="hold">
-                            <p:stCondLst>
-                              <p:cond delay="0"/>
-                            </p:stCondLst>
-                            <p:childTnLst>
-                              <p:par>
-                                <p:cTn id="71" presetID="10" presetClass="entr" presetSubtype="0" fill="hold" grpId="0" nodeType="clickEffect">
-                                  <p:stCondLst>
-                                    <p:cond delay="0"/>
-                                  </p:stCondLst>
-                                  <p:childTnLst>
-                                    <p:set>
-                                      <p:cBhvr>
-                                        <p:cTn id="72" dur="1" fill="hold">
-                                          <p:stCondLst>
-                                            <p:cond delay="0"/>
-                                          </p:stCondLst>
-                                        </p:cTn>
-                                        <p:tgtEl>
-                                          <p:spTgt spid="28"/>
-                                        </p:tgtEl>
-                                        <p:attrNameLst>
-                                          <p:attrName>style.visibility</p:attrName>
-                                        </p:attrNameLst>
-                                      </p:cBhvr>
-                                      <p:to>
-                                        <p:strVal val="visible"/>
-                                      </p:to>
-                                    </p:set>
-                                    <p:animEffect transition="in" filter="fade">
-                                      <p:cBhvr>
-                                        <p:cTn id="73" dur="400"/>
-                                        <p:tgtEl>
-                                          <p:spTgt spid="28"/>
+                                          <p:spTgt spid="26"/>
                                         </p:tgtEl>
                                       </p:cBhvr>
                                     </p:animEffect>
@@ -20524,10 +20677,11 @@
       <p:bldP spid="24" grpId="0"/>
       <p:bldP spid="25" grpId="0"/>
       <p:bldP spid="16" grpId="0" animBg="1"/>
+      <p:bldP spid="27" grpId="0"/>
+      <p:bldP spid="30" grpId="0" animBg="1"/>
+      <p:bldP spid="28" grpId="0"/>
+      <p:bldP spid="29" grpId="0"/>
       <p:bldP spid="26" grpId="0"/>
-      <p:bldP spid="29" grpId="0" animBg="1"/>
-      <p:bldP spid="27" grpId="0"/>
-      <p:bldP spid="28" grpId="0"/>
     </p:bldLst>
   </p:timing>
 </p:sld>
@@ -22702,7 +22856,13 @@
       </p:grpSp>
       <p:sp>
         <p:nvSpPr>
-          <p:cNvPr id="22" name="BUILD arrow 4s box1 up" descr="Up arrow in 4s box 1"/>
+          <p:cNvPr id="22" name="BUILD arrow 4s box1 up" descr="">
+            <a:extLst>
+              <a:ext uri="{C183D7F6-B498-43B3-948B-1728B52AA6E4}">
+                <adec:decorative xmlns:adec="http://schemas.microsoft.com/office/drawing/2017/decorative" val="1"/>
+              </a:ext>
+            </a:extLst>
+          </p:cNvPr>
           <p:cNvSpPr/>
           <p:nvPr/>
         </p:nvSpPr>
@@ -22749,7 +22909,13 @@
       </p:sp>
       <p:sp>
         <p:nvSpPr>
-          <p:cNvPr id="23" name="BUILD arrow 4s box1 down" descr="Down arrow in 4s box 1"/>
+          <p:cNvPr id="23" name="BUILD arrow 4s box1 down" descr="">
+            <a:extLst>
+              <a:ext uri="{C183D7F6-B498-43B3-948B-1728B52AA6E4}">
+                <adec:decorative xmlns:adec="http://schemas.microsoft.com/office/drawing/2017/decorative" val="1"/>
+              </a:ext>
+            </a:extLst>
+          </p:cNvPr>
           <p:cNvSpPr/>
           <p:nvPr/>
         </p:nvSpPr>
@@ -22796,7 +22962,13 @@
       </p:sp>
       <p:sp>
         <p:nvSpPr>
-          <p:cNvPr id="24" name="BUILD arrow 3d box1 up" descr="Up arrow in 3d box 1"/>
+          <p:cNvPr id="24" name="BUILD arrow 3d box1 up" descr="">
+            <a:extLst>
+              <a:ext uri="{C183D7F6-B498-43B3-948B-1728B52AA6E4}">
+                <adec:decorative xmlns:adec="http://schemas.microsoft.com/office/drawing/2017/decorative" val="1"/>
+              </a:ext>
+            </a:extLst>
+          </p:cNvPr>
           <p:cNvSpPr/>
           <p:nvPr/>
         </p:nvSpPr>
@@ -22843,7 +23015,13 @@
       </p:sp>
       <p:sp>
         <p:nvSpPr>
-          <p:cNvPr id="25" name="BUILD arrow 3d box2 up" descr="Up arrow in 3d box 2"/>
+          <p:cNvPr id="25" name="BUILD arrow 3d box2 up" descr="">
+            <a:extLst>
+              <a:ext uri="{C183D7F6-B498-43B3-948B-1728B52AA6E4}">
+                <adec:decorative xmlns:adec="http://schemas.microsoft.com/office/drawing/2017/decorative" val="1"/>
+              </a:ext>
+            </a:extLst>
+          </p:cNvPr>
           <p:cNvSpPr/>
           <p:nvPr/>
         </p:nvSpPr>
@@ -22890,7 +23068,13 @@
       </p:sp>
       <p:sp>
         <p:nvSpPr>
-          <p:cNvPr id="26" name="BUILD arrow 3d box3 up" descr="Up arrow in 3d box 3"/>
+          <p:cNvPr id="26" name="BUILD arrow 3d box3 up" descr="">
+            <a:extLst>
+              <a:ext uri="{C183D7F6-B498-43B3-948B-1728B52AA6E4}">
+                <adec:decorative xmlns:adec="http://schemas.microsoft.com/office/drawing/2017/decorative" val="1"/>
+              </a:ext>
+            </a:extLst>
+          </p:cNvPr>
           <p:cNvSpPr/>
           <p:nvPr/>
         </p:nvSpPr>
@@ -22937,7 +23121,13 @@
       </p:sp>
       <p:sp>
         <p:nvSpPr>
-          <p:cNvPr id="27" name="BUILD arrow 3d box4 up" descr="Up arrow in 3d box 4"/>
+          <p:cNvPr id="27" name="BUILD arrow 3d box4 up" descr="">
+            <a:extLst>
+              <a:ext uri="{C183D7F6-B498-43B3-948B-1728B52AA6E4}">
+                <adec:decorative xmlns:adec="http://schemas.microsoft.com/office/drawing/2017/decorative" val="1"/>
+              </a:ext>
+            </a:extLst>
+          </p:cNvPr>
           <p:cNvSpPr/>
           <p:nvPr/>
         </p:nvSpPr>
@@ -22984,7 +23174,13 @@
       </p:sp>
       <p:sp>
         <p:nvSpPr>
-          <p:cNvPr id="28" name="BUILD arrow 3d box5 up" descr="Up arrow in 3d box 5"/>
+          <p:cNvPr id="28" name="BUILD arrow 3d box5 up" descr="">
+            <a:extLst>
+              <a:ext uri="{C183D7F6-B498-43B3-948B-1728B52AA6E4}">
+                <adec:decorative xmlns:adec="http://schemas.microsoft.com/office/drawing/2017/decorative" val="1"/>
+              </a:ext>
+            </a:extLst>
+          </p:cNvPr>
           <p:cNvSpPr/>
           <p:nvPr/>
         </p:nvSpPr>
@@ -23031,7 +23227,13 @@
       </p:sp>
       <p:sp>
         <p:nvSpPr>
-          <p:cNvPr id="29" name="BUILD arrow 3d box1 down" descr="Down arrow in 3d box 1"/>
+          <p:cNvPr id="29" name="BUILD arrow 3d box1 down" descr="">
+            <a:extLst>
+              <a:ext uri="{C183D7F6-B498-43B3-948B-1728B52AA6E4}">
+                <adec:decorative xmlns:adec="http://schemas.microsoft.com/office/drawing/2017/decorative" val="1"/>
+              </a:ext>
+            </a:extLst>
+          </p:cNvPr>
           <p:cNvSpPr/>
           <p:nvPr/>
         </p:nvSpPr>
@@ -25061,7 +25263,13 @@
       </p:grpSp>
       <p:sp>
         <p:nvSpPr>
-          <p:cNvPr id="24" name="BUILD arrow 4s box1 up" descr="Up arrow in 4s box 1"/>
+          <p:cNvPr id="24" name="BUILD arrow 4s box1 up" descr="">
+            <a:extLst>
+              <a:ext uri="{C183D7F6-B498-43B3-948B-1728B52AA6E4}">
+                <adec:decorative xmlns:adec="http://schemas.microsoft.com/office/drawing/2017/decorative" val="1"/>
+              </a:ext>
+            </a:extLst>
+          </p:cNvPr>
           <p:cNvSpPr/>
           <p:nvPr/>
         </p:nvSpPr>
@@ -25108,7 +25316,13 @@
       </p:sp>
       <p:sp>
         <p:nvSpPr>
-          <p:cNvPr id="25" name="BUILD arrow 4s box1 down" descr="Down arrow in 4s box 1"/>
+          <p:cNvPr id="25" name="BUILD arrow 4s box1 down" descr="">
+            <a:extLst>
+              <a:ext uri="{C183D7F6-B498-43B3-948B-1728B52AA6E4}">
+                <adec:decorative xmlns:adec="http://schemas.microsoft.com/office/drawing/2017/decorative" val="1"/>
+              </a:ext>
+            </a:extLst>
+          </p:cNvPr>
           <p:cNvSpPr/>
           <p:nvPr/>
         </p:nvSpPr>
@@ -25155,7 +25369,13 @@
       </p:sp>
       <p:sp>
         <p:nvSpPr>
-          <p:cNvPr id="26" name="BUILD arrow 3d box1 up" descr="Up arrow in 3d box 1"/>
+          <p:cNvPr id="26" name="BUILD arrow 3d box1 up" descr="">
+            <a:extLst>
+              <a:ext uri="{C183D7F6-B498-43B3-948B-1728B52AA6E4}">
+                <adec:decorative xmlns:adec="http://schemas.microsoft.com/office/drawing/2017/decorative" val="1"/>
+              </a:ext>
+            </a:extLst>
+          </p:cNvPr>
           <p:cNvSpPr/>
           <p:nvPr/>
         </p:nvSpPr>
@@ -25202,7 +25422,13 @@
       </p:sp>
       <p:sp>
         <p:nvSpPr>
-          <p:cNvPr id="27" name="BUILD arrow 3d box2 up" descr="Up arrow in 3d box 2"/>
+          <p:cNvPr id="27" name="BUILD arrow 3d box2 up" descr="">
+            <a:extLst>
+              <a:ext uri="{C183D7F6-B498-43B3-948B-1728B52AA6E4}">
+                <adec:decorative xmlns:adec="http://schemas.microsoft.com/office/drawing/2017/decorative" val="1"/>
+              </a:ext>
+            </a:extLst>
+          </p:cNvPr>
           <p:cNvSpPr/>
           <p:nvPr/>
         </p:nvSpPr>
@@ -25249,7 +25475,13 @@
       </p:sp>
       <p:sp>
         <p:nvSpPr>
-          <p:cNvPr id="28" name="BUILD arrow 3d box3 up" descr="Up arrow in 3d box 3"/>
+          <p:cNvPr id="28" name="BUILD arrow 3d box3 up" descr="">
+            <a:extLst>
+              <a:ext uri="{C183D7F6-B498-43B3-948B-1728B52AA6E4}">
+                <adec:decorative xmlns:adec="http://schemas.microsoft.com/office/drawing/2017/decorative" val="1"/>
+              </a:ext>
+            </a:extLst>
+          </p:cNvPr>
           <p:cNvSpPr/>
           <p:nvPr/>
         </p:nvSpPr>
@@ -25296,7 +25528,13 @@
       </p:sp>
       <p:sp>
         <p:nvSpPr>
-          <p:cNvPr id="29" name="BUILD arrow 3d box4 up" descr="Up arrow in 3d box 4"/>
+          <p:cNvPr id="29" name="BUILD arrow 3d box4 up" descr="">
+            <a:extLst>
+              <a:ext uri="{C183D7F6-B498-43B3-948B-1728B52AA6E4}">
+                <adec:decorative xmlns:adec="http://schemas.microsoft.com/office/drawing/2017/decorative" val="1"/>
+              </a:ext>
+            </a:extLst>
+          </p:cNvPr>
           <p:cNvSpPr/>
           <p:nvPr/>
         </p:nvSpPr>
@@ -25343,7 +25581,13 @@
       </p:sp>
       <p:sp>
         <p:nvSpPr>
-          <p:cNvPr id="30" name="BUILD arrow 3d box5 up" descr="Up arrow in 3d box 5"/>
+          <p:cNvPr id="30" name="BUILD arrow 3d box5 up" descr="">
+            <a:extLst>
+              <a:ext uri="{C183D7F6-B498-43B3-948B-1728B52AA6E4}">
+                <adec:decorative xmlns:adec="http://schemas.microsoft.com/office/drawing/2017/decorative" val="1"/>
+              </a:ext>
+            </a:extLst>
+          </p:cNvPr>
           <p:cNvSpPr/>
           <p:nvPr/>
         </p:nvSpPr>
@@ -25390,7 +25634,13 @@
       </p:sp>
       <p:sp>
         <p:nvSpPr>
-          <p:cNvPr id="31" name="BUILD arrow 3d box1 down" descr="Down arrow in 3d box 1"/>
+          <p:cNvPr id="31" name="BUILD arrow 3d box1 down" descr="">
+            <a:extLst>
+              <a:ext uri="{C183D7F6-B498-43B3-948B-1728B52AA6E4}">
+                <adec:decorative xmlns:adec="http://schemas.microsoft.com/office/drawing/2017/decorative" val="1"/>
+              </a:ext>
+            </a:extLst>
+          </p:cNvPr>
           <p:cNvSpPr/>
           <p:nvPr/>
         </p:nvSpPr>
@@ -25437,7 +25687,13 @@
       </p:sp>
       <p:sp>
         <p:nvSpPr>
-          <p:cNvPr id="32" name="BUILD arrow 3d box2 down" descr="Down arrow in 3d box 2"/>
+          <p:cNvPr id="32" name="BUILD arrow 3d box2 down" descr="">
+            <a:extLst>
+              <a:ext uri="{C183D7F6-B498-43B3-948B-1728B52AA6E4}">
+                <adec:decorative xmlns:adec="http://schemas.microsoft.com/office/drawing/2017/decorative" val="1"/>
+              </a:ext>
+            </a:extLst>
+          </p:cNvPr>
           <p:cNvSpPr/>
           <p:nvPr/>
         </p:nvSpPr>
@@ -25484,7 +25740,13 @@
       </p:sp>
       <p:sp>
         <p:nvSpPr>
-          <p:cNvPr id="33" name="BUILD arrow 3d box3 down" descr="Down arrow in 3d box 3"/>
+          <p:cNvPr id="33" name="BUILD arrow 3d box3 down" descr="">
+            <a:extLst>
+              <a:ext uri="{C183D7F6-B498-43B3-948B-1728B52AA6E4}">
+                <adec:decorative xmlns:adec="http://schemas.microsoft.com/office/drawing/2017/decorative" val="1"/>
+              </a:ext>
+            </a:extLst>
+          </p:cNvPr>
           <p:cNvSpPr/>
           <p:nvPr/>
         </p:nvSpPr>
@@ -25531,7 +25793,13 @@
       </p:sp>
       <p:sp>
         <p:nvSpPr>
-          <p:cNvPr id="34" name="BUILD arrow 3d box4 down" descr="Down arrow in 3d box 4"/>
+          <p:cNvPr id="34" name="BUILD arrow 3d box4 down" descr="">
+            <a:extLst>
+              <a:ext uri="{C183D7F6-B498-43B3-948B-1728B52AA6E4}">
+                <adec:decorative xmlns:adec="http://schemas.microsoft.com/office/drawing/2017/decorative" val="1"/>
+              </a:ext>
+            </a:extLst>
+          </p:cNvPr>
           <p:cNvSpPr/>
           <p:nvPr/>
         </p:nvSpPr>
@@ -25578,7 +25846,13 @@
       </p:sp>
       <p:sp>
         <p:nvSpPr>
-          <p:cNvPr id="35" name="BUILD arrow 3d box5 down" descr="Down arrow in 3d box 5"/>
+          <p:cNvPr id="35" name="BUILD arrow 3d box5 down" descr="">
+            <a:extLst>
+              <a:ext uri="{C183D7F6-B498-43B3-948B-1728B52AA6E4}">
+                <adec:decorative xmlns:adec="http://schemas.microsoft.com/office/drawing/2017/decorative" val="1"/>
+              </a:ext>
+            </a:extLst>
+          </p:cNvPr>
           <p:cNvSpPr/>
           <p:nvPr/>
         </p:nvSpPr>
@@ -27968,7 +28242,13 @@
       </p:grpSp>
       <p:sp>
         <p:nvSpPr>
-          <p:cNvPr id="24" name="BUILD arrow 4s box1 up" descr="Up arrow in 4s box 1"/>
+          <p:cNvPr id="24" name="BUILD arrow 4s box1 up" descr="">
+            <a:extLst>
+              <a:ext uri="{C183D7F6-B498-43B3-948B-1728B52AA6E4}">
+                <adec:decorative xmlns:adec="http://schemas.microsoft.com/office/drawing/2017/decorative" val="1"/>
+              </a:ext>
+            </a:extLst>
+          </p:cNvPr>
           <p:cNvSpPr/>
           <p:nvPr/>
         </p:nvSpPr>
@@ -28015,7 +28295,13 @@
       </p:sp>
       <p:sp>
         <p:nvSpPr>
-          <p:cNvPr id="25" name="BUILD arrow 4s box1 down" descr="Down arrow in 4s box 1"/>
+          <p:cNvPr id="25" name="BUILD arrow 4s box1 down" descr="">
+            <a:extLst>
+              <a:ext uri="{C183D7F6-B498-43B3-948B-1728B52AA6E4}">
+                <adec:decorative xmlns:adec="http://schemas.microsoft.com/office/drawing/2017/decorative" val="1"/>
+              </a:ext>
+            </a:extLst>
+          </p:cNvPr>
           <p:cNvSpPr/>
           <p:nvPr/>
         </p:nvSpPr>
@@ -28062,7 +28348,13 @@
       </p:sp>
       <p:sp>
         <p:nvSpPr>
-          <p:cNvPr id="26" name="BUILD arrow 3d box1 up" descr="Up arrow in 3d box 1"/>
+          <p:cNvPr id="26" name="BUILD arrow 3d box1 up" descr="">
+            <a:extLst>
+              <a:ext uri="{C183D7F6-B498-43B3-948B-1728B52AA6E4}">
+                <adec:decorative xmlns:adec="http://schemas.microsoft.com/office/drawing/2017/decorative" val="1"/>
+              </a:ext>
+            </a:extLst>
+          </p:cNvPr>
           <p:cNvSpPr/>
           <p:nvPr/>
         </p:nvSpPr>
@@ -28109,7 +28401,13 @@
       </p:sp>
       <p:sp>
         <p:nvSpPr>
-          <p:cNvPr id="27" name="BUILD arrow 3d box2 up" descr="Up arrow in 3d box 2"/>
+          <p:cNvPr id="27" name="BUILD arrow 3d box2 up" descr="">
+            <a:extLst>
+              <a:ext uri="{C183D7F6-B498-43B3-948B-1728B52AA6E4}">
+                <adec:decorative xmlns:adec="http://schemas.microsoft.com/office/drawing/2017/decorative" val="1"/>
+              </a:ext>
+            </a:extLst>
+          </p:cNvPr>
           <p:cNvSpPr/>
           <p:nvPr/>
         </p:nvSpPr>
@@ -28156,7 +28454,13 @@
       </p:sp>
       <p:sp>
         <p:nvSpPr>
-          <p:cNvPr id="28" name="BUILD arrow 3d box3 up" descr="Up arrow in 3d box 3"/>
+          <p:cNvPr id="28" name="BUILD arrow 3d box3 up" descr="">
+            <a:extLst>
+              <a:ext uri="{C183D7F6-B498-43B3-948B-1728B52AA6E4}">
+                <adec:decorative xmlns:adec="http://schemas.microsoft.com/office/drawing/2017/decorative" val="1"/>
+              </a:ext>
+            </a:extLst>
+          </p:cNvPr>
           <p:cNvSpPr/>
           <p:nvPr/>
         </p:nvSpPr>
@@ -28203,7 +28507,13 @@
       </p:sp>
       <p:sp>
         <p:nvSpPr>
-          <p:cNvPr id="29" name="BUILD arrow 3d box4 up" descr="Up arrow in 3d box 4"/>
+          <p:cNvPr id="29" name="BUILD arrow 3d box4 up" descr="">
+            <a:extLst>
+              <a:ext uri="{C183D7F6-B498-43B3-948B-1728B52AA6E4}">
+                <adec:decorative xmlns:adec="http://schemas.microsoft.com/office/drawing/2017/decorative" val="1"/>
+              </a:ext>
+            </a:extLst>
+          </p:cNvPr>
           <p:cNvSpPr/>
           <p:nvPr/>
         </p:nvSpPr>
@@ -28250,7 +28560,13 @@
       </p:sp>
       <p:sp>
         <p:nvSpPr>
-          <p:cNvPr id="30" name="BUILD arrow 3d box5 up" descr="Up arrow in 3d box 5"/>
+          <p:cNvPr id="30" name="BUILD arrow 3d box5 up" descr="">
+            <a:extLst>
+              <a:ext uri="{C183D7F6-B498-43B3-948B-1728B52AA6E4}">
+                <adec:decorative xmlns:adec="http://schemas.microsoft.com/office/drawing/2017/decorative" val="1"/>
+              </a:ext>
+            </a:extLst>
+          </p:cNvPr>
           <p:cNvSpPr/>
           <p:nvPr/>
         </p:nvSpPr>
@@ -36700,7 +37016,13 @@
       </p:grpSp>
       <p:sp>
         <p:nvSpPr>
-          <p:cNvPr id="24" name="BUILD arrow 1s box1 up" descr="Up arrow in 1s box 1"/>
+          <p:cNvPr id="24" name="BUILD arrow 1s box1 up" descr="">
+            <a:extLst>
+              <a:ext uri="{C183D7F6-B498-43B3-948B-1728B52AA6E4}">
+                <adec:decorative xmlns:adec="http://schemas.microsoft.com/office/drawing/2017/decorative" val="1"/>
+              </a:ext>
+            </a:extLst>
+          </p:cNvPr>
           <p:cNvSpPr/>
           <p:nvPr/>
         </p:nvSpPr>
@@ -36747,7 +37069,13 @@
       </p:sp>
       <p:sp>
         <p:nvSpPr>
-          <p:cNvPr id="25" name="BUILD arrow 1s box1 down" descr="Down arrow in 1s box 1"/>
+          <p:cNvPr id="25" name="BUILD arrow 1s box1 down" descr="">
+            <a:extLst>
+              <a:ext uri="{C183D7F6-B498-43B3-948B-1728B52AA6E4}">
+                <adec:decorative xmlns:adec="http://schemas.microsoft.com/office/drawing/2017/decorative" val="1"/>
+              </a:ext>
+            </a:extLst>
+          </p:cNvPr>
           <p:cNvSpPr/>
           <p:nvPr/>
         </p:nvSpPr>
@@ -36794,7 +37122,13 @@
       </p:sp>
       <p:sp>
         <p:nvSpPr>
-          <p:cNvPr id="26" name="BUILD arrow 2s box1 up" descr="Up arrow in 2s box 1"/>
+          <p:cNvPr id="26" name="BUILD arrow 2s box1 up" descr="">
+            <a:extLst>
+              <a:ext uri="{C183D7F6-B498-43B3-948B-1728B52AA6E4}">
+                <adec:decorative xmlns:adec="http://schemas.microsoft.com/office/drawing/2017/decorative" val="1"/>
+              </a:ext>
+            </a:extLst>
+          </p:cNvPr>
           <p:cNvSpPr/>
           <p:nvPr/>
         </p:nvSpPr>
@@ -36841,7 +37175,13 @@
       </p:sp>
       <p:sp>
         <p:nvSpPr>
-          <p:cNvPr id="27" name="BUILD arrow 2s box1 down" descr="Down arrow in 2s box 1"/>
+          <p:cNvPr id="27" name="BUILD arrow 2s box1 down" descr="">
+            <a:extLst>
+              <a:ext uri="{C183D7F6-B498-43B3-948B-1728B52AA6E4}">
+                <adec:decorative xmlns:adec="http://schemas.microsoft.com/office/drawing/2017/decorative" val="1"/>
+              </a:ext>
+            </a:extLst>
+          </p:cNvPr>
           <p:cNvSpPr/>
           <p:nvPr/>
         </p:nvSpPr>
@@ -36888,7 +37228,13 @@
       </p:sp>
       <p:sp>
         <p:nvSpPr>
-          <p:cNvPr id="28" name="BUILD arrow 2p box1 up" descr="Up arrow in 2p box 1"/>
+          <p:cNvPr id="28" name="BUILD arrow 2p box1 up" descr="">
+            <a:extLst>
+              <a:ext uri="{C183D7F6-B498-43B3-948B-1728B52AA6E4}">
+                <adec:decorative xmlns:adec="http://schemas.microsoft.com/office/drawing/2017/decorative" val="1"/>
+              </a:ext>
+            </a:extLst>
+          </p:cNvPr>
           <p:cNvSpPr/>
           <p:nvPr/>
         </p:nvSpPr>
@@ -36935,7 +37281,13 @@
       </p:sp>
       <p:sp>
         <p:nvSpPr>
-          <p:cNvPr id="29" name="BUILD arrow 2p box2 up" descr="Up arrow in 2p box 2"/>
+          <p:cNvPr id="29" name="BUILD arrow 2p box2 up" descr="">
+            <a:extLst>
+              <a:ext uri="{C183D7F6-B498-43B3-948B-1728B52AA6E4}">
+                <adec:decorative xmlns:adec="http://schemas.microsoft.com/office/drawing/2017/decorative" val="1"/>
+              </a:ext>
+            </a:extLst>
+          </p:cNvPr>
           <p:cNvSpPr/>
           <p:nvPr/>
         </p:nvSpPr>
@@ -36982,7 +37334,13 @@
       </p:sp>
       <p:sp>
         <p:nvSpPr>
-          <p:cNvPr id="30" name="BUILD arrow 2p box3 up" descr="Up arrow in 2p box 3"/>
+          <p:cNvPr id="30" name="BUILD arrow 2p box3 up" descr="">
+            <a:extLst>
+              <a:ext uri="{C183D7F6-B498-43B3-948B-1728B52AA6E4}">
+                <adec:decorative xmlns:adec="http://schemas.microsoft.com/office/drawing/2017/decorative" val="1"/>
+              </a:ext>
+            </a:extLst>
+          </p:cNvPr>
           <p:cNvSpPr/>
           <p:nvPr/>
         </p:nvSpPr>
@@ -38688,7 +39046,13 @@
       </p:grpSp>
       <p:sp>
         <p:nvSpPr>
-          <p:cNvPr id="20" name="BUILD arrow 2p box1 up" descr="Up arrow in 2p box 1"/>
+          <p:cNvPr id="20" name="BUILD arrow 2p box1 up" descr="">
+            <a:extLst>
+              <a:ext uri="{C183D7F6-B498-43B3-948B-1728B52AA6E4}">
+                <adec:decorative xmlns:adec="http://schemas.microsoft.com/office/drawing/2017/decorative" val="1"/>
+              </a:ext>
+            </a:extLst>
+          </p:cNvPr>
           <p:cNvSpPr/>
           <p:nvPr/>
         </p:nvSpPr>
@@ -38735,7 +39099,13 @@
       </p:sp>
       <p:sp>
         <p:nvSpPr>
-          <p:cNvPr id="21" name="BUILD arrow 2p box2 up" descr="Up arrow in 2p box 2"/>
+          <p:cNvPr id="21" name="BUILD arrow 2p box2 up" descr="">
+            <a:extLst>
+              <a:ext uri="{C183D7F6-B498-43B3-948B-1728B52AA6E4}">
+                <adec:decorative xmlns:adec="http://schemas.microsoft.com/office/drawing/2017/decorative" val="1"/>
+              </a:ext>
+            </a:extLst>
+          </p:cNvPr>
           <p:cNvSpPr/>
           <p:nvPr/>
         </p:nvSpPr>
@@ -38782,7 +39152,13 @@
       </p:sp>
       <p:sp>
         <p:nvSpPr>
-          <p:cNvPr id="22" name="BUILD arrow 2p box3 up" descr="Up arrow in 2p box 3"/>
+          <p:cNvPr id="22" name="BUILD arrow 2p box3 up" descr="">
+            <a:extLst>
+              <a:ext uri="{C183D7F6-B498-43B3-948B-1728B52AA6E4}">
+                <adec:decorative xmlns:adec="http://schemas.microsoft.com/office/drawing/2017/decorative" val="1"/>
+              </a:ext>
+            </a:extLst>
+          </p:cNvPr>
           <p:cNvSpPr/>
           <p:nvPr/>
         </p:nvSpPr>
@@ -38829,7 +39205,13 @@
       </p:sp>
       <p:sp>
         <p:nvSpPr>
-          <p:cNvPr id="23" name="BUILD arrow 2p box1 down" descr="Down arrow in 2p box 1"/>
+          <p:cNvPr id="23" name="BUILD arrow 2p box1 down" descr="">
+            <a:extLst>
+              <a:ext uri="{C183D7F6-B498-43B3-948B-1728B52AA6E4}">
+                <adec:decorative xmlns:adec="http://schemas.microsoft.com/office/drawing/2017/decorative" val="1"/>
+              </a:ext>
+            </a:extLst>
+          </p:cNvPr>
           <p:cNvSpPr/>
           <p:nvPr/>
         </p:nvSpPr>

</xml_diff>

<commit_message>
Chemistry U2 S2.3 final fixes: full configuration before shorthand, compare wording, notes; rebuild animated and static decks
Co-Authored-By: Claude Sonnet 5.5 <noreply@anthropic.com>
Claude-Session: https://claude.ai/code/session_01CAqidLLu6PiYNMcZx5qMsE
</commit_message>
<xml_diff>
--- a/deliverables/chem-u02/SHULL_CHEM_Slides_U02_S02.3.pptx
+++ b/deliverables/chem-u02/SHULL_CHEM_Slides_U02_S02.3.pptx
@@ -799,7 +799,7 @@
           <a:p>
             <a:r>
               <a:rPr lang="en-US" dirty="0"/>
-              <a:t>Second orbital-diagram example, after oxygen. Students copy the setup, then work it; answer on the next slide. Fe, Z = 26. Fill 4s before 3d, and we write 4s ahead of 3d (filling-order notation, PROVISIONAL convention). Only the 4s and 3d boxes are drawn; the first 18 electrons (through 3p) are just counted. The [Ar] label on the next slide previews noble-gas shorthand, which has not been taught yet at this point: say 'the first 18 electrons, the same as argon' and let the shorthand slides name it. Image prompt (aside slot): a rusted iron nail on a white bench.</a:t>
+              <a:t>Second orbital-diagram example, after oxygen. Students copy the setup, then work it; answer on the next slide. Fe, Z = 26. Fill 4s before 3d, and we write 4s ahead of 3d (filling-order notation, PROVISIONAL convention). Only the 4s and 3d boxes are drawn; the first 18 electrons (through 3p) are just counted. The next slide counts them as 'the first 18 electrons'; the noble-gas shorthand has not been taught yet at this point, so do not name it and let the shorthand slides do that. Image prompt (aside slot): a rusted iron nail on a white bench.</a:t>
             </a:r>
             <a:endParaRPr lang="en-US" dirty="0"/>
           </a:p>
@@ -886,7 +886,7 @@
           <a:lstStyle/>
           <a:p>
             <a:r>
-              <a:t>Fe: 1s^2 2s^2 2p^6 3s^2 3p^6 4s^2 3d^6, written with the first 18 as [Ar] 4s^2 3d^6, 18 + 2 + 6 = 26. The 3d boxes hold one pair and four singles, so 4 unpaired. The 4s pair is drawn first, then the 3d boxes (Hund: one up arrow in each box, then pair). [Ar] here is a preview of the noble-gas shorthand taught two slides later; treat it as 'the first 18'.</a:t>
+              <a:t>Fe: 1s^2 2s^2 2p^6 3s^2 3p^6 4s^2 3d^6, 2+2+6+2+6+2+6 = 26. The diagram draws only 4s and 3d; the first 18 electrons (through 3p) are counted, not drawn, so its sum reads first 18 + 2 + 6 = 26. The 3d boxes hold one pair and four singles, so 4 unpaired. The 4s pair is drawn first, then the 3d boxes (Hund: one up arrow in each box, then pair). No [Ar] appears on this slide: the noble-gas shorthand is taught two slides later (slide 15), so say 'the first 18 electrons' here.</a:t>
             </a:r>
           </a:p>
           <a:p>
@@ -1066,7 +1066,7 @@
           <a:p>
             <a:r>
               <a:rPr lang="en-US" dirty="0"/>
-              <a:t>COMMON ERROR (brief): using the noble gas of the same period, or the element's own. Cl is period 3, so the core is [Ne], not [Ar]; the core is the previous period's noble gas. Shorthand: [Ne] 3s^2 3p^5, which equals the longhand 1s^2 2s^2 2p^6 3s^2 3p^5. Next slide: the same idea for germanium, built one click at a time (the longhand first, then the noble gas before it in brackets). Image prompt (concept slot): a neon sign tube glowing orange-red in a dark window.</a:t>
+              <a:t>COMMON ERROR (brief): using the noble gas of the same period, or the element's own. Cl is period 3, so the core is [Ne], not [Ar]; the core is the previous period's noble gas. Shorthand: [Ne] 3s^2 3p^5, which equals the longhand 1s^2 2s^2 2p^6 3s^2 3p^5. Next slide: the same idea for germanium (the longhand first, then the noble gas before it in brackets); in the animated deck that slide is built one click at a time, in the static deck it shows the finished line. Image prompt (concept slot): a neon sign tube glowing orange-red in a dark window.</a:t>
             </a:r>
             <a:endParaRPr lang="en-US" dirty="0"/>
           </a:p>
@@ -2131,7 +2131,7 @@
           <a:p>
             <a:r>
               <a:rPr lang="en-US" dirty="0"/>
-              <a:t>Answers on the next slide. Each was written as a ground state. (a) O: 1s^2 2s^2 2p^6 is 10 electrons, O has 8. (b) K: [Ar] 3d^1 puts 3d before 4s. (c) Ca: [Ne] 4s^2 is 12 electrons, wrong core. (d) Cr: [Ar] 4s^2 3d^4 obeys the rules but is not the real ground state. Replay the Chromium click build if students are unsure. Image prompt (aside slot): a page of student work with a few lines circled in red pen.</a:t>
+              <a:t>Answers on the next slide. Each was written as a ground state. (a) O: 1s^2 2s^2 2p^6 is 10 electrons, O has 8. (b) K: [Ar] 3d^1 puts 3d before 4s. (c) Ca: [Ne] 4s^2 is 12 electrons, wrong core. (d) Cr: [Ar] 4s^2 3d^4 obeys the rules but is not the real ground state. Revisit the Chromium exception slide if students are unsure. Image prompt (aside slot): a page of student work with a few lines circled in red pen.</a:t>
             </a:r>
             <a:endParaRPr lang="en-US" dirty="0"/>
           </a:p>
@@ -2219,7 +2219,7 @@
           <a:p>
             <a:r>
               <a:rPr lang="en-US" dirty="0"/>
-              <a:t>Corrected: (a) O 1s^2 2s^2 2p^4. (b) K [Ar] 4s^1. (c) Ca [Ar] 4s^2. (d) Cr [Ar] 4s^1 3d^5. (d) is the Chromium click build: predicted [Ar] 4s^2 3d^4, actual [Ar] 4s^1 3d^5. Teach 'rules-consistent' versus 'observed': (d) passes every rule on paper and is still not the real atom. Image prompt (data slot): a pencil resting on a page of crossed-out electron counts.</a:t>
+              <a:t>Corrected: (a) O 1s^2 2s^2 2p^4. (b) K [Ar] 4s^1. (c) Ca [Ar] 4s^2. (d) Cr [Ar] 4s^1 3d^5. (d) is the Chromium exception slide: predicted [Ar] 4s^2 3d^4, actual [Ar] 4s^1 3d^5. Teach 'rules-consistent' versus 'observed': (d) passes every rule on paper and is still not the real atom. Image prompt (data slot): a pencil resting on a page of crossed-out electron counts.</a:t>
             </a:r>
             <a:endParaRPr lang="en-US" dirty="0"/>
           </a:p>
@@ -2571,7 +2571,7 @@
           <a:p>
             <a:r>
               <a:rPr lang="en-US" dirty="0"/>
-              <a:t>Answers (re-derived). P, Z = 15: 1s^2 2s^2 2p^6 3s^2 3p^3, 2+2+6+2+3 = 15, 3 unpaired. S, Z = 16: [Ne] 3s^2 3p^4, 10+2+4 = 16; 3p boxes: one pair and two singles, 2 unpaired. Cu, Z = 29: [Ar] 4s^1 3d^10, 18+1+10 = 29. Exception: replay the Copper click build (slide 'Exception: Copper'): the rules predict [Ar] 4s^2 3d^9, one 4s electron moves into 3d, and the filled 3d lowers the atom's total energy slightly. That is the simplified reason from the Why slide (4s and 3d are close in energy); it does not predict every exception, so do not accept 'full is always more stable'. Image prompt (aside slot): a pencil and a blank sheet of lined paper on a lab bench.</a:t>
+              <a:t>Answers (re-derived). P, Z = 15: 1s^2 2s^2 2p^6 3s^2 3p^3, 2+2+6+2+3 = 15, 3 unpaired. S, Z = 16: [Ne] 3s^2 3p^4, 10+2+4 = 16; 3p boxes: one pair and two singles, 2 unpaired. Cu, Z = 29: [Ar] 4s^1 3d^10, 18+1+10 = 29. Exception: go back to the Copper exception slide ('Exception: Copper', a click build in the animated deck): the rules predict [Ar] 4s^2 3d^9, one 4s electron moves into 3d, and the filled 3d lowers the atom's total energy slightly. That is the simplified reason from the Why slide (4s and 3d are close in energy); it does not predict every exception, so do not accept 'full is always more stable'. Image prompt (aside slot): a pencil and a blank sheet of lined paper on a lab bench.</a:t>
             </a:r>
             <a:endParaRPr lang="en-US" dirty="0"/>
           </a:p>
@@ -14384,7 +14384,7 @@
                 <a:ea typeface="Trade Gothic Next" pitchFamily="34" charset="-122"/>
                 <a:cs typeface="Trade Gothic Next" pitchFamily="34" charset="-120"/>
               </a:rPr>
-              <a:t>Write the longhand configuration and the orbital diagram for oxygen.</a:t>
+              <a:t>Write the full configuration and the orbital diagram for oxygen.</a:t>
             </a:r>
             <a:endParaRPr lang="en-US" sz="1600" dirty="0"/>
           </a:p>
@@ -14565,7 +14565,7 @@
                 <a:ea typeface="Trade Gothic Next" pitchFamily="34" charset="-122"/>
                 <a:cs typeface="Trade Gothic Next" pitchFamily="34" charset="-120"/>
               </a:rPr>
-              <a:t>Longhand configuration</a:t>
+              <a:t>Full configuration</a:t>
             </a:r>
             <a:endParaRPr lang="en-US" sz="1600" dirty="0"/>
           </a:p>
@@ -17533,7 +17533,7 @@
                 <a:ea typeface="Trade Gothic Next" pitchFamily="34" charset="-122"/>
                 <a:cs typeface="Trade Gothic Next" pitchFamily="34" charset="-120"/>
               </a:rPr>
-              <a:t>Longhand configuration</a:t>
+              <a:t>Full configuration</a:t>
             </a:r>
             <a:endParaRPr lang="en-US" sz="1600" dirty="0"/>
           </a:p>
@@ -17898,7 +17898,7 @@
                 <a:ea typeface="Trade Gothic Next" pitchFamily="34" charset="-122"/>
                 <a:cs typeface="Trade Gothic Next" pitchFamily="34" charset="-120"/>
               </a:rPr>
-              <a:t>LONGHAND</a:t>
+              <a:t>FULL CONFIGURATION</a:t>
             </a:r>
             <a:endParaRPr lang="en-US" sz="1200" dirty="0"/>
           </a:p>
@@ -18165,7 +18165,7 @@
                 <a:ea typeface="Trade Gothic Next" pitchFamily="34" charset="-122"/>
                 <a:cs typeface="Trade Gothic Next" pitchFamily="34" charset="-120"/>
               </a:rPr>
-              <a:t>[Ar] 4s</a:t>
+              <a:t>1s</a:t>
             </a:r>
             <a:pPr indent="0" marL="0">
               <a:buNone/>
@@ -18193,6 +18193,149 @@
                 <a:ea typeface="Trade Gothic Next" pitchFamily="34" charset="-122"/>
                 <a:cs typeface="Trade Gothic Next" pitchFamily="34" charset="-120"/>
               </a:rPr>
+              <a:t> 2s</a:t>
+            </a:r>
+            <a:pPr indent="0" marL="0">
+              <a:buNone/>
+            </a:pPr>
+            <a:r>
+              <a:rPr lang="en-US" sz="1900" baseline="30000" dirty="0">
+                <a:solidFill>
+                  <a:srgbClr val="14161B"/>
+                </a:solidFill>
+                <a:latin typeface="Trade Gothic Next" pitchFamily="34" charset="0"/>
+                <a:ea typeface="Trade Gothic Next" pitchFamily="34" charset="-122"/>
+                <a:cs typeface="Trade Gothic Next" pitchFamily="34" charset="-120"/>
+              </a:rPr>
+              <a:t>2</a:t>
+            </a:r>
+            <a:pPr indent="0" marL="0">
+              <a:buNone/>
+            </a:pPr>
+            <a:r>
+              <a:rPr lang="en-US" sz="1900" dirty="0">
+                <a:solidFill>
+                  <a:srgbClr val="14161B"/>
+                </a:solidFill>
+                <a:latin typeface="Trade Gothic Next" pitchFamily="34" charset="0"/>
+                <a:ea typeface="Trade Gothic Next" pitchFamily="34" charset="-122"/>
+                <a:cs typeface="Trade Gothic Next" pitchFamily="34" charset="-120"/>
+              </a:rPr>
+              <a:t> 2p</a:t>
+            </a:r>
+            <a:pPr indent="0" marL="0">
+              <a:buNone/>
+            </a:pPr>
+            <a:r>
+              <a:rPr lang="en-US" sz="1900" baseline="30000" dirty="0">
+                <a:solidFill>
+                  <a:srgbClr val="14161B"/>
+                </a:solidFill>
+                <a:latin typeface="Trade Gothic Next" pitchFamily="34" charset="0"/>
+                <a:ea typeface="Trade Gothic Next" pitchFamily="34" charset="-122"/>
+                <a:cs typeface="Trade Gothic Next" pitchFamily="34" charset="-120"/>
+              </a:rPr>
+              <a:t>6</a:t>
+            </a:r>
+            <a:pPr indent="0" marL="0">
+              <a:buNone/>
+            </a:pPr>
+            <a:r>
+              <a:rPr lang="en-US" sz="1900" dirty="0">
+                <a:solidFill>
+                  <a:srgbClr val="14161B"/>
+                </a:solidFill>
+                <a:latin typeface="Trade Gothic Next" pitchFamily="34" charset="0"/>
+                <a:ea typeface="Trade Gothic Next" pitchFamily="34" charset="-122"/>
+                <a:cs typeface="Trade Gothic Next" pitchFamily="34" charset="-120"/>
+              </a:rPr>
+              <a:t> 3s</a:t>
+            </a:r>
+            <a:pPr indent="0" marL="0">
+              <a:buNone/>
+            </a:pPr>
+            <a:r>
+              <a:rPr lang="en-US" sz="1900" baseline="30000" dirty="0">
+                <a:solidFill>
+                  <a:srgbClr val="14161B"/>
+                </a:solidFill>
+                <a:latin typeface="Trade Gothic Next" pitchFamily="34" charset="0"/>
+                <a:ea typeface="Trade Gothic Next" pitchFamily="34" charset="-122"/>
+                <a:cs typeface="Trade Gothic Next" pitchFamily="34" charset="-120"/>
+              </a:rPr>
+              <a:t>2</a:t>
+            </a:r>
+            <a:pPr indent="0" marL="0">
+              <a:buNone/>
+            </a:pPr>
+            <a:r>
+              <a:rPr lang="en-US" sz="1900" dirty="0">
+                <a:solidFill>
+                  <a:srgbClr val="14161B"/>
+                </a:solidFill>
+                <a:latin typeface="Trade Gothic Next" pitchFamily="34" charset="0"/>
+                <a:ea typeface="Trade Gothic Next" pitchFamily="34" charset="-122"/>
+                <a:cs typeface="Trade Gothic Next" pitchFamily="34" charset="-120"/>
+              </a:rPr>
+              <a:t> 3p</a:t>
+            </a:r>
+            <a:pPr indent="0" marL="0">
+              <a:buNone/>
+            </a:pPr>
+            <a:r>
+              <a:rPr lang="en-US" sz="1900" baseline="30000" dirty="0">
+                <a:solidFill>
+                  <a:srgbClr val="14161B"/>
+                </a:solidFill>
+                <a:latin typeface="Trade Gothic Next" pitchFamily="34" charset="0"/>
+                <a:ea typeface="Trade Gothic Next" pitchFamily="34" charset="-122"/>
+                <a:cs typeface="Trade Gothic Next" pitchFamily="34" charset="-120"/>
+              </a:rPr>
+              <a:t>6</a:t>
+            </a:r>
+            <a:endParaRPr lang="en-US" sz="1900" dirty="0"/>
+          </a:p>
+          <a:p>
+            <a:pPr indent="0" marL="0">
+              <a:buNone/>
+            </a:pPr>
+            <a:r>
+              <a:rPr lang="en-US" sz="1900" dirty="0">
+                <a:solidFill>
+                  <a:srgbClr val="14161B"/>
+                </a:solidFill>
+                <a:latin typeface="Trade Gothic Next" pitchFamily="34" charset="0"/>
+                <a:ea typeface="Trade Gothic Next" pitchFamily="34" charset="-122"/>
+                <a:cs typeface="Trade Gothic Next" pitchFamily="34" charset="-120"/>
+              </a:rPr>
+              <a:t>4s</a:t>
+            </a:r>
+            <a:pPr indent="0" marL="0">
+              <a:buNone/>
+            </a:pPr>
+            <a:r>
+              <a:rPr lang="en-US" sz="1900" baseline="30000" dirty="0">
+                <a:solidFill>
+                  <a:srgbClr val="14161B"/>
+                </a:solidFill>
+                <a:latin typeface="Trade Gothic Next" pitchFamily="34" charset="0"/>
+                <a:ea typeface="Trade Gothic Next" pitchFamily="34" charset="-122"/>
+                <a:cs typeface="Trade Gothic Next" pitchFamily="34" charset="-120"/>
+              </a:rPr>
+              <a:t>2</a:t>
+            </a:r>
+            <a:pPr indent="0" marL="0">
+              <a:buNone/>
+            </a:pPr>
+            <a:r>
+              <a:rPr lang="en-US" sz="1900" dirty="0">
+                <a:solidFill>
+                  <a:srgbClr val="14161B"/>
+                </a:solidFill>
+                <a:latin typeface="Trade Gothic Next" pitchFamily="34" charset="0"/>
+                <a:ea typeface="Trade Gothic Next" pitchFamily="34" charset="-122"/>
+                <a:cs typeface="Trade Gothic Next" pitchFamily="34" charset="-120"/>
+              </a:rPr>
               <a:t> 3d</a:t>
             </a:r>
             <a:pPr indent="0" marL="0">
@@ -18224,7 +18367,7 @@
                 <a:ea typeface="Trade Gothic Next" pitchFamily="34" charset="-122"/>
                 <a:cs typeface="Trade Gothic Next" pitchFamily="34" charset="-120"/>
               </a:rPr>
-              <a:t>18 + 2 + 6 = 26</a:t>
+              <a:t>2+2+6+2+6+2+6 = 26</a:t>
             </a:r>
             <a:endParaRPr lang="en-US" sz="1900" dirty="0"/>
           </a:p>
@@ -19490,7 +19633,7 @@
                 </a:solidFill>
                 <a:latin typeface="Trade Gothic Next"/>
               </a:rPr>
-              <a:t>[Ar] 18 + 2 + 6 = 26</a:t>
+              <a:t>first 18 + 2 + 6 = 26</a:t>
             </a:r>
           </a:p>
         </p:txBody>
@@ -27397,7 +27540,7 @@
                 <a:ea typeface="Trade Gothic Next" pitchFamily="34" charset="-122"/>
                 <a:cs typeface="Trade Gothic Next" pitchFamily="34" charset="-120"/>
               </a:rPr>
-              <a:t>. Watch what the real atom does.</a:t>
+              <a:t>. Compare it with the real atom.</a:t>
             </a:r>
             <a:endParaRPr lang="en-US" sz="1700" dirty="0"/>
           </a:p>
@@ -27438,7 +27581,7 @@
                 <a:ea typeface="Trade Gothic Next" pitchFamily="34" charset="-122"/>
                 <a:cs typeface="Trade Gothic Next" pitchFamily="34" charset="-120"/>
               </a:rPr>
-              <a:t>WATCH</a:t>
+              <a:t>COMPARE</a:t>
             </a:r>
             <a:endParaRPr lang="en-US" sz="1200" dirty="0"/>
           </a:p>
@@ -27479,7 +27622,7 @@
                 <a:ea typeface="Trade Gothic Next" pitchFamily="34" charset="-122"/>
                 <a:cs typeface="Trade Gothic Next" pitchFamily="34" charset="-120"/>
               </a:rPr>
-              <a:t>Which sublevel loses an electron, and which gains one?</a:t>
+              <a:t>Predicted versus actual: which sublevel loses an electron, and which gains one?</a:t>
             </a:r>
             <a:endParaRPr lang="en-US" sz="1600" dirty="0"/>
           </a:p>
@@ -30529,7 +30672,7 @@
                 <a:ea typeface="Trade Gothic Next" pitchFamily="34" charset="-122"/>
                 <a:cs typeface="Trade Gothic Next" pitchFamily="34" charset="-120"/>
               </a:rPr>
-              <a:t>WATCH</a:t>
+              <a:t>COMPARE</a:t>
             </a:r>
             <a:endParaRPr lang="en-US" sz="1200" dirty="0"/>
           </a:p>
@@ -30570,7 +30713,7 @@
                 <a:ea typeface="Trade Gothic Next" pitchFamily="34" charset="-122"/>
                 <a:cs typeface="Trade Gothic Next" pitchFamily="34" charset="-120"/>
               </a:rPr>
-              <a:t>Count the arrows in 3d before and after.</a:t>
+              <a:t>Count the arrows in 3d, predicted versus actual.</a:t>
             </a:r>
             <a:endParaRPr lang="en-US" sz="1600" dirty="0"/>
           </a:p>

</xml_diff>